<commit_message>
Switch deck fonts to Poppins (EN) and Prompt (TH); bundle font files
Co-Authored-By: Claude Fable 5.1 <noreply@anthropic.com>
Claude-Session: https://claude.ai/code/session_01MJB3WpVo3kuH25GjttwApw
</commit_message>
<xml_diff>
--- a/presentation/AI_Work_Performance_ENG501.pptx
+++ b/presentation/AI_Work_Performance_ENG501.pptx
@@ -116,7 +116,7 @@
   <p:extLst>
     <p:ext uri="{521415D9-36F7-43E2-AB2F-B90AF26B5E84}">
       <p14:sectionLst xmlns:p14="http://schemas.microsoft.com/office/powerpoint/2010/main">
-        <p14:section name="English (Slides 1-5)" id="{3e9537ed-fada-b735-946b-e2a3a12bbb5a}">
+        <p14:section name="English (Slides 1-5)" id="{6181e29a-e672-cf70-2f7a-b3ec54fbc939}">
           <p14:sldIdLst>
             <p14:sldId id="256"/>
             <p14:sldId id="257"/>
@@ -125,7 +125,7 @@
             <p14:sldId id="260"/>
           </p14:sldIdLst>
         </p14:section>
-        <p14:section name="ภาษาไทย (Slides 6-10)" id="{e5c3b8c7-e207-c39b-994a-4120ca6ba37f}">
+        <p14:section name="ภาษาไทย (Slides 6-10)" id="{56039b48-a59d-e2dd-a6f5-0217f1e3d054}">
           <p14:sldIdLst>
             <p14:sldId id="261"/>
             <p14:sldId id="262"/>
@@ -297,13 +297,13 @@
                     <c:v>Task speed</c:v>
                   </c:pt>
                   <c:pt idx="2">
-                    <c:v>Quality vs. control</c:v>
+                    <c:v>Quality</c:v>
                   </c:pt>
                   <c:pt idx="3">
-                    <c:v>Below-average performers</c:v>
+                    <c:v>Below-average</c:v>
                   </c:pt>
                   <c:pt idx="4">
-                    <c:v>Above-average performers</c:v>
+                    <c:v>Above-average</c:v>
                   </c:pt>
                 </c:lvl>
               </c:multiLvlStrCache>
@@ -358,7 +358,7 @@
           <c:showBubbleSize val="0"/>
           <c:showLeaderLines val="0"/>
         </c:dLbls>
-        <c:gapWidth val="45"/>
+        <c:gapWidth val="40"/>
         <c:overlap val="0"/>
         <c:axId val="2094734554"/>
         <c:axId val="2094734552"/>
@@ -389,7 +389,7 @@
           <a:lstStyle/>
           <a:p>
             <a:pPr>
-              <a:defRPr sz="850" b="0" i="0" u="none" strike="noStrike">
+              <a:defRPr sz="800" b="0" i="0" u="none" strike="noStrike">
                 <a:solidFill>
                   <a:srgbClr val="5A6472"/>
                 </a:solidFill>
@@ -685,7 +685,7 @@
           <c:showBubbleSize val="0"/>
           <c:showLeaderLines val="0"/>
         </c:dLbls>
-        <c:gapWidth val="45"/>
+        <c:gapWidth val="40"/>
         <c:overlap val="0"/>
         <c:axId val="2094734554"/>
         <c:axId val="2094734552"/>
@@ -716,7 +716,7 @@
           <a:lstStyle/>
           <a:p>
             <a:pPr>
-              <a:defRPr sz="850" b="0" i="0" u="none" strike="noStrike">
+              <a:defRPr sz="800" b="0" i="0" u="none" strike="noStrike">
                 <a:solidFill>
                   <a:srgbClr val="5A6472"/>
                 </a:solidFill>
@@ -2058,7 +2058,7 @@
 
 <file path=ppt/slideLayouts/slideLayout2.xml><?xml version="1.0" encoding="utf-8"?>
 <p:sldLayout xmlns:a="http://schemas.openxmlformats.org/drawingml/2006/main" xmlns:r="http://schemas.openxmlformats.org/officeDocument/2006/relationships" xmlns:p="http://schemas.openxmlformats.org/presentationml/2006/main" preserve="1">
-  <p:cSld name="TITLE_DARK">
+  <p:cSld name="TITLE_DARK_EN">
     <p:bg>
       <p:bgPr>
         <a:blipFill dpi="0" rotWithShape="1">
@@ -2115,6 +2115,9 @@
                 <a:solidFill>
                   <a:schemeClr val="bg1"/>
                 </a:solidFill>
+                <a:latin typeface="Poppins" pitchFamily="34" charset="0"/>
+                <a:ea typeface="Poppins" pitchFamily="34" charset="-122"/>
+                <a:cs typeface="Poppins" pitchFamily="34" charset="-120"/>
               </a:defRPr>
             </a:lvl1pPr>
           </a:lstStyle>
@@ -2154,6 +2157,9 @@
                 <a:solidFill>
                   <a:schemeClr val="accent4"/>
                 </a:solidFill>
+                <a:latin typeface="Poppins" pitchFamily="34" charset="0"/>
+                <a:ea typeface="Poppins" pitchFamily="34" charset="-122"/>
+                <a:cs typeface="Poppins" pitchFamily="34" charset="-120"/>
               </a:defRPr>
             </a:lvl1pPr>
           </a:lstStyle>
@@ -2197,6 +2203,9 @@
                 <a:solidFill>
                   <a:srgbClr val="9AA5B4"/>
                 </a:solidFill>
+                <a:latin typeface="Poppins"/>
+                <a:ea typeface="Poppins"/>
+                <a:cs typeface="Poppins"/>
               </a:defRPr>
             </a:lvl1pPr>
           </a:lstStyle>
@@ -2277,6 +2286,9 @@
                 <a:solidFill>
                   <a:schemeClr val="accent1"/>
                 </a:solidFill>
+                <a:latin typeface="Poppins" pitchFamily="34" charset="0"/>
+                <a:ea typeface="Poppins" pitchFamily="34" charset="-122"/>
+                <a:cs typeface="Poppins" pitchFamily="34" charset="-120"/>
               </a:defRPr>
             </a:lvl1pPr>
           </a:lstStyle>
@@ -2316,6 +2328,9 @@
                 <a:solidFill>
                   <a:schemeClr val="tx1"/>
                 </a:solidFill>
+                <a:latin typeface="Poppins" pitchFamily="34" charset="0"/>
+                <a:ea typeface="Poppins" pitchFamily="34" charset="-122"/>
+                <a:cs typeface="Poppins" pitchFamily="34" charset="-120"/>
               </a:defRPr>
             </a:lvl1pPr>
           </a:lstStyle>
@@ -2356,6 +2371,9 @@
                 <a:solidFill>
                   <a:srgbClr val="9AA5B4"/>
                 </a:solidFill>
+                <a:latin typeface="Poppins" pitchFamily="34" charset="0"/>
+                <a:ea typeface="Poppins" pitchFamily="34" charset="-122"/>
+                <a:cs typeface="Poppins" pitchFamily="34" charset="-120"/>
               </a:rPr>
               <a:t>Chayanun Sungsa-ard  |  691401708  |  MBA  |  ENG 501</a:t>
             </a:r>
@@ -2395,6 +2413,9 @@
                 <a:solidFill>
                   <a:srgbClr val="9AA5B4"/>
                 </a:solidFill>
+                <a:latin typeface="Poppins"/>
+                <a:ea typeface="Poppins"/>
+                <a:cs typeface="Poppins"/>
               </a:defRPr>
             </a:lvl1pPr>
           </a:lstStyle>
@@ -2417,6 +2438,177 @@
 </file>
 
 <file path=ppt/slideLayouts/slideLayout4.xml><?xml version="1.0" encoding="utf-8"?>
+<p:sldLayout xmlns:a="http://schemas.openxmlformats.org/drawingml/2006/main" xmlns:r="http://schemas.openxmlformats.org/officeDocument/2006/relationships" xmlns:p="http://schemas.openxmlformats.org/presentationml/2006/main" preserve="1">
+  <p:cSld name="TITLE_DARK_TH">
+    <p:bg>
+      <p:bgPr>
+        <a:blipFill dpi="0" rotWithShape="1">
+          <a:blip r:embed="rId1">
+            <a:lum/>
+          </a:blip>
+          <a:srcRect/>
+          <a:stretch>
+            <a:fillRect/>
+          </a:stretch>
+        </a:blipFill>
+        <a:effectLst/>
+      </p:bgPr>
+    </p:bg>
+    <p:spTree>
+      <p:nvGrpSpPr>
+        <p:cNvPr id="1" name=""/>
+        <p:cNvGrpSpPr/>
+        <p:nvPr/>
+      </p:nvGrpSpPr>
+      <p:grpSpPr>
+        <a:xfrm>
+          <a:off x="0" y="0"/>
+          <a:ext cx="0" cy="0"/>
+          <a:chOff x="0" y="0"/>
+          <a:chExt cx="0" cy="0"/>
+        </a:xfrm>
+      </p:grpSpPr>
+      <p:sp>
+        <p:nvSpPr>
+          <p:cNvPr id="2" name="Text 0"/>
+          <p:cNvSpPr/>
+          <p:nvPr>
+            <p:ph idx="100" type="title" hasCustomPrompt="1"/>
+          </p:nvPr>
+        </p:nvSpPr>
+        <p:spPr>
+          <a:xfrm>
+            <a:off x="457200" y="274320"/>
+            <a:ext cx="6309360" cy="1143000"/>
+          </a:xfrm>
+          <a:prstGeom prst="rect">
+            <a:avLst/>
+          </a:prstGeom>
+          <a:noFill/>
+          <a:ln/>
+        </p:spPr>
+        <p:txBody>
+          <a:bodyPr wrap="square" rtlCol="0"/>
+          <a:lstStyle>
+            <a:lvl1pPr algn="l" indent="0" marL="0">
+              <a:buNone/>
+              <a:defRPr lang="en-US" sz="3200" b="1" dirty="0">
+                <a:solidFill>
+                  <a:schemeClr val="bg1"/>
+                </a:solidFill>
+                <a:latin typeface="Prompt" pitchFamily="34" charset="0"/>
+                <a:ea typeface="Prompt" pitchFamily="34" charset="-122"/>
+                <a:cs typeface="Prompt" pitchFamily="34" charset="-120"/>
+              </a:defRPr>
+            </a:lvl1pPr>
+          </a:lstStyle>
+          <a:p>
+            <a:pPr algn="l" indent="0" marL="0">
+              <a:buNone/>
+            </a:pPr>
+            <a:endParaRPr lang="en-US" sz="3200" dirty="0"/>
+          </a:p>
+        </p:txBody>
+      </p:sp>
+      <p:sp>
+        <p:nvSpPr>
+          <p:cNvPr id="3" name="Text 0"/>
+          <p:cNvSpPr/>
+          <p:nvPr>
+            <p:ph idx="101" type="body" hasCustomPrompt="1"/>
+          </p:nvPr>
+        </p:nvSpPr>
+        <p:spPr>
+          <a:xfrm>
+            <a:off x="457200" y="1463040"/>
+            <a:ext cx="6309360" cy="365760"/>
+          </a:xfrm>
+          <a:prstGeom prst="rect">
+            <a:avLst/>
+          </a:prstGeom>
+          <a:noFill/>
+          <a:ln/>
+        </p:spPr>
+        <p:txBody>
+          <a:bodyPr wrap="square" rtlCol="0"/>
+          <a:lstStyle>
+            <a:lvl1pPr algn="l" indent="0" marL="0">
+              <a:buNone/>
+              <a:defRPr lang="en-US" sz="1400" dirty="0">
+                <a:solidFill>
+                  <a:schemeClr val="accent4"/>
+                </a:solidFill>
+                <a:latin typeface="Prompt" pitchFamily="34" charset="0"/>
+                <a:ea typeface="Prompt" pitchFamily="34" charset="-122"/>
+                <a:cs typeface="Prompt" pitchFamily="34" charset="-120"/>
+              </a:defRPr>
+            </a:lvl1pPr>
+          </a:lstStyle>
+          <a:p>
+            <a:pPr algn="l" indent="0" marL="0">
+              <a:buNone/>
+            </a:pPr>
+            <a:endParaRPr lang="en-US" sz="1400" dirty="0"/>
+          </a:p>
+        </p:txBody>
+      </p:sp>
+      <p:sp>
+        <p:nvSpPr>
+          <p:cNvPr id="25" name="Slide Number Placeholder 0"/>
+          <p:cNvSpPr>
+            <a:spLocks noGrp="1"/>
+          </p:cNvSpPr>
+          <p:nvPr>
+            <p:ph type="sldNum" sz="quarter" idx="4294967295"/>
+          </p:nvPr>
+        </p:nvSpPr>
+        <p:spPr>
+          <a:xfrm>
+            <a:off x="8138160" y="4773168"/>
+            <a:ext cx="548640" cy="274320"/>
+          </a:xfrm>
+          <a:prstGeom prst="rect">
+            <a:avLst/>
+          </a:prstGeom>
+          <a:extLst>
+            <a:ext uri="{C572A759-6A51-4108-AA02-DFA0A04FC94B}">
+              <ma14:wrappingTextBoxFlag xmlns:ma14="http://schemas.microsoft.com/office/mac/drawingml/2011/main" val="0"/>
+            </a:ext>
+          </a:extLst>
+        </p:spPr>
+        <p:txBody>
+          <a:bodyPr/>
+          <a:lstStyle>
+            <a:lvl1pPr>
+              <a:defRPr sz="900">
+                <a:solidFill>
+                  <a:srgbClr val="9AA5B4"/>
+                </a:solidFill>
+                <a:latin typeface="Prompt"/>
+                <a:ea typeface="Prompt"/>
+                <a:cs typeface="Prompt"/>
+              </a:defRPr>
+            </a:lvl1pPr>
+          </a:lstStyle>
+          <a:p>
+            <a:pPr algn="r"/>
+            <a:fld id="{F7021451-1387-4CA6-816F-3879F97B5CBC}" type="slidenum">
+              <a:rPr b="0" lang="en-US"/>
+              <a:t>1004</a:t>
+            </a:fld>
+            <a:endParaRPr lang="en-US"/>
+          </a:p>
+        </p:txBody>
+      </p:sp>
+    </p:spTree>
+  </p:cSld>
+  <p:clrMapOvr>
+    <a:masterClrMapping/>
+  </p:clrMapOvr>
+</p:sldLayout>
+</file>
+
+<file path=ppt/slideLayouts/slideLayout5.xml><?xml version="1.0" encoding="utf-8"?>
 <p:sldLayout xmlns:a="http://schemas.openxmlformats.org/drawingml/2006/main" xmlns:r="http://schemas.openxmlformats.org/officeDocument/2006/relationships" xmlns:p="http://schemas.openxmlformats.org/presentationml/2006/main" preserve="1">
   <p:cSld name="CONTENT_TH">
     <p:bg>
@@ -2475,6 +2667,9 @@
                 <a:solidFill>
                   <a:schemeClr val="accent1"/>
                 </a:solidFill>
+                <a:latin typeface="Prompt" pitchFamily="34" charset="0"/>
+                <a:ea typeface="Prompt" pitchFamily="34" charset="-122"/>
+                <a:cs typeface="Prompt" pitchFamily="34" charset="-120"/>
               </a:defRPr>
             </a:lvl1pPr>
           </a:lstStyle>
@@ -2514,6 +2709,9 @@
                 <a:solidFill>
                   <a:schemeClr val="tx1"/>
                 </a:solidFill>
+                <a:latin typeface="Prompt" pitchFamily="34" charset="0"/>
+                <a:ea typeface="Prompt" pitchFamily="34" charset="-122"/>
+                <a:cs typeface="Prompt" pitchFamily="34" charset="-120"/>
               </a:defRPr>
             </a:lvl1pPr>
           </a:lstStyle>
@@ -2554,6 +2752,9 @@
                 <a:solidFill>
                   <a:srgbClr val="9AA5B4"/>
                 </a:solidFill>
+                <a:latin typeface="Prompt" pitchFamily="34" charset="0"/>
+                <a:ea typeface="Prompt" pitchFamily="34" charset="-122"/>
+                <a:cs typeface="Prompt" pitchFamily="34" charset="-120"/>
               </a:rPr>
               <a:t>Chayanun Sungsa-ard  |  691401708  |  MBA  |  ENG 501</a:t>
             </a:r>
@@ -2593,6 +2794,9 @@
                 <a:solidFill>
                   <a:srgbClr val="9AA5B4"/>
                 </a:solidFill>
+                <a:latin typeface="Prompt"/>
+                <a:ea typeface="Prompt"/>
+                <a:cs typeface="Prompt"/>
               </a:defRPr>
             </a:lvl1pPr>
           </a:lstStyle>
@@ -2600,7 +2804,7 @@
             <a:pPr algn="r"/>
             <a:fld id="{F7021451-1387-4CA6-816F-3879F97B5CBC}" type="slidenum">
               <a:rPr b="0" lang="en-US"/>
-              <a:t>1004</a:t>
+              <a:t>1005</a:t>
             </a:fld>
             <a:endParaRPr lang="en-US"/>
           </a:p>
@@ -2663,6 +2867,9 @@
                 <a:solidFill>
                   <a:srgbClr val="9AA5B4"/>
                 </a:solidFill>
+                <a:latin typeface="Poppins"/>
+                <a:ea typeface="Poppins"/>
+                <a:cs typeface="Poppins"/>
               </a:defRPr>
             </a:lvl1pPr>
           </a:lstStyle>
@@ -2684,6 +2891,7 @@
     <p:sldLayoutId id="2147483650" r:id="rId2"/>
     <p:sldLayoutId id="2147483651" r:id="rId3"/>
     <p:sldLayoutId id="2147483652" r:id="rId4"/>
+    <p:sldLayoutId id="2147483653" r:id="rId5"/>
   </p:sldLayoutIdLst>
   <p:hf sldNum="0" hdr="0" ftr="0" dt="0"/>
   <p:txStyles>
@@ -2987,6 +3195,9 @@
                 <a:solidFill>
                   <a:schemeClr val="bg1"/>
                 </a:solidFill>
+                <a:latin typeface="Poppins" pitchFamily="34" charset="0"/>
+                <a:ea typeface="Poppins" pitchFamily="34" charset="-122"/>
+                <a:cs typeface="Poppins" pitchFamily="34" charset="-120"/>
               </a:rPr>
               <a:t>Artificial Intelligence and Work Performance</a:t>
             </a:r>
@@ -3025,6 +3236,9 @@
                 <a:solidFill>
                   <a:schemeClr val="accent4"/>
                 </a:solidFill>
+                <a:latin typeface="Poppins" pitchFamily="34" charset="0"/>
+                <a:ea typeface="Poppins" pitchFamily="34" charset="-122"/>
+                <a:cs typeface="Poppins" pitchFamily="34" charset="-120"/>
               </a:rPr>
               <a:t>Evidence from two recent field experiments</a:t>
             </a:r>
@@ -3085,6 +3299,9 @@
                 <a:solidFill>
                   <a:srgbClr val="BFE6E0"/>
                 </a:solidFill>
+                <a:latin typeface="Poppins" pitchFamily="34" charset="0"/>
+                <a:ea typeface="Poppins" pitchFamily="34" charset="-122"/>
+                <a:cs typeface="Poppins" pitchFamily="34" charset="-120"/>
               </a:rPr>
               <a:t>Central question: How does AI affect productivity, work quality, and business performance?</a:t>
             </a:r>
@@ -3148,6 +3365,9 @@
                 <a:solidFill>
                   <a:srgbClr val="BFE6E0"/>
                 </a:solidFill>
+                <a:latin typeface="Poppins" pitchFamily="34" charset="0"/>
+                <a:ea typeface="Poppins" pitchFamily="34" charset="-122"/>
+                <a:cs typeface="Poppins" pitchFamily="34" charset="-120"/>
               </a:rPr>
               <a:t>Article 2</a:t>
             </a:r>
@@ -3184,6 +3404,9 @@
                 <a:solidFill>
                   <a:srgbClr val="FFFFFF"/>
                 </a:solidFill>
+                <a:latin typeface="Poppins" pitchFamily="34" charset="0"/>
+                <a:ea typeface="Poppins" pitchFamily="34" charset="-122"/>
+                <a:cs typeface="Poppins" pitchFamily="34" charset="-120"/>
               </a:rPr>
               <a:t>Navigating the Jagged Technological Frontier: Field Experimental Evidence of the Effects of AI on Knowledge Worker Productivity and Quality</a:t>
             </a:r>
@@ -3220,6 +3443,9 @@
                 <a:solidFill>
                   <a:srgbClr val="BFE6E0"/>
                 </a:solidFill>
+                <a:latin typeface="Poppins" pitchFamily="34" charset="0"/>
+                <a:ea typeface="Poppins" pitchFamily="34" charset="-122"/>
+                <a:cs typeface="Poppins" pitchFamily="34" charset="-120"/>
               </a:rPr>
               <a:t>Fabrizio Dell'Acqua et al.  |  Harvard Business School Working Paper 24-013, 2023</a:t>
             </a:r>
@@ -3283,6 +3509,9 @@
                 <a:solidFill>
                   <a:srgbClr val="BFE6E0"/>
                 </a:solidFill>
+                <a:latin typeface="Poppins" pitchFamily="34" charset="0"/>
+                <a:ea typeface="Poppins" pitchFamily="34" charset="-122"/>
+                <a:cs typeface="Poppins" pitchFamily="34" charset="-120"/>
               </a:rPr>
               <a:t>Article 5</a:t>
             </a:r>
@@ -3319,6 +3548,9 @@
                 <a:solidFill>
                   <a:srgbClr val="FFFFFF"/>
                 </a:solidFill>
+                <a:latin typeface="Poppins" pitchFamily="34" charset="0"/>
+                <a:ea typeface="Poppins" pitchFamily="34" charset="-122"/>
+                <a:cs typeface="Poppins" pitchFamily="34" charset="-120"/>
               </a:rPr>
               <a:t>The Uneven Impact of Generative Artificial Intelligence on Entrepreneurial Performance: Evidence from a Field Experiment in Kenya</a:t>
             </a:r>
@@ -3355,6 +3587,9 @@
                 <a:solidFill>
                   <a:srgbClr val="BFE6E0"/>
                 </a:solidFill>
+                <a:latin typeface="Poppins" pitchFamily="34" charset="0"/>
+                <a:ea typeface="Poppins" pitchFamily="34" charset="-122"/>
+                <a:cs typeface="Poppins" pitchFamily="34" charset="-120"/>
               </a:rPr>
               <a:t>Nicholas G. Otis et al.  |  Management Science, Vol. 72, No. 7, 2026  |  DOI 10.1287/mnsc.2024.06909</a:t>
             </a:r>
@@ -3391,6 +3626,9 @@
                 <a:solidFill>
                   <a:srgbClr val="BFE6E0"/>
                 </a:solidFill>
+                <a:latin typeface="Poppins" pitchFamily="34" charset="0"/>
+                <a:ea typeface="Poppins" pitchFamily="34" charset="-122"/>
+                <a:cs typeface="Poppins" pitchFamily="34" charset="-120"/>
               </a:rPr>
               <a:t>Today's path</a:t>
             </a:r>
@@ -3454,6 +3692,9 @@
                 <a:solidFill>
                   <a:srgbClr val="FFFFFF"/>
                 </a:solidFill>
+                <a:latin typeface="Poppins" pitchFamily="34" charset="0"/>
+                <a:ea typeface="Poppins" pitchFamily="34" charset="-122"/>
+                <a:cs typeface="Poppins" pitchFamily="34" charset="-120"/>
               </a:rPr>
               <a:t>1  Introduction</a:t>
             </a:r>
@@ -3517,6 +3758,9 @@
                 <a:solidFill>
                   <a:srgbClr val="FFFFFF"/>
                 </a:solidFill>
+                <a:latin typeface="Poppins" pitchFamily="34" charset="0"/>
+                <a:ea typeface="Poppins" pitchFamily="34" charset="-122"/>
+                <a:cs typeface="Poppins" pitchFamily="34" charset="-120"/>
               </a:rPr>
               <a:t>2  Article 2: Method</a:t>
             </a:r>
@@ -3580,6 +3824,9 @@
                 <a:solidFill>
                   <a:srgbClr val="FFFFFF"/>
                 </a:solidFill>
+                <a:latin typeface="Poppins" pitchFamily="34" charset="0"/>
+                <a:ea typeface="Poppins" pitchFamily="34" charset="-122"/>
+                <a:cs typeface="Poppins" pitchFamily="34" charset="-120"/>
               </a:rPr>
               <a:t>3  Article 2: Findings</a:t>
             </a:r>
@@ -3643,6 +3890,9 @@
                 <a:solidFill>
                   <a:srgbClr val="FFFFFF"/>
                 </a:solidFill>
+                <a:latin typeface="Poppins" pitchFamily="34" charset="0"/>
+                <a:ea typeface="Poppins" pitchFamily="34" charset="-122"/>
+                <a:cs typeface="Poppins" pitchFamily="34" charset="-120"/>
               </a:rPr>
               <a:t>4  Article 5: Entrepreneurs</a:t>
             </a:r>
@@ -3706,6 +3956,9 @@
                 <a:solidFill>
                   <a:srgbClr val="FFFFFF"/>
                 </a:solidFill>
+                <a:latin typeface="Poppins" pitchFamily="34" charset="0"/>
+                <a:ea typeface="Poppins" pitchFamily="34" charset="-122"/>
+                <a:cs typeface="Poppins" pitchFamily="34" charset="-120"/>
               </a:rPr>
               <a:t>5  Discussion</a:t>
             </a:r>
@@ -3742,6 +3995,9 @@
                 <a:solidFill>
                   <a:srgbClr val="FFFFFF"/>
                 </a:solidFill>
+                <a:latin typeface="Poppins" pitchFamily="34" charset="0"/>
+                <a:ea typeface="Poppins" pitchFamily="34" charset="-122"/>
+                <a:cs typeface="Poppins" pitchFamily="34" charset="-120"/>
               </a:rPr>
               <a:t>Chayanun Sungsa-ard</a:t>
             </a:r>
@@ -3756,6 +4012,9 @@
                 <a:solidFill>
                   <a:srgbClr val="BFE6E0"/>
                 </a:solidFill>
+                <a:latin typeface="Poppins" pitchFamily="34" charset="0"/>
+                <a:ea typeface="Poppins" pitchFamily="34" charset="-122"/>
+                <a:cs typeface="Poppins" pitchFamily="34" charset="-120"/>
               </a:rPr>
               <a:t>Student ID 691401708  |  Master of Business Administration (MBA)  |  ENG 501 English for Master's Degree</a:t>
             </a:r>
@@ -3795,6 +4054,9 @@
                 <a:solidFill>
                   <a:srgbClr val="9AA5B4"/>
                 </a:solidFill>
+                <a:latin typeface="Poppins"/>
+                <a:ea typeface="Poppins"/>
+                <a:cs typeface="Poppins"/>
               </a:defRPr>
             </a:lvl1pPr>
           </a:lstStyle>
@@ -3864,6 +4126,9 @@
                 <a:solidFill>
                   <a:schemeClr val="accent1"/>
                 </a:solidFill>
+                <a:latin typeface="Prompt" pitchFamily="34" charset="0"/>
+                <a:ea typeface="Prompt" pitchFamily="34" charset="-122"/>
+                <a:cs typeface="Prompt" pitchFamily="34" charset="-120"/>
               </a:rPr>
               <a:t>อภิปรายผลและเปรียบเทียบ</a:t>
             </a:r>
@@ -3904,6 +4169,9 @@
                 <a:solidFill>
                   <a:schemeClr val="tx1"/>
                 </a:solidFill>
+                <a:latin typeface="Prompt" pitchFamily="34" charset="0"/>
+                <a:ea typeface="Prompt" pitchFamily="34" charset="-122"/>
+                <a:cs typeface="Prompt" pitchFamily="34" charset="-120"/>
               </a:rPr>
               <a:t>AI เป็นเครื่องมือ ไม่ใช่หลักประกันความสำเร็จ</a:t>
             </a:r>
@@ -4065,6 +4333,9 @@
                 <a:solidFill>
                   <a:schemeClr val="tx2"/>
                 </a:solidFill>
+                <a:latin typeface="Prompt" pitchFamily="34" charset="0"/>
+                <a:ea typeface="Prompt" pitchFamily="34" charset="-122"/>
+                <a:cs typeface="Prompt" pitchFamily="34" charset="-120"/>
               </a:rPr>
               <a:t>อภิปรายผล</a:t>
             </a:r>
@@ -4128,6 +4399,9 @@
                 <a:solidFill>
                   <a:srgbClr val="FFFFFF"/>
                 </a:solidFill>
+                <a:latin typeface="Prompt" pitchFamily="34" charset="0"/>
+                <a:ea typeface="Prompt" pitchFamily="34" charset="-122"/>
+                <a:cs typeface="Prompt" pitchFamily="34" charset="-120"/>
               </a:rPr>
               <a:t>ผลการวิจัย (รายงานในบทความ)</a:t>
             </a:r>
@@ -4172,9 +4446,9 @@
                         <a:buNone/>
                       </a:pPr>
                       <a:endParaRPr lang="en-US" sz="1050" dirty="0">
-                        <a:latin typeface="Tahoma" charset="0"/>
-                        <a:ea typeface="Tahoma" charset="0"/>
-                        <a:cs typeface="Tahoma" charset="0"/>
+                        <a:latin typeface="Prompt" charset="0"/>
+                        <a:ea typeface="Prompt" charset="0"/>
+                        <a:cs typeface="Prompt" charset="0"/>
                       </a:endParaRPr>
                     </a:p>
                   </a:txBody>
@@ -4233,16 +4507,16 @@
                           <a:solidFill>
                             <a:srgbClr val="FFFFFF"/>
                           </a:solidFill>
-                          <a:latin typeface="Tahoma" pitchFamily="34" charset="0"/>
-                          <a:ea typeface="Tahoma" pitchFamily="34" charset="-122"/>
-                          <a:cs typeface="Tahoma" pitchFamily="34" charset="-120"/>
+                          <a:latin typeface="Prompt" pitchFamily="34" charset="0"/>
+                          <a:ea typeface="Prompt" pitchFamily="34" charset="-122"/>
+                          <a:cs typeface="Prompt" pitchFamily="34" charset="-120"/>
                         </a:rPr>
                         <a:t>บทความที่ 2  |  Dell'Acqua et al. (2023)</a:t>
                       </a:r>
                       <a:endParaRPr lang="en-US" sz="1050" dirty="0">
-                        <a:latin typeface="Tahoma" charset="0"/>
-                        <a:ea typeface="Tahoma" charset="0"/>
-                        <a:cs typeface="Tahoma" charset="0"/>
+                        <a:latin typeface="Prompt" charset="0"/>
+                        <a:ea typeface="Prompt" charset="0"/>
+                        <a:cs typeface="Prompt" charset="0"/>
                       </a:endParaRPr>
                     </a:p>
                   </a:txBody>
@@ -4301,16 +4575,16 @@
                           <a:solidFill>
                             <a:srgbClr val="FFFFFF"/>
                           </a:solidFill>
-                          <a:latin typeface="Tahoma" pitchFamily="34" charset="0"/>
-                          <a:ea typeface="Tahoma" pitchFamily="34" charset="-122"/>
-                          <a:cs typeface="Tahoma" pitchFamily="34" charset="-120"/>
+                          <a:latin typeface="Prompt" pitchFamily="34" charset="0"/>
+                          <a:ea typeface="Prompt" pitchFamily="34" charset="-122"/>
+                          <a:cs typeface="Prompt" pitchFamily="34" charset="-120"/>
                         </a:rPr>
                         <a:t>บทความที่ 5  |  Otis et al. (2026)</a:t>
                       </a:r>
                       <a:endParaRPr lang="en-US" sz="1050" dirty="0">
-                        <a:latin typeface="Tahoma" charset="0"/>
-                        <a:ea typeface="Tahoma" charset="0"/>
-                        <a:cs typeface="Tahoma" charset="0"/>
+                        <a:latin typeface="Prompt" charset="0"/>
+                        <a:ea typeface="Prompt" charset="0"/>
+                        <a:cs typeface="Prompt" charset="0"/>
                       </a:endParaRPr>
                     </a:p>
                   </a:txBody>
@@ -4371,16 +4645,16 @@
                           <a:solidFill>
                             <a:srgbClr val="1B2A4A"/>
                           </a:solidFill>
-                          <a:latin typeface="Tahoma" pitchFamily="34" charset="0"/>
-                          <a:ea typeface="Tahoma" pitchFamily="34" charset="-122"/>
-                          <a:cs typeface="Tahoma" pitchFamily="34" charset="-120"/>
+                          <a:latin typeface="Prompt" pitchFamily="34" charset="0"/>
+                          <a:ea typeface="Prompt" pitchFamily="34" charset="-122"/>
+                          <a:cs typeface="Prompt" pitchFamily="34" charset="-120"/>
                         </a:rPr>
                         <a:t>กลุ่มที่ศึกษา</a:t>
                       </a:r>
                       <a:endParaRPr lang="en-US" sz="1050" dirty="0">
-                        <a:latin typeface="Tahoma" charset="0"/>
-                        <a:ea typeface="Tahoma" charset="0"/>
-                        <a:cs typeface="Tahoma" charset="0"/>
+                        <a:latin typeface="Prompt" charset="0"/>
+                        <a:ea typeface="Prompt" charset="0"/>
+                        <a:cs typeface="Prompt" charset="0"/>
                       </a:endParaRPr>
                     </a:p>
                   </a:txBody>
@@ -4439,16 +4713,16 @@
                           <a:solidFill>
                             <a:srgbClr val="5A6472"/>
                           </a:solidFill>
-                          <a:latin typeface="Tahoma" pitchFamily="34" charset="0"/>
-                          <a:ea typeface="Tahoma" pitchFamily="34" charset="-122"/>
-                          <a:cs typeface="Tahoma" pitchFamily="34" charset="-120"/>
+                          <a:latin typeface="Prompt" pitchFamily="34" charset="0"/>
+                          <a:ea typeface="Prompt" pitchFamily="34" charset="-122"/>
+                          <a:cs typeface="Prompt" pitchFamily="34" charset="-120"/>
                         </a:rPr>
                         <a:t>พนักงานความรู้และที่ปรึกษา (BCG)</a:t>
                       </a:r>
                       <a:endParaRPr lang="en-US" sz="1050" dirty="0">
-                        <a:latin typeface="Tahoma" charset="0"/>
-                        <a:ea typeface="Tahoma" charset="0"/>
-                        <a:cs typeface="Tahoma" charset="0"/>
+                        <a:latin typeface="Prompt" charset="0"/>
+                        <a:ea typeface="Prompt" charset="0"/>
+                        <a:cs typeface="Prompt" charset="0"/>
                       </a:endParaRPr>
                     </a:p>
                   </a:txBody>
@@ -4507,16 +4781,16 @@
                           <a:solidFill>
                             <a:srgbClr val="5A6472"/>
                           </a:solidFill>
-                          <a:latin typeface="Tahoma" pitchFamily="34" charset="0"/>
-                          <a:ea typeface="Tahoma" pitchFamily="34" charset="-122"/>
-                          <a:cs typeface="Tahoma" pitchFamily="34" charset="-120"/>
+                          <a:latin typeface="Prompt" pitchFamily="34" charset="0"/>
+                          <a:ea typeface="Prompt" pitchFamily="34" charset="-122"/>
+                          <a:cs typeface="Prompt" pitchFamily="34" charset="-120"/>
                         </a:rPr>
                         <a:t>ผู้ประกอบการในประเทศเคนยา</a:t>
                       </a:r>
                       <a:endParaRPr lang="en-US" sz="1050" dirty="0">
-                        <a:latin typeface="Tahoma" charset="0"/>
-                        <a:ea typeface="Tahoma" charset="0"/>
-                        <a:cs typeface="Tahoma" charset="0"/>
+                        <a:latin typeface="Prompt" charset="0"/>
+                        <a:ea typeface="Prompt" charset="0"/>
+                        <a:cs typeface="Prompt" charset="0"/>
                       </a:endParaRPr>
                     </a:p>
                   </a:txBody>
@@ -4577,16 +4851,16 @@
                           <a:solidFill>
                             <a:srgbClr val="1B2A4A"/>
                           </a:solidFill>
-                          <a:latin typeface="Tahoma" pitchFamily="34" charset="0"/>
-                          <a:ea typeface="Tahoma" pitchFamily="34" charset="-122"/>
-                          <a:cs typeface="Tahoma" pitchFamily="34" charset="-120"/>
+                          <a:latin typeface="Prompt" pitchFamily="34" charset="0"/>
+                          <a:ea typeface="Prompt" pitchFamily="34" charset="-122"/>
+                          <a:cs typeface="Prompt" pitchFamily="34" charset="-120"/>
                         </a:rPr>
                         <a:t>ผลหลัก</a:t>
                       </a:r>
                       <a:endParaRPr lang="en-US" sz="1050" dirty="0">
-                        <a:latin typeface="Tahoma" charset="0"/>
-                        <a:ea typeface="Tahoma" charset="0"/>
-                        <a:cs typeface="Tahoma" charset="0"/>
+                        <a:latin typeface="Prompt" charset="0"/>
+                        <a:ea typeface="Prompt" charset="0"/>
+                        <a:cs typeface="Prompt" charset="0"/>
                       </a:endParaRPr>
                     </a:p>
                   </a:txBody>
@@ -4645,16 +4919,16 @@
                           <a:solidFill>
                             <a:srgbClr val="5A6472"/>
                           </a:solidFill>
-                          <a:latin typeface="Tahoma" pitchFamily="34" charset="0"/>
-                          <a:ea typeface="Tahoma" pitchFamily="34" charset="-122"/>
-                          <a:cs typeface="Tahoma" pitchFamily="34" charset="-120"/>
+                          <a:latin typeface="Prompt" pitchFamily="34" charset="0"/>
+                          <a:ea typeface="Prompt" pitchFamily="34" charset="-122"/>
+                          <a:cs typeface="Prompt" pitchFamily="34" charset="-120"/>
                         </a:rPr>
                         <a:t>ผลิตภาพและคุณภาพงานสูงขึ้นสำหรับงานภายในพรมแดนความสามารถของ AI</a:t>
                       </a:r>
                       <a:endParaRPr lang="en-US" sz="1050" dirty="0">
-                        <a:latin typeface="Tahoma" charset="0"/>
-                        <a:ea typeface="Tahoma" charset="0"/>
-                        <a:cs typeface="Tahoma" charset="0"/>
+                        <a:latin typeface="Prompt" charset="0"/>
+                        <a:ea typeface="Prompt" charset="0"/>
+                        <a:cs typeface="Prompt" charset="0"/>
                       </a:endParaRPr>
                     </a:p>
                   </a:txBody>
@@ -4713,16 +4987,16 @@
                           <a:solidFill>
                             <a:srgbClr val="5A6472"/>
                           </a:solidFill>
-                          <a:latin typeface="Tahoma" pitchFamily="34" charset="0"/>
-                          <a:ea typeface="Tahoma" pitchFamily="34" charset="-122"/>
-                          <a:cs typeface="Tahoma" pitchFamily="34" charset="-120"/>
+                          <a:latin typeface="Prompt" pitchFamily="34" charset="0"/>
+                          <a:ea typeface="Prompt" pitchFamily="34" charset="-122"/>
+                          <a:cs typeface="Prompt" pitchFamily="34" charset="-120"/>
                         </a:rPr>
                         <a:t>ไม่พบผลเฉลี่ยของการทดลองต่อรายได้และกำไรอย่างชัดเจน</a:t>
                       </a:r>
                       <a:endParaRPr lang="en-US" sz="1050" dirty="0">
-                        <a:latin typeface="Tahoma" charset="0"/>
-                        <a:ea typeface="Tahoma" charset="0"/>
-                        <a:cs typeface="Tahoma" charset="0"/>
+                        <a:latin typeface="Prompt" charset="0"/>
+                        <a:ea typeface="Prompt" charset="0"/>
+                        <a:cs typeface="Prompt" charset="0"/>
                       </a:endParaRPr>
                     </a:p>
                   </a:txBody>
@@ -4783,16 +5057,16 @@
                           <a:solidFill>
                             <a:srgbClr val="1B2A4A"/>
                           </a:solidFill>
-                          <a:latin typeface="Tahoma" pitchFamily="34" charset="0"/>
-                          <a:ea typeface="Tahoma" pitchFamily="34" charset="-122"/>
-                          <a:cs typeface="Tahoma" pitchFamily="34" charset="-120"/>
+                          <a:latin typeface="Prompt" pitchFamily="34" charset="0"/>
+                          <a:ea typeface="Prompt" pitchFamily="34" charset="-122"/>
+                          <a:cs typeface="Prompt" pitchFamily="34" charset="-120"/>
                         </a:rPr>
                         <a:t>ข้อจำกัดหรือข้อค้นพบสำคัญ</a:t>
                       </a:r>
                       <a:endParaRPr lang="en-US" sz="1050" dirty="0">
-                        <a:latin typeface="Tahoma" charset="0"/>
-                        <a:ea typeface="Tahoma" charset="0"/>
-                        <a:cs typeface="Tahoma" charset="0"/>
+                        <a:latin typeface="Prompt" charset="0"/>
+                        <a:ea typeface="Prompt" charset="0"/>
+                        <a:cs typeface="Prompt" charset="0"/>
                       </a:endParaRPr>
                     </a:p>
                   </a:txBody>
@@ -4851,16 +5125,16 @@
                           <a:solidFill>
                             <a:srgbClr val="5A6472"/>
                           </a:solidFill>
-                          <a:latin typeface="Tahoma" pitchFamily="34" charset="0"/>
-                          <a:ea typeface="Tahoma" pitchFamily="34" charset="-122"/>
-                          <a:cs typeface="Tahoma" pitchFamily="34" charset="-120"/>
+                          <a:latin typeface="Prompt" pitchFamily="34" charset="0"/>
+                          <a:ea typeface="Prompt" pitchFamily="34" charset="-122"/>
+                          <a:cs typeface="Prompt" pitchFamily="34" charset="-120"/>
                         </a:rPr>
                         <a:t>ความถูกต้องลดลงในงานที่อยู่นอกพรมแดนนั้น</a:t>
                       </a:r>
                       <a:endParaRPr lang="en-US" sz="1050" dirty="0">
-                        <a:latin typeface="Tahoma" charset="0"/>
-                        <a:ea typeface="Tahoma" charset="0"/>
-                        <a:cs typeface="Tahoma" charset="0"/>
+                        <a:latin typeface="Prompt" charset="0"/>
+                        <a:ea typeface="Prompt" charset="0"/>
+                        <a:cs typeface="Prompt" charset="0"/>
                       </a:endParaRPr>
                     </a:p>
                   </a:txBody>
@@ -4919,16 +5193,16 @@
                           <a:solidFill>
                             <a:srgbClr val="5A6472"/>
                           </a:solidFill>
-                          <a:latin typeface="Tahoma" pitchFamily="34" charset="0"/>
-                          <a:ea typeface="Tahoma" pitchFamily="34" charset="-122"/>
-                          <a:cs typeface="Tahoma" pitchFamily="34" charset="-120"/>
+                          <a:latin typeface="Prompt" pitchFamily="34" charset="0"/>
+                          <a:ea typeface="Prompt" pitchFamily="34" charset="-122"/>
+                          <a:cs typeface="Prompt" pitchFamily="34" charset="-120"/>
                         </a:rPr>
                         <a:t>ผลลัพธ์ต่างกันตามผลการดำเนินงานตั้งต้น และตามคำแนะนำของ AI ที่เลือกนำไปปฏิบัติ</a:t>
                       </a:r>
                       <a:endParaRPr lang="en-US" sz="1050" dirty="0">
-                        <a:latin typeface="Tahoma" charset="0"/>
-                        <a:ea typeface="Tahoma" charset="0"/>
-                        <a:cs typeface="Tahoma" charset="0"/>
+                        <a:latin typeface="Prompt" charset="0"/>
+                        <a:ea typeface="Prompt" charset="0"/>
+                        <a:cs typeface="Prompt" charset="0"/>
                       </a:endParaRPr>
                     </a:p>
                   </a:txBody>
@@ -5069,6 +5343,9 @@
                 <a:solidFill>
                   <a:schemeClr val="tx2"/>
                 </a:solidFill>
+                <a:latin typeface="Prompt" pitchFamily="34" charset="0"/>
+                <a:ea typeface="Prompt" pitchFamily="34" charset="-122"/>
+                <a:cs typeface="Prompt" pitchFamily="34" charset="-120"/>
               </a:rPr>
               <a:t>การตีความ</a:t>
             </a:r>
@@ -5105,6 +5382,9 @@
                 <a:solidFill>
                   <a:srgbClr val="FFFFFF"/>
                 </a:solidFill>
+                <a:latin typeface="Prompt" pitchFamily="34" charset="0"/>
+                <a:ea typeface="Prompt" pitchFamily="34" charset="-122"/>
+                <a:cs typeface="Prompt" pitchFamily="34" charset="-120"/>
               </a:rPr>
               <a:t>บทสรุป</a:t>
             </a:r>
@@ -5141,6 +5421,9 @@
                 <a:solidFill>
                   <a:srgbClr val="FFFFFF"/>
                 </a:solidFill>
+                <a:latin typeface="Prompt" pitchFamily="34" charset="0"/>
+                <a:ea typeface="Prompt" pitchFamily="34" charset="-122"/>
+                <a:cs typeface="Prompt" pitchFamily="34" charset="-120"/>
               </a:rPr>
               <a:t>AI ส่งผลต่อผลการทำงานจริงได้ แต่ผลกระทบขึ้นอยู่กับความเหมาะสมของงาน พฤติกรรมของผู้ใช้ และวิจารณญาณของมนุษย์</a:t>
             </a:r>
@@ -5197,14 +5480,17 @@
               <a:buNone/>
             </a:pPr>
             <a:r>
-              <a:rPr lang="en-US" sz="1000" dirty="0">
+              <a:rPr lang="en-US" sz="950" dirty="0">
                 <a:solidFill>
                   <a:srgbClr val="FFFFFF"/>
                 </a:solidFill>
+                <a:latin typeface="Prompt" pitchFamily="34" charset="0"/>
+                <a:ea typeface="Prompt" pitchFamily="34" charset="-122"/>
+                <a:cs typeface="Prompt" pitchFamily="34" charset="-120"/>
               </a:rPr>
               <a:t>เลือกงานให้เหมาะกับสิ่งที่ AI ทำได้ดี</a:t>
             </a:r>
-            <a:endParaRPr lang="en-US" sz="1000" dirty="0"/>
+            <a:endParaRPr lang="en-US" sz="950" dirty="0"/>
           </a:p>
         </p:txBody>
       </p:sp>
@@ -5257,14 +5543,17 @@
               <a:buNone/>
             </a:pPr>
             <a:r>
-              <a:rPr lang="en-US" sz="1000" dirty="0">
+              <a:rPr lang="en-US" sz="950" dirty="0">
                 <a:solidFill>
                   <a:srgbClr val="FFFFFF"/>
                 </a:solidFill>
+                <a:latin typeface="Prompt" pitchFamily="34" charset="0"/>
+                <a:ea typeface="Prompt" pitchFamily="34" charset="-122"/>
+                <a:cs typeface="Prompt" pitchFamily="34" charset="-120"/>
               </a:rPr>
               <a:t>ประเมินคำแนะนำของ AI อย่างมีวิจารณญาณก่อนนำไปใช้</a:t>
             </a:r>
-            <a:endParaRPr lang="en-US" sz="1000" dirty="0"/>
+            <a:endParaRPr lang="en-US" sz="950" dirty="0"/>
           </a:p>
         </p:txBody>
       </p:sp>
@@ -5317,14 +5606,17 @@
               <a:buNone/>
             </a:pPr>
             <a:r>
-              <a:rPr lang="en-US" sz="1000" dirty="0">
+              <a:rPr lang="en-US" sz="950" dirty="0">
                 <a:solidFill>
                   <a:srgbClr val="FFFFFF"/>
                 </a:solidFill>
+                <a:latin typeface="Prompt" pitchFamily="34" charset="0"/>
+                <a:ea typeface="Prompt" pitchFamily="34" charset="-122"/>
+                <a:cs typeface="Prompt" pitchFamily="34" charset="-120"/>
               </a:rPr>
               <a:t>ให้มนุษย์เป็นผู้ตัดสินใจขั้นสุดท้าย</a:t>
             </a:r>
-            <a:endParaRPr lang="en-US" sz="1000" dirty="0"/>
+            <a:endParaRPr lang="en-US" sz="950" dirty="0"/>
           </a:p>
         </p:txBody>
       </p:sp>
@@ -5405,6 +5697,9 @@
                 <a:solidFill>
                   <a:schemeClr val="tx2"/>
                 </a:solidFill>
+                <a:latin typeface="Prompt" pitchFamily="34" charset="0"/>
+                <a:ea typeface="Prompt" pitchFamily="34" charset="-122"/>
+                <a:cs typeface="Prompt" pitchFamily="34" charset="-120"/>
               </a:rPr>
               <a:t>Dell'Acqua et al. (2023), Harvard Business School Working Paper 24-013   |   Otis et al. (2026), Management Science, 72(7), https://doi.org/10.1287/mnsc.2024.06909</a:t>
             </a:r>
@@ -5492,6 +5787,9 @@
                 <a:solidFill>
                   <a:srgbClr val="2E8B86"/>
                 </a:solidFill>
+                <a:latin typeface="Prompt" pitchFamily="34" charset="0"/>
+                <a:ea typeface="Prompt" pitchFamily="34" charset="-122"/>
+                <a:cs typeface="Prompt" pitchFamily="34" charset="-120"/>
               </a:rPr>
               <a:t>ถัดไป:  </a:t>
             </a:r>
@@ -5503,6 +5801,9 @@
                 <a:solidFill>
                   <a:srgbClr val="1B2A4A"/>
                 </a:solidFill>
+                <a:latin typeface="Prompt" pitchFamily="34" charset="0"/>
+                <a:ea typeface="Prompt" pitchFamily="34" charset="-122"/>
+                <a:cs typeface="Prompt" pitchFamily="34" charset="-120"/>
               </a:rPr>
               <a:t>ขอบคุณครับ ยินดีรับคำถาม</a:t>
             </a:r>
@@ -5542,6 +5843,9 @@
                 <a:solidFill>
                   <a:srgbClr val="9AA5B4"/>
                 </a:solidFill>
+                <a:latin typeface="Prompt"/>
+                <a:ea typeface="Prompt"/>
+                <a:cs typeface="Prompt"/>
               </a:defRPr>
             </a:lvl1pPr>
           </a:lstStyle>
@@ -5611,6 +5915,9 @@
                 <a:solidFill>
                   <a:schemeClr val="accent1"/>
                 </a:solidFill>
+                <a:latin typeface="Poppins" pitchFamily="34" charset="0"/>
+                <a:ea typeface="Poppins" pitchFamily="34" charset="-122"/>
+                <a:cs typeface="Poppins" pitchFamily="34" charset="-120"/>
               </a:rPr>
               <a:t>Article 2  |  Research purpose and method</a:t>
             </a:r>
@@ -5651,6 +5958,9 @@
                 <a:solidFill>
                   <a:schemeClr val="tx1"/>
                 </a:solidFill>
+                <a:latin typeface="Poppins" pitchFamily="34" charset="0"/>
+                <a:ea typeface="Poppins" pitchFamily="34" charset="-122"/>
+                <a:cs typeface="Poppins" pitchFamily="34" charset="-120"/>
               </a:rPr>
               <a:t>Navigating the Jagged Technological Frontier</a:t>
             </a:r>
@@ -5812,6 +6122,9 @@
                 <a:solidFill>
                   <a:schemeClr val="tx2"/>
                 </a:solidFill>
+                <a:latin typeface="Poppins" pitchFamily="34" charset="0"/>
+                <a:ea typeface="Poppins" pitchFamily="34" charset="-122"/>
+                <a:cs typeface="Poppins" pitchFamily="34" charset="-120"/>
               </a:rPr>
               <a:t>Article 2: Method</a:t>
             </a:r>
@@ -5848,6 +6161,9 @@
                 <a:solidFill>
                   <a:schemeClr val="tx2"/>
                 </a:solidFill>
+                <a:latin typeface="Poppins" pitchFamily="34" charset="0"/>
+                <a:ea typeface="Poppins" pitchFamily="34" charset="-122"/>
+                <a:cs typeface="Poppins" pitchFamily="34" charset="-120"/>
               </a:rPr>
               <a:t>Fabrizio Dell'Acqua et al.  |  Harvard Business School Working Paper 24-013, 2023</a:t>
             </a:r>
@@ -5933,6 +6249,9 @@
                 <a:solidFill>
                   <a:schemeClr val="tx1"/>
                 </a:solidFill>
+                <a:latin typeface="Poppins" pitchFamily="34" charset="0"/>
+                <a:ea typeface="Poppins" pitchFamily="34" charset="-122"/>
+                <a:cs typeface="Poppins" pitchFamily="34" charset="-120"/>
               </a:rPr>
               <a:t>Research partner</a:t>
             </a:r>
@@ -5947,6 +6266,9 @@
                 <a:solidFill>
                   <a:schemeClr val="tx2"/>
                 </a:solidFill>
+                <a:latin typeface="Poppins" pitchFamily="34" charset="0"/>
+                <a:ea typeface="Poppins" pitchFamily="34" charset="-122"/>
+                <a:cs typeface="Poppins" pitchFamily="34" charset="-120"/>
               </a:rPr>
               <a:t>Field experiment conducted with Boston Consulting Group (BCG)</a:t>
             </a:r>
@@ -6032,6 +6354,9 @@
                 <a:solidFill>
                   <a:schemeClr val="tx1"/>
                 </a:solidFill>
+                <a:latin typeface="Poppins" pitchFamily="34" charset="0"/>
+                <a:ea typeface="Poppins" pitchFamily="34" charset="-122"/>
+                <a:cs typeface="Poppins" pitchFamily="34" charset="-120"/>
               </a:rPr>
               <a:t>Participants</a:t>
             </a:r>
@@ -6046,6 +6371,9 @@
                 <a:solidFill>
                   <a:schemeClr val="tx2"/>
                 </a:solidFill>
+                <a:latin typeface="Poppins" pitchFamily="34" charset="0"/>
+                <a:ea typeface="Poppins" pitchFamily="34" charset="-122"/>
+                <a:cs typeface="Poppins" pitchFamily="34" charset="-120"/>
               </a:rPr>
               <a:t>758 consultants took part</a:t>
             </a:r>
@@ -6131,6 +6459,9 @@
                 <a:solidFill>
                   <a:schemeClr val="tx1"/>
                 </a:solidFill>
+                <a:latin typeface="Poppins" pitchFamily="34" charset="0"/>
+                <a:ea typeface="Poppins" pitchFamily="34" charset="-122"/>
+                <a:cs typeface="Poppins" pitchFamily="34" charset="-120"/>
               </a:rPr>
               <a:t>Research focus</a:t>
             </a:r>
@@ -6145,6 +6476,9 @@
                 <a:solidFill>
                   <a:schemeClr val="tx2"/>
                 </a:solidFill>
+                <a:latin typeface="Poppins" pitchFamily="34" charset="0"/>
+                <a:ea typeface="Poppins" pitchFamily="34" charset="-122"/>
+                <a:cs typeface="Poppins" pitchFamily="34" charset="-120"/>
               </a:rPr>
               <a:t>Productivity, work quality, and the boundaries of AI capability</a:t>
             </a:r>
@@ -6181,6 +6515,9 @@
                 <a:solidFill>
                   <a:schemeClr val="tx1"/>
                 </a:solidFill>
+                <a:latin typeface="Poppins" pitchFamily="34" charset="0"/>
+                <a:ea typeface="Poppins" pitchFamily="34" charset="-122"/>
+                <a:cs typeface="Poppins" pitchFamily="34" charset="-120"/>
               </a:rPr>
               <a:t>Three experimental conditions</a:t>
             </a:r>
@@ -6251,6 +6588,9 @@
                 <a:solidFill>
                   <a:srgbClr val="2E8B86"/>
                 </a:solidFill>
+                <a:latin typeface="Poppins" pitchFamily="34" charset="0"/>
+                <a:ea typeface="Poppins" pitchFamily="34" charset="-122"/>
+                <a:cs typeface="Poppins" pitchFamily="34" charset="-120"/>
               </a:rPr>
               <a:t>1</a:t>
             </a:r>
@@ -6287,6 +6627,9 @@
                 <a:solidFill>
                   <a:schemeClr val="tx1"/>
                 </a:solidFill>
+                <a:latin typeface="Poppins" pitchFamily="34" charset="0"/>
+                <a:ea typeface="Poppins" pitchFamily="34" charset="-122"/>
+                <a:cs typeface="Poppins" pitchFamily="34" charset="-120"/>
               </a:rPr>
               <a:t>No AI access</a:t>
             </a:r>
@@ -6381,6 +6724,9 @@
                 <a:solidFill>
                   <a:srgbClr val="BFE6E0"/>
                 </a:solidFill>
+                <a:latin typeface="Poppins" pitchFamily="34" charset="0"/>
+                <a:ea typeface="Poppins" pitchFamily="34" charset="-122"/>
+                <a:cs typeface="Poppins" pitchFamily="34" charset="-120"/>
               </a:rPr>
               <a:t>2</a:t>
             </a:r>
@@ -6417,6 +6763,9 @@
                 <a:solidFill>
                   <a:srgbClr val="FFFFFF"/>
                 </a:solidFill>
+                <a:latin typeface="Poppins" pitchFamily="34" charset="0"/>
+                <a:ea typeface="Poppins" pitchFamily="34" charset="-122"/>
+                <a:cs typeface="Poppins" pitchFamily="34" charset="-120"/>
               </a:rPr>
               <a:t>GPT-4 access</a:t>
             </a:r>
@@ -6511,6 +6860,9 @@
                 <a:solidFill>
                   <a:srgbClr val="BFE6E0"/>
                 </a:solidFill>
+                <a:latin typeface="Poppins" pitchFamily="34" charset="0"/>
+                <a:ea typeface="Poppins" pitchFamily="34" charset="-122"/>
+                <a:cs typeface="Poppins" pitchFamily="34" charset="-120"/>
               </a:rPr>
               <a:t>3</a:t>
             </a:r>
@@ -6547,6 +6899,9 @@
                 <a:solidFill>
                   <a:srgbClr val="FFFFFF"/>
                 </a:solidFill>
+                <a:latin typeface="Poppins" pitchFamily="34" charset="0"/>
+                <a:ea typeface="Poppins" pitchFamily="34" charset="-122"/>
+                <a:cs typeface="Poppins" pitchFamily="34" charset="-120"/>
               </a:rPr>
               <a:t>GPT-4 access with prompt engineering guidance</a:t>
             </a:r>
@@ -6644,6 +6999,9 @@
                 <a:solidFill>
                   <a:schemeClr val="tx2"/>
                 </a:solidFill>
+                <a:latin typeface="Poppins" pitchFamily="34" charset="0"/>
+                <a:ea typeface="Poppins" pitchFamily="34" charset="-122"/>
+                <a:cs typeface="Poppins" pitchFamily="34" charset="-120"/>
               </a:rPr>
               <a:t>CONCEPT</a:t>
             </a:r>
@@ -6680,6 +7038,9 @@
                 <a:solidFill>
                   <a:schemeClr val="tx1"/>
                 </a:solidFill>
+                <a:latin typeface="Poppins" pitchFamily="34" charset="0"/>
+                <a:ea typeface="Poppins" pitchFamily="34" charset="-122"/>
+                <a:cs typeface="Poppins" pitchFamily="34" charset="-120"/>
               </a:rPr>
               <a:t>The "Jagged Technological Frontier"</a:t>
             </a:r>
@@ -6716,6 +7077,9 @@
                 <a:solidFill>
                   <a:schemeClr val="tx2"/>
                 </a:solidFill>
+                <a:latin typeface="Poppins" pitchFamily="34" charset="0"/>
+                <a:ea typeface="Poppins" pitchFamily="34" charset="-122"/>
+                <a:cs typeface="Poppins" pitchFamily="34" charset="-120"/>
               </a:rPr>
               <a:t>AI can perform some tasks well while struggling with other tasks that appear similarly difficult. The boundary is uneven, so workers cannot assume that a task is "safe" for AI just because it looks easy.</a:t>
             </a:r>
@@ -6800,6 +7164,9 @@
                 <a:solidFill>
                   <a:schemeClr val="tx2"/>
                 </a:solidFill>
+                <a:latin typeface="Poppins" pitchFamily="34" charset="0"/>
+                <a:ea typeface="Poppins" pitchFamily="34" charset="-122"/>
+                <a:cs typeface="Poppins" pitchFamily="34" charset="-120"/>
               </a:rPr>
               <a:t>Outside the frontier: AI struggles</a:t>
             </a:r>
@@ -6836,6 +7203,9 @@
                 <a:solidFill>
                   <a:srgbClr val="2E8B86"/>
                 </a:solidFill>
+                <a:latin typeface="Poppins" pitchFamily="34" charset="0"/>
+                <a:ea typeface="Poppins" pitchFamily="34" charset="-122"/>
+                <a:cs typeface="Poppins" pitchFamily="34" charset="-120"/>
               </a:rPr>
               <a:t>Inside the frontier: AI performs well</a:t>
             </a:r>
@@ -6872,6 +7242,9 @@
                 <a:solidFill>
                   <a:schemeClr val="tx2"/>
                 </a:solidFill>
+                <a:latin typeface="Poppins" pitchFamily="34" charset="0"/>
+                <a:ea typeface="Poppins" pitchFamily="34" charset="-122"/>
+                <a:cs typeface="Poppins" pitchFamily="34" charset="-120"/>
               </a:rPr>
               <a:t>Tasks of similar apparent difficulty</a:t>
             </a:r>
@@ -6908,6 +7281,9 @@
                 <a:solidFill>
                   <a:schemeClr val="tx2"/>
                 </a:solidFill>
+                <a:latin typeface="Poppins" pitchFamily="34" charset="0"/>
+                <a:ea typeface="Poppins" pitchFamily="34" charset="-122"/>
+                <a:cs typeface="Poppins" pitchFamily="34" charset="-120"/>
               </a:rPr>
               <a:t>Dell'Acqua, F., McFowland III, E., Mollick, E., Lifshitz-Assaf, H., Kellogg, K. C., Rajendran, S., Krayer, L., Candelon, F., &amp; Lakhani, K. R. (2023). Navigating the Jagged Technological Frontier. Harvard Business School Working Paper 24-013.</a:t>
             </a:r>
@@ -6995,6 +7371,9 @@
                 <a:solidFill>
                   <a:srgbClr val="2E8B86"/>
                 </a:solidFill>
+                <a:latin typeface="Poppins" pitchFamily="34" charset="0"/>
+                <a:ea typeface="Poppins" pitchFamily="34" charset="-122"/>
+                <a:cs typeface="Poppins" pitchFamily="34" charset="-120"/>
               </a:rPr>
               <a:t>Next:  </a:t>
             </a:r>
@@ -7006,6 +7385,9 @@
                 <a:solidFill>
                   <a:srgbClr val="1B2A4A"/>
                 </a:solidFill>
+                <a:latin typeface="Poppins" pitchFamily="34" charset="0"/>
+                <a:ea typeface="Poppins" pitchFamily="34" charset="-122"/>
+                <a:cs typeface="Poppins" pitchFamily="34" charset="-120"/>
               </a:rPr>
               <a:t>So what happened when 758 consultants actually used GPT-4?</a:t>
             </a:r>
@@ -7045,6 +7427,9 @@
                 <a:solidFill>
                   <a:srgbClr val="9AA5B4"/>
                 </a:solidFill>
+                <a:latin typeface="Poppins"/>
+                <a:ea typeface="Poppins"/>
+                <a:cs typeface="Poppins"/>
               </a:defRPr>
             </a:lvl1pPr>
           </a:lstStyle>
@@ -7114,6 +7499,9 @@
                 <a:solidFill>
                   <a:schemeClr val="accent1"/>
                 </a:solidFill>
+                <a:latin typeface="Poppins" pitchFamily="34" charset="0"/>
+                <a:ea typeface="Poppins" pitchFamily="34" charset="-122"/>
+                <a:cs typeface="Poppins" pitchFamily="34" charset="-120"/>
               </a:rPr>
               <a:t>Article 2  |  Key findings</a:t>
             </a:r>
@@ -7154,6 +7542,9 @@
                 <a:solidFill>
                   <a:schemeClr val="tx1"/>
                 </a:solidFill>
+                <a:latin typeface="Poppins" pitchFamily="34" charset="0"/>
+                <a:ea typeface="Poppins" pitchFamily="34" charset="-122"/>
+                <a:cs typeface="Poppins" pitchFamily="34" charset="-120"/>
               </a:rPr>
               <a:t>AI Can Improve Productivity, but Has Limits</a:t>
             </a:r>
@@ -7315,6 +7706,9 @@
                 <a:solidFill>
                   <a:schemeClr val="tx2"/>
                 </a:solidFill>
+                <a:latin typeface="Poppins" pitchFamily="34" charset="0"/>
+                <a:ea typeface="Poppins" pitchFamily="34" charset="-122"/>
+                <a:cs typeface="Poppins" pitchFamily="34" charset="-120"/>
               </a:rPr>
               <a:t>Article 2: Findings</a:t>
             </a:r>
@@ -7378,6 +7772,9 @@
                 <a:solidFill>
                   <a:srgbClr val="FFFFFF"/>
                 </a:solidFill>
+                <a:latin typeface="Poppins" pitchFamily="34" charset="0"/>
+                <a:ea typeface="Poppins" pitchFamily="34" charset="-122"/>
+                <a:cs typeface="Poppins" pitchFamily="34" charset="-120"/>
               </a:rPr>
               <a:t>FINDING (reported in the article)</a:t>
             </a:r>
@@ -7393,7 +7790,7 @@
         </p:nvGraphicFramePr>
         <p:xfrm>
           <a:off x="457200" y="1371600"/>
-          <a:ext cx="4846320" cy="2057400"/>
+          <a:ext cx="4846320" cy="2103120"/>
         </p:xfrm>
         <a:graphic xmlns:a="http://schemas.openxmlformats.org/drawingml/2006/main">
           <a:graphicData uri="http://schemas.openxmlformats.org/drawingml/2006/chart">
@@ -7430,8 +7827,11 @@
                 <a:solidFill>
                   <a:schemeClr val="tx2"/>
                 </a:solidFill>
-              </a:rPr>
-              <a:t>Quality is reported as "more than 40%" higher; the bar is plotted at 40. Performer figures are each group's improvement over its own baseline score.</a:t>
+                <a:latin typeface="Poppins" pitchFamily="34" charset="0"/>
+                <a:ea typeface="Poppins" pitchFamily="34" charset="-122"/>
+                <a:cs typeface="Poppins" pitchFamily="34" charset="-120"/>
+              </a:rPr>
+              <a:t>Quality is reported as "more than 40%" higher than the control group; the bar is plotted at 40. Below-/above-average rows are performer groups, each improving against its own baseline score.</a:t>
             </a:r>
             <a:endParaRPr lang="en-US" sz="750" dirty="0"/>
           </a:p>
@@ -7500,6 +7900,9 @@
                 <a:solidFill>
                   <a:srgbClr val="BFE6E0"/>
                 </a:solidFill>
+                <a:latin typeface="Poppins" pitchFamily="34" charset="0"/>
+                <a:ea typeface="Poppins" pitchFamily="34" charset="-122"/>
+                <a:cs typeface="Poppins" pitchFamily="34" charset="-120"/>
               </a:rPr>
               <a:t>Outside the frontier</a:t>
             </a:r>
@@ -7536,6 +7939,9 @@
                 <a:solidFill>
                   <a:srgbClr val="FFFFFF"/>
                 </a:solidFill>
+                <a:latin typeface="Poppins" pitchFamily="34" charset="0"/>
+                <a:ea typeface="Poppins" pitchFamily="34" charset="-122"/>
+                <a:cs typeface="Poppins" pitchFamily="34" charset="-120"/>
               </a:rPr>
               <a:t>−19</a:t>
             </a:r>
@@ -7552,7 +7958,7 @@
         <p:spPr>
           <a:xfrm>
             <a:off x="5760720" y="1883664"/>
-            <a:ext cx="1828800" cy="201168"/>
+            <a:ext cx="1920240" cy="201168"/>
           </a:xfrm>
           <a:prstGeom prst="rect">
             <a:avLst/>
@@ -7568,14 +7974,17 @@
               <a:buNone/>
             </a:pPr>
             <a:r>
-              <a:rPr lang="en-US" sz="950" dirty="0">
+              <a:rPr lang="en-US" sz="850" dirty="0">
                 <a:solidFill>
                   <a:srgbClr val="BFE6E0"/>
                 </a:solidFill>
+                <a:latin typeface="Poppins" pitchFamily="34" charset="0"/>
+                <a:ea typeface="Poppins" pitchFamily="34" charset="-122"/>
+                <a:cs typeface="Poppins" pitchFamily="34" charset="-120"/>
               </a:rPr>
               <a:t>percentage points</a:t>
             </a:r>
-            <a:endParaRPr lang="en-US" sz="950" dirty="0"/>
+            <a:endParaRPr lang="en-US" sz="850" dirty="0"/>
           </a:p>
         </p:txBody>
       </p:sp>
@@ -7632,6 +8041,9 @@
                 <a:solidFill>
                   <a:srgbClr val="FFFFFF"/>
                 </a:solidFill>
+                <a:latin typeface="Poppins" pitchFamily="34" charset="0"/>
+                <a:ea typeface="Poppins" pitchFamily="34" charset="-122"/>
+                <a:cs typeface="Poppins" pitchFamily="34" charset="-120"/>
               </a:rPr>
               <a:t>For a task selected to be outside the frontier, AI users were 19 percentage points less likely to produce correct solutions than consultants without AI.</a:t>
             </a:r>
@@ -7695,6 +8107,9 @@
                 <a:solidFill>
                   <a:schemeClr val="tx2"/>
                 </a:solidFill>
+                <a:latin typeface="Poppins" pitchFamily="34" charset="0"/>
+                <a:ea typeface="Poppins" pitchFamily="34" charset="-122"/>
+                <a:cs typeface="Poppins" pitchFamily="34" charset="-120"/>
               </a:rPr>
               <a:t>Percentage change (e.g. +12.2%) compares to a baseline. Percentage points (−19) is the gap between two success rates.</a:t>
             </a:r>
@@ -7731,6 +8146,9 @@
                 <a:solidFill>
                   <a:schemeClr val="tx1"/>
                 </a:solidFill>
+                <a:latin typeface="Poppins" pitchFamily="34" charset="0"/>
+                <a:ea typeface="Poppins" pitchFamily="34" charset="-122"/>
+                <a:cs typeface="Poppins" pitchFamily="34" charset="-120"/>
               </a:rPr>
               <a:t>Two successful patterns of AI use</a:t>
             </a:r>
@@ -7818,6 +8236,9 @@
                 <a:solidFill>
                   <a:schemeClr val="tx1"/>
                 </a:solidFill>
+                <a:latin typeface="Poppins" pitchFamily="34" charset="0"/>
+                <a:ea typeface="Poppins" pitchFamily="34" charset="-122"/>
+                <a:cs typeface="Poppins" pitchFamily="34" charset="-120"/>
               </a:rPr>
               <a:t>Centaurs  </a:t>
             </a:r>
@@ -7829,6 +8250,9 @@
                 <a:solidFill>
                   <a:schemeClr val="tx2"/>
                 </a:solidFill>
+                <a:latin typeface="Poppins" pitchFamily="34" charset="0"/>
+                <a:ea typeface="Poppins" pitchFamily="34" charset="-122"/>
+                <a:cs typeface="Poppins" pitchFamily="34" charset="-120"/>
               </a:rPr>
               <a:t>Divide tasks between humans and AI, delegating sub-tasks to whichever is better suited.</a:t>
             </a:r>
@@ -7916,6 +8340,9 @@
                 <a:solidFill>
                   <a:schemeClr val="tx1"/>
                 </a:solidFill>
+                <a:latin typeface="Poppins" pitchFamily="34" charset="0"/>
+                <a:ea typeface="Poppins" pitchFamily="34" charset="-122"/>
+                <a:cs typeface="Poppins" pitchFamily="34" charset="-120"/>
               </a:rPr>
               <a:t>Cyborgs  </a:t>
             </a:r>
@@ -7927,6 +8354,9 @@
                 <a:solidFill>
                   <a:schemeClr val="tx2"/>
                 </a:solidFill>
+                <a:latin typeface="Poppins" pitchFamily="34" charset="0"/>
+                <a:ea typeface="Poppins" pitchFamily="34" charset="-122"/>
+                <a:cs typeface="Poppins" pitchFamily="34" charset="-120"/>
               </a:rPr>
               <a:t>Integrate AI continuously into the workflow, moving back and forth with the tool.</a:t>
             </a:r>
@@ -7963,6 +8393,9 @@
                 <a:solidFill>
                   <a:schemeClr val="tx2"/>
                 </a:solidFill>
+                <a:latin typeface="Poppins" pitchFamily="34" charset="0"/>
+                <a:ea typeface="Poppins" pitchFamily="34" charset="-122"/>
+                <a:cs typeface="Poppins" pitchFamily="34" charset="-120"/>
               </a:rPr>
               <a:t>Dell'Acqua, F., McFowland III, E., Mollick, E., Lifshitz-Assaf, H., Kellogg, K. C., Rajendran, S., Krayer, L., Candelon, F., &amp; Lakhani, K. R. (2023). Navigating the Jagged Technological Frontier. Harvard Business School Working Paper 24-013.</a:t>
             </a:r>
@@ -8050,6 +8483,9 @@
                 <a:solidFill>
                   <a:srgbClr val="2E8B86"/>
                 </a:solidFill>
+                <a:latin typeface="Poppins" pitchFamily="34" charset="0"/>
+                <a:ea typeface="Poppins" pitchFamily="34" charset="-122"/>
+                <a:cs typeface="Poppins" pitchFamily="34" charset="-120"/>
               </a:rPr>
               <a:t>Next:  </a:t>
             </a:r>
@@ -8061,6 +8497,9 @@
                 <a:solidFill>
                   <a:srgbClr val="1B2A4A"/>
                 </a:solidFill>
+                <a:latin typeface="Poppins" pitchFamily="34" charset="0"/>
+                <a:ea typeface="Poppins" pitchFamily="34" charset="-122"/>
+                <a:cs typeface="Poppins" pitchFamily="34" charset="-120"/>
               </a:rPr>
               <a:t>Does this hold outside the office, for real small businesses?</a:t>
             </a:r>
@@ -8100,6 +8539,9 @@
                 <a:solidFill>
                   <a:srgbClr val="9AA5B4"/>
                 </a:solidFill>
+                <a:latin typeface="Poppins"/>
+                <a:ea typeface="Poppins"/>
+                <a:cs typeface="Poppins"/>
               </a:defRPr>
             </a:lvl1pPr>
           </a:lstStyle>
@@ -8169,6 +8611,9 @@
                 <a:solidFill>
                   <a:schemeClr val="accent1"/>
                 </a:solidFill>
+                <a:latin typeface="Poppins" pitchFamily="34" charset="0"/>
+                <a:ea typeface="Poppins" pitchFamily="34" charset="-122"/>
+                <a:cs typeface="Poppins" pitchFamily="34" charset="-120"/>
               </a:rPr>
               <a:t>Article 5  |  Research purpose and findings</a:t>
             </a:r>
@@ -8209,6 +8654,9 @@
                 <a:solidFill>
                   <a:schemeClr val="tx1"/>
                 </a:solidFill>
+                <a:latin typeface="Poppins" pitchFamily="34" charset="0"/>
+                <a:ea typeface="Poppins" pitchFamily="34" charset="-122"/>
+                <a:cs typeface="Poppins" pitchFamily="34" charset="-120"/>
               </a:rPr>
               <a:t>The Uneven Impact of Generative AI on Entrepreneurial Performance</a:t>
             </a:r>
@@ -8370,6 +8818,9 @@
                 <a:solidFill>
                   <a:schemeClr val="tx2"/>
                 </a:solidFill>
+                <a:latin typeface="Poppins" pitchFamily="34" charset="0"/>
+                <a:ea typeface="Poppins" pitchFamily="34" charset="-122"/>
+                <a:cs typeface="Poppins" pitchFamily="34" charset="-120"/>
               </a:rPr>
               <a:t>Article 5: Entrepreneurs</a:t>
             </a:r>
@@ -8406,6 +8857,9 @@
                 <a:solidFill>
                   <a:schemeClr val="tx2"/>
                 </a:solidFill>
+                <a:latin typeface="Poppins" pitchFamily="34" charset="0"/>
+                <a:ea typeface="Poppins" pitchFamily="34" charset="-122"/>
+                <a:cs typeface="Poppins" pitchFamily="34" charset="-120"/>
               </a:rPr>
               <a:t>Nicholas G. Otis et al.  |  Management Science, Vol. 72, No. 7, 2026  |  DOI 10.1287/mnsc.2024.06909</a:t>
             </a:r>
@@ -8491,6 +8945,9 @@
                 <a:solidFill>
                   <a:schemeClr val="tx1"/>
                 </a:solidFill>
+                <a:latin typeface="Poppins" pitchFamily="34" charset="0"/>
+                <a:ea typeface="Poppins" pitchFamily="34" charset="-122"/>
+                <a:cs typeface="Poppins" pitchFamily="34" charset="-120"/>
               </a:rPr>
               <a:t>Setting</a:t>
             </a:r>
@@ -8505,6 +8962,9 @@
                 <a:solidFill>
                   <a:schemeClr val="tx2"/>
                 </a:solidFill>
+                <a:latin typeface="Poppins" pitchFamily="34" charset="0"/>
+                <a:ea typeface="Poppins" pitchFamily="34" charset="-122"/>
+                <a:cs typeface="Poppins" pitchFamily="34" charset="-120"/>
               </a:rPr>
               <a:t>Field experiment with small-business entrepreneurs in Kenya</a:t>
             </a:r>
@@ -8590,6 +9050,9 @@
                 <a:solidFill>
                   <a:schemeClr val="tx1"/>
                 </a:solidFill>
+                <a:latin typeface="Poppins" pitchFamily="34" charset="0"/>
+                <a:ea typeface="Poppins" pitchFamily="34" charset="-122"/>
+                <a:cs typeface="Poppins" pitchFamily="34" charset="-120"/>
               </a:rPr>
               <a:t>Intervention</a:t>
             </a:r>
@@ -8604,6 +9067,9 @@
                 <a:solidFill>
                   <a:schemeClr val="tx2"/>
                 </a:solidFill>
+                <a:latin typeface="Poppins" pitchFamily="34" charset="0"/>
+                <a:ea typeface="Poppins" pitchFamily="34" charset="-122"/>
+                <a:cs typeface="Poppins" pitchFamily="34" charset="-120"/>
               </a:rPr>
               <a:t>Access to a GPT-4-powered AI business assistant that gave business advice</a:t>
             </a:r>
@@ -8689,6 +9155,9 @@
                 <a:solidFill>
                   <a:schemeClr val="tx1"/>
                 </a:solidFill>
+                <a:latin typeface="Poppins" pitchFamily="34" charset="0"/>
+                <a:ea typeface="Poppins" pitchFamily="34" charset="-122"/>
+                <a:cs typeface="Poppins" pitchFamily="34" charset="-120"/>
               </a:rPr>
               <a:t>Outcomes examined</a:t>
             </a:r>
@@ -8703,6 +9172,9 @@
                 <a:solidFill>
                   <a:schemeClr val="tx2"/>
                 </a:solidFill>
+                <a:latin typeface="Poppins" pitchFamily="34" charset="0"/>
+                <a:ea typeface="Poppins" pitchFamily="34" charset="-122"/>
+                <a:cs typeface="Poppins" pitchFamily="34" charset="-120"/>
               </a:rPr>
               <a:t>Small-business revenue and profit</a:t>
             </a:r>
@@ -8800,6 +9272,9 @@
                 <a:solidFill>
                   <a:srgbClr val="FFFFFF"/>
                 </a:solidFill>
+                <a:latin typeface="Poppins" pitchFamily="34" charset="0"/>
+                <a:ea typeface="Poppins" pitchFamily="34" charset="-122"/>
+                <a:cs typeface="Poppins" pitchFamily="34" charset="-120"/>
               </a:rPr>
               <a:t>FINDING (reported in the article)</a:t>
             </a:r>
@@ -8836,6 +9311,9 @@
                 <a:solidFill>
                   <a:srgbClr val="BFE6E0"/>
                 </a:solidFill>
+                <a:latin typeface="Poppins" pitchFamily="34" charset="0"/>
+                <a:ea typeface="Poppins" pitchFamily="34" charset="-122"/>
+                <a:cs typeface="Poppins" pitchFamily="34" charset="-120"/>
               </a:rPr>
               <a:t>Average effect</a:t>
             </a:r>
@@ -8872,6 +9350,9 @@
                 <a:solidFill>
                   <a:srgbClr val="FFFFFF"/>
                 </a:solidFill>
+                <a:latin typeface="Poppins" pitchFamily="34" charset="0"/>
+                <a:ea typeface="Poppins" pitchFamily="34" charset="-122"/>
+                <a:cs typeface="Poppins" pitchFamily="34" charset="-120"/>
               </a:rPr>
               <a:t>The researchers could not reject the null hypothesis of no average treatment effect on revenue and profits.</a:t>
             </a:r>
@@ -8993,6 +9474,9 @@
                 <a:solidFill>
                   <a:srgbClr val="FFFFFF"/>
                 </a:solidFill>
+                <a:latin typeface="Poppins" pitchFamily="34" charset="0"/>
+                <a:ea typeface="Poppins" pitchFamily="34" charset="-122"/>
+                <a:cs typeface="Poppins" pitchFamily="34" charset="-120"/>
               </a:rPr>
               <a:t>FINDING (reported in the article)</a:t>
             </a:r>
@@ -9029,6 +9513,9 @@
                 <a:solidFill>
                   <a:schemeClr val="tx1"/>
                 </a:solidFill>
+                <a:latin typeface="Poppins" pitchFamily="34" charset="0"/>
+                <a:ea typeface="Poppins" pitchFamily="34" charset="-122"/>
+                <a:cs typeface="Poppins" pitchFamily="34" charset="-120"/>
               </a:rPr>
               <a:t>Subgroup results by baseline performance</a:t>
             </a:r>
@@ -9108,10 +9595,13 @@
               <a:buNone/>
             </a:pPr>
             <a:r>
-              <a:rPr lang="en-US" sz="900" b="1" dirty="0">
+              <a:rPr lang="en-US" sz="850" b="1" dirty="0">
                 <a:solidFill>
                   <a:schemeClr val="tx1"/>
                 </a:solidFill>
+                <a:latin typeface="Poppins" pitchFamily="34" charset="0"/>
+                <a:ea typeface="Poppins" pitchFamily="34" charset="-122"/>
+                <a:cs typeface="Poppins" pitchFamily="34" charset="-120"/>
               </a:rPr>
               <a:t>Low performers at baseline  </a:t>
             </a:r>
@@ -9119,14 +9609,17 @@
               <a:buNone/>
             </a:pPr>
             <a:r>
-              <a:rPr lang="en-US" sz="900" b="1" dirty="0">
+              <a:rPr lang="en-US" sz="850" b="1" dirty="0">
                 <a:solidFill>
                   <a:srgbClr val="5A6472"/>
                 </a:solidFill>
+                <a:latin typeface="Poppins" pitchFamily="34" charset="0"/>
+                <a:ea typeface="Poppins" pitchFamily="34" charset="-122"/>
+                <a:cs typeface="Poppins" pitchFamily="34" charset="-120"/>
               </a:rPr>
               <a:t>nearly 10% worse</a:t>
             </a:r>
-            <a:endParaRPr lang="en-US" sz="900" dirty="0"/>
+            <a:endParaRPr lang="en-US" sz="850" dirty="0"/>
           </a:p>
         </p:txBody>
       </p:sp>
@@ -9180,10 +9673,13 @@
               <a:buNone/>
             </a:pPr>
             <a:r>
-              <a:rPr lang="en-US" sz="900" b="1" dirty="0">
+              <a:rPr lang="en-US" sz="850" b="1" dirty="0">
                 <a:solidFill>
                   <a:schemeClr val="tx1"/>
                 </a:solidFill>
+                <a:latin typeface="Poppins" pitchFamily="34" charset="0"/>
+                <a:ea typeface="Poppins" pitchFamily="34" charset="-122"/>
+                <a:cs typeface="Poppins" pitchFamily="34" charset="-120"/>
               </a:rPr>
               <a:t>High performers at baseline  </a:t>
             </a:r>
@@ -9191,14 +9687,17 @@
               <a:buNone/>
             </a:pPr>
             <a:r>
-              <a:rPr lang="en-US" sz="900" b="1" dirty="0">
+              <a:rPr lang="en-US" sz="850" b="1" dirty="0">
                 <a:solidFill>
                   <a:srgbClr val="2E8B86"/>
                 </a:solidFill>
+                <a:latin typeface="Poppins" pitchFamily="34" charset="0"/>
+                <a:ea typeface="Poppins" pitchFamily="34" charset="-122"/>
+                <a:cs typeface="Poppins" pitchFamily="34" charset="-120"/>
               </a:rPr>
               <a:t>may have benefited by more than 15%</a:t>
             </a:r>
-            <a:endParaRPr lang="en-US" sz="900" dirty="0"/>
+            <a:endParaRPr lang="en-US" sz="850" dirty="0"/>
           </a:p>
         </p:txBody>
       </p:sp>
@@ -9256,6 +9755,9 @@
                 <a:solidFill>
                   <a:schemeClr val="tx2"/>
                 </a:solidFill>
+                <a:latin typeface="Poppins" pitchFamily="34" charset="0"/>
+                <a:ea typeface="Poppins" pitchFamily="34" charset="-122"/>
+                <a:cs typeface="Poppins" pitchFamily="34" charset="-120"/>
               </a:rPr>
               <a:t>Bar lengths are illustrative of the reported figures</a:t>
             </a:r>
@@ -9319,6 +9821,9 @@
                 <a:solidFill>
                   <a:schemeClr val="tx1"/>
                 </a:solidFill>
+                <a:latin typeface="Poppins" pitchFamily="34" charset="0"/>
+                <a:ea typeface="Poppins" pitchFamily="34" charset="-122"/>
+                <a:cs typeface="Poppins" pitchFamily="34" charset="-120"/>
               </a:rPr>
               <a:t>The difference did not appear to result from differences in the questions asked or the AI advice given, but from the advice entrepreneurs chose to implement.</a:t>
             </a:r>
@@ -9406,6 +9911,9 @@
                 <a:solidFill>
                   <a:schemeClr val="tx2"/>
                 </a:solidFill>
+                <a:latin typeface="Poppins" pitchFamily="34" charset="0"/>
+                <a:ea typeface="Poppins" pitchFamily="34" charset="-122"/>
+                <a:cs typeface="Poppins" pitchFamily="34" charset="-120"/>
               </a:rPr>
               <a:t>Caution: these are subgroup averages. They do not show that every high-performing entrepreneur benefits or that every low-performing entrepreneur loses.</a:t>
             </a:r>
@@ -9442,6 +9950,9 @@
                 <a:solidFill>
                   <a:schemeClr val="tx2"/>
                 </a:solidFill>
+                <a:latin typeface="Poppins" pitchFamily="34" charset="0"/>
+                <a:ea typeface="Poppins" pitchFamily="34" charset="-122"/>
+                <a:cs typeface="Poppins" pitchFamily="34" charset="-120"/>
               </a:rPr>
               <a:t>Otis, N. G., Clarke, R., Delecourt, S., Holtz, D., &amp; Koning, R. (2026). The Uneven Impact of Generative Artificial Intelligence on Entrepreneurial Performance: Evidence from a Field Experiment in Kenya. Management Science, 72(7). https://doi.org/10.1287/mnsc.2024.06909</a:t>
             </a:r>
@@ -9529,6 +10040,9 @@
                 <a:solidFill>
                   <a:srgbClr val="2E8B86"/>
                 </a:solidFill>
+                <a:latin typeface="Poppins" pitchFamily="34" charset="0"/>
+                <a:ea typeface="Poppins" pitchFamily="34" charset="-122"/>
+                <a:cs typeface="Poppins" pitchFamily="34" charset="-120"/>
               </a:rPr>
               <a:t>Next:  </a:t>
             </a:r>
@@ -9540,6 +10054,9 @@
                 <a:solidFill>
                   <a:srgbClr val="1B2A4A"/>
                 </a:solidFill>
+                <a:latin typeface="Poppins" pitchFamily="34" charset="0"/>
+                <a:ea typeface="Poppins" pitchFamily="34" charset="-122"/>
+                <a:cs typeface="Poppins" pitchFamily="34" charset="-120"/>
               </a:rPr>
               <a:t>Two studies, one lesson: what do they tell us together?</a:t>
             </a:r>
@@ -9579,6 +10096,9 @@
                 <a:solidFill>
                   <a:srgbClr val="9AA5B4"/>
                 </a:solidFill>
+                <a:latin typeface="Poppins"/>
+                <a:ea typeface="Poppins"/>
+                <a:cs typeface="Poppins"/>
               </a:defRPr>
             </a:lvl1pPr>
           </a:lstStyle>
@@ -9648,6 +10168,9 @@
                 <a:solidFill>
                   <a:schemeClr val="accent1"/>
                 </a:solidFill>
+                <a:latin typeface="Poppins" pitchFamily="34" charset="0"/>
+                <a:ea typeface="Poppins" pitchFamily="34" charset="-122"/>
+                <a:cs typeface="Poppins" pitchFamily="34" charset="-120"/>
               </a:rPr>
               <a:t>Discussion and comparison</a:t>
             </a:r>
@@ -9688,6 +10211,9 @@
                 <a:solidFill>
                   <a:schemeClr val="tx1"/>
                 </a:solidFill>
+                <a:latin typeface="Poppins" pitchFamily="34" charset="0"/>
+                <a:ea typeface="Poppins" pitchFamily="34" charset="-122"/>
+                <a:cs typeface="Poppins" pitchFamily="34" charset="-120"/>
               </a:rPr>
               <a:t>AI Is a Tool, Not a Guarantee of Success</a:t>
             </a:r>
@@ -9849,6 +10375,9 @@
                 <a:solidFill>
                   <a:schemeClr val="tx2"/>
                 </a:solidFill>
+                <a:latin typeface="Poppins" pitchFamily="34" charset="0"/>
+                <a:ea typeface="Poppins" pitchFamily="34" charset="-122"/>
+                <a:cs typeface="Poppins" pitchFamily="34" charset="-120"/>
               </a:rPr>
               <a:t>Discussion</a:t>
             </a:r>
@@ -9912,6 +10441,9 @@
                 <a:solidFill>
                   <a:srgbClr val="FFFFFF"/>
                 </a:solidFill>
+                <a:latin typeface="Poppins" pitchFamily="34" charset="0"/>
+                <a:ea typeface="Poppins" pitchFamily="34" charset="-122"/>
+                <a:cs typeface="Poppins" pitchFamily="34" charset="-120"/>
               </a:rPr>
               <a:t>FINDING (reported in the article)</a:t>
             </a:r>
@@ -9956,9 +10488,9 @@
                         <a:buNone/>
                       </a:pPr>
                       <a:endParaRPr lang="en-US" sz="950" dirty="0">
-                        <a:latin typeface="Tahoma" charset="0"/>
-                        <a:ea typeface="Tahoma" charset="0"/>
-                        <a:cs typeface="Tahoma" charset="0"/>
+                        <a:latin typeface="Poppins" charset="0"/>
+                        <a:ea typeface="Poppins" charset="0"/>
+                        <a:cs typeface="Poppins" charset="0"/>
                       </a:endParaRPr>
                     </a:p>
                   </a:txBody>
@@ -10017,16 +10549,16 @@
                           <a:solidFill>
                             <a:srgbClr val="FFFFFF"/>
                           </a:solidFill>
-                          <a:latin typeface="Tahoma" pitchFamily="34" charset="0"/>
-                          <a:ea typeface="Tahoma" pitchFamily="34" charset="-122"/>
-                          <a:cs typeface="Tahoma" pitchFamily="34" charset="-120"/>
+                          <a:latin typeface="Poppins" pitchFamily="34" charset="0"/>
+                          <a:ea typeface="Poppins" pitchFamily="34" charset="-122"/>
+                          <a:cs typeface="Poppins" pitchFamily="34" charset="-120"/>
                         </a:rPr>
                         <a:t>Article 2  |  Dell'Acqua et al. (2023)</a:t>
                       </a:r>
                       <a:endParaRPr lang="en-US" sz="950" dirty="0">
-                        <a:latin typeface="Tahoma" charset="0"/>
-                        <a:ea typeface="Tahoma" charset="0"/>
-                        <a:cs typeface="Tahoma" charset="0"/>
+                        <a:latin typeface="Poppins" charset="0"/>
+                        <a:ea typeface="Poppins" charset="0"/>
+                        <a:cs typeface="Poppins" charset="0"/>
                       </a:endParaRPr>
                     </a:p>
                   </a:txBody>
@@ -10085,16 +10617,16 @@
                           <a:solidFill>
                             <a:srgbClr val="FFFFFF"/>
                           </a:solidFill>
-                          <a:latin typeface="Tahoma" pitchFamily="34" charset="0"/>
-                          <a:ea typeface="Tahoma" pitchFamily="34" charset="-122"/>
-                          <a:cs typeface="Tahoma" pitchFamily="34" charset="-120"/>
+                          <a:latin typeface="Poppins" pitchFamily="34" charset="0"/>
+                          <a:ea typeface="Poppins" pitchFamily="34" charset="-122"/>
+                          <a:cs typeface="Poppins" pitchFamily="34" charset="-120"/>
                         </a:rPr>
                         <a:t>Article 5  |  Otis et al. (2026)</a:t>
                       </a:r>
                       <a:endParaRPr lang="en-US" sz="950" dirty="0">
-                        <a:latin typeface="Tahoma" charset="0"/>
-                        <a:ea typeface="Tahoma" charset="0"/>
-                        <a:cs typeface="Tahoma" charset="0"/>
+                        <a:latin typeface="Poppins" charset="0"/>
+                        <a:ea typeface="Poppins" charset="0"/>
+                        <a:cs typeface="Poppins" charset="0"/>
                       </a:endParaRPr>
                     </a:p>
                   </a:txBody>
@@ -10155,16 +10687,16 @@
                           <a:solidFill>
                             <a:srgbClr val="1B2A4A"/>
                           </a:solidFill>
-                          <a:latin typeface="Tahoma" pitchFamily="34" charset="0"/>
-                          <a:ea typeface="Tahoma" pitchFamily="34" charset="-122"/>
-                          <a:cs typeface="Tahoma" pitchFamily="34" charset="-120"/>
+                          <a:latin typeface="Poppins" pitchFamily="34" charset="0"/>
+                          <a:ea typeface="Poppins" pitchFamily="34" charset="-122"/>
+                          <a:cs typeface="Poppins" pitchFamily="34" charset="-120"/>
                         </a:rPr>
                         <a:t>Focus</a:t>
                       </a:r>
                       <a:endParaRPr lang="en-US" sz="950" dirty="0">
-                        <a:latin typeface="Tahoma" charset="0"/>
-                        <a:ea typeface="Tahoma" charset="0"/>
-                        <a:cs typeface="Tahoma" charset="0"/>
+                        <a:latin typeface="Poppins" charset="0"/>
+                        <a:ea typeface="Poppins" charset="0"/>
+                        <a:cs typeface="Poppins" charset="0"/>
                       </a:endParaRPr>
                     </a:p>
                   </a:txBody>
@@ -10223,16 +10755,16 @@
                           <a:solidFill>
                             <a:srgbClr val="5A6472"/>
                           </a:solidFill>
-                          <a:latin typeface="Tahoma" pitchFamily="34" charset="0"/>
-                          <a:ea typeface="Tahoma" pitchFamily="34" charset="-122"/>
-                          <a:cs typeface="Tahoma" pitchFamily="34" charset="-120"/>
+                          <a:latin typeface="Poppins" pitchFamily="34" charset="0"/>
+                          <a:ea typeface="Poppins" pitchFamily="34" charset="-122"/>
+                          <a:cs typeface="Poppins" pitchFamily="34" charset="-120"/>
                         </a:rPr>
                         <a:t>Knowledge workers and consultants (BCG)</a:t>
                       </a:r>
                       <a:endParaRPr lang="en-US" sz="950" dirty="0">
-                        <a:latin typeface="Tahoma" charset="0"/>
-                        <a:ea typeface="Tahoma" charset="0"/>
-                        <a:cs typeface="Tahoma" charset="0"/>
+                        <a:latin typeface="Poppins" charset="0"/>
+                        <a:ea typeface="Poppins" charset="0"/>
+                        <a:cs typeface="Poppins" charset="0"/>
                       </a:endParaRPr>
                     </a:p>
                   </a:txBody>
@@ -10291,16 +10823,16 @@
                           <a:solidFill>
                             <a:srgbClr val="5A6472"/>
                           </a:solidFill>
-                          <a:latin typeface="Tahoma" pitchFamily="34" charset="0"/>
-                          <a:ea typeface="Tahoma" pitchFamily="34" charset="-122"/>
-                          <a:cs typeface="Tahoma" pitchFamily="34" charset="-120"/>
+                          <a:latin typeface="Poppins" pitchFamily="34" charset="0"/>
+                          <a:ea typeface="Poppins" pitchFamily="34" charset="-122"/>
+                          <a:cs typeface="Poppins" pitchFamily="34" charset="-120"/>
                         </a:rPr>
                         <a:t>Entrepreneurs in Kenya</a:t>
                       </a:r>
                       <a:endParaRPr lang="en-US" sz="950" dirty="0">
-                        <a:latin typeface="Tahoma" charset="0"/>
-                        <a:ea typeface="Tahoma" charset="0"/>
-                        <a:cs typeface="Tahoma" charset="0"/>
+                        <a:latin typeface="Poppins" charset="0"/>
+                        <a:ea typeface="Poppins" charset="0"/>
+                        <a:cs typeface="Poppins" charset="0"/>
                       </a:endParaRPr>
                     </a:p>
                   </a:txBody>
@@ -10361,16 +10893,16 @@
                           <a:solidFill>
                             <a:srgbClr val="1B2A4A"/>
                           </a:solidFill>
-                          <a:latin typeface="Tahoma" pitchFamily="34" charset="0"/>
-                          <a:ea typeface="Tahoma" pitchFamily="34" charset="-122"/>
-                          <a:cs typeface="Tahoma" pitchFamily="34" charset="-120"/>
+                          <a:latin typeface="Poppins" pitchFamily="34" charset="0"/>
+                          <a:ea typeface="Poppins" pitchFamily="34" charset="-122"/>
+                          <a:cs typeface="Poppins" pitchFamily="34" charset="-120"/>
                         </a:rPr>
                         <a:t>Main result</a:t>
                       </a:r>
                       <a:endParaRPr lang="en-US" sz="950" dirty="0">
-                        <a:latin typeface="Tahoma" charset="0"/>
-                        <a:ea typeface="Tahoma" charset="0"/>
-                        <a:cs typeface="Tahoma" charset="0"/>
+                        <a:latin typeface="Poppins" charset="0"/>
+                        <a:ea typeface="Poppins" charset="0"/>
+                        <a:cs typeface="Poppins" charset="0"/>
                       </a:endParaRPr>
                     </a:p>
                   </a:txBody>
@@ -10429,16 +10961,16 @@
                           <a:solidFill>
                             <a:srgbClr val="5A6472"/>
                           </a:solidFill>
-                          <a:latin typeface="Tahoma" pitchFamily="34" charset="0"/>
-                          <a:ea typeface="Tahoma" pitchFamily="34" charset="-122"/>
-                          <a:cs typeface="Tahoma" pitchFamily="34" charset="-120"/>
+                          <a:latin typeface="Poppins" pitchFamily="34" charset="0"/>
+                          <a:ea typeface="Poppins" pitchFamily="34" charset="-122"/>
+                          <a:cs typeface="Poppins" pitchFamily="34" charset="-120"/>
                         </a:rPr>
                         <a:t>Higher productivity and work quality for tasks within AI's capability frontier</a:t>
                       </a:r>
                       <a:endParaRPr lang="en-US" sz="950" dirty="0">
-                        <a:latin typeface="Tahoma" charset="0"/>
-                        <a:ea typeface="Tahoma" charset="0"/>
-                        <a:cs typeface="Tahoma" charset="0"/>
+                        <a:latin typeface="Poppins" charset="0"/>
+                        <a:ea typeface="Poppins" charset="0"/>
+                        <a:cs typeface="Poppins" charset="0"/>
                       </a:endParaRPr>
                     </a:p>
                   </a:txBody>
@@ -10497,16 +11029,16 @@
                           <a:solidFill>
                             <a:srgbClr val="5A6472"/>
                           </a:solidFill>
-                          <a:latin typeface="Tahoma" pitchFamily="34" charset="0"/>
-                          <a:ea typeface="Tahoma" pitchFamily="34" charset="-122"/>
-                          <a:cs typeface="Tahoma" pitchFamily="34" charset="-120"/>
+                          <a:latin typeface="Poppins" pitchFamily="34" charset="0"/>
+                          <a:ea typeface="Poppins" pitchFamily="34" charset="-122"/>
+                          <a:cs typeface="Poppins" pitchFamily="34" charset="-120"/>
                         </a:rPr>
                         <a:t>No established average treatment effect on revenue and profits</a:t>
                       </a:r>
                       <a:endParaRPr lang="en-US" sz="950" dirty="0">
-                        <a:latin typeface="Tahoma" charset="0"/>
-                        <a:ea typeface="Tahoma" charset="0"/>
-                        <a:cs typeface="Tahoma" charset="0"/>
+                        <a:latin typeface="Poppins" charset="0"/>
+                        <a:ea typeface="Poppins" charset="0"/>
+                        <a:cs typeface="Poppins" charset="0"/>
                       </a:endParaRPr>
                     </a:p>
                   </a:txBody>
@@ -10567,16 +11099,16 @@
                           <a:solidFill>
                             <a:srgbClr val="1B2A4A"/>
                           </a:solidFill>
-                          <a:latin typeface="Tahoma" pitchFamily="34" charset="0"/>
-                          <a:ea typeface="Tahoma" pitchFamily="34" charset="-122"/>
-                          <a:cs typeface="Tahoma" pitchFamily="34" charset="-120"/>
+                          <a:latin typeface="Poppins" pitchFamily="34" charset="0"/>
+                          <a:ea typeface="Poppins" pitchFamily="34" charset="-122"/>
+                          <a:cs typeface="Poppins" pitchFamily="34" charset="-120"/>
                         </a:rPr>
                         <a:t>Key limitation or insight</a:t>
                       </a:r>
                       <a:endParaRPr lang="en-US" sz="950" dirty="0">
-                        <a:latin typeface="Tahoma" charset="0"/>
-                        <a:ea typeface="Tahoma" charset="0"/>
-                        <a:cs typeface="Tahoma" charset="0"/>
+                        <a:latin typeface="Poppins" charset="0"/>
+                        <a:ea typeface="Poppins" charset="0"/>
+                        <a:cs typeface="Poppins" charset="0"/>
                       </a:endParaRPr>
                     </a:p>
                   </a:txBody>
@@ -10635,16 +11167,16 @@
                           <a:solidFill>
                             <a:srgbClr val="5A6472"/>
                           </a:solidFill>
-                          <a:latin typeface="Tahoma" pitchFamily="34" charset="0"/>
-                          <a:ea typeface="Tahoma" pitchFamily="34" charset="-122"/>
-                          <a:cs typeface="Tahoma" pitchFamily="34" charset="-120"/>
+                          <a:latin typeface="Poppins" pitchFamily="34" charset="0"/>
+                          <a:ea typeface="Poppins" pitchFamily="34" charset="-122"/>
+                          <a:cs typeface="Poppins" pitchFamily="34" charset="-120"/>
                         </a:rPr>
                         <a:t>Reduced correctness on a task outside that frontier</a:t>
                       </a:r>
                       <a:endParaRPr lang="en-US" sz="950" dirty="0">
-                        <a:latin typeface="Tahoma" charset="0"/>
-                        <a:ea typeface="Tahoma" charset="0"/>
-                        <a:cs typeface="Tahoma" charset="0"/>
+                        <a:latin typeface="Poppins" charset="0"/>
+                        <a:ea typeface="Poppins" charset="0"/>
+                        <a:cs typeface="Poppins" charset="0"/>
                       </a:endParaRPr>
                     </a:p>
                   </a:txBody>
@@ -10703,16 +11235,16 @@
                           <a:solidFill>
                             <a:srgbClr val="5A6472"/>
                           </a:solidFill>
-                          <a:latin typeface="Tahoma" pitchFamily="34" charset="0"/>
-                          <a:ea typeface="Tahoma" pitchFamily="34" charset="-122"/>
-                          <a:cs typeface="Tahoma" pitchFamily="34" charset="-120"/>
+                          <a:latin typeface="Poppins" pitchFamily="34" charset="0"/>
+                          <a:ea typeface="Poppins" pitchFamily="34" charset="-122"/>
+                          <a:cs typeface="Poppins" pitchFamily="34" charset="-120"/>
                         </a:rPr>
                         <a:t>Outcomes differed by baseline performance and by which AI recommendations were implemented</a:t>
                       </a:r>
                       <a:endParaRPr lang="en-US" sz="950" dirty="0">
-                        <a:latin typeface="Tahoma" charset="0"/>
-                        <a:ea typeface="Tahoma" charset="0"/>
-                        <a:cs typeface="Tahoma" charset="0"/>
+                        <a:latin typeface="Poppins" charset="0"/>
+                        <a:ea typeface="Poppins" charset="0"/>
+                        <a:cs typeface="Poppins" charset="0"/>
                       </a:endParaRPr>
                     </a:p>
                   </a:txBody>
@@ -10853,6 +11385,9 @@
                 <a:solidFill>
                   <a:schemeClr val="tx2"/>
                 </a:solidFill>
+                <a:latin typeface="Poppins" pitchFamily="34" charset="0"/>
+                <a:ea typeface="Poppins" pitchFamily="34" charset="-122"/>
+                <a:cs typeface="Poppins" pitchFamily="34" charset="-120"/>
               </a:rPr>
               <a:t>INTERPRETATION</a:t>
             </a:r>
@@ -10889,6 +11424,9 @@
                 <a:solidFill>
                   <a:srgbClr val="FFFFFF"/>
                 </a:solidFill>
+                <a:latin typeface="Poppins" pitchFamily="34" charset="0"/>
+                <a:ea typeface="Poppins" pitchFamily="34" charset="-122"/>
+                <a:cs typeface="Poppins" pitchFamily="34" charset="-120"/>
               </a:rPr>
               <a:t>Conclusion</a:t>
             </a:r>
@@ -10925,6 +11463,9 @@
                 <a:solidFill>
                   <a:srgbClr val="FFFFFF"/>
                 </a:solidFill>
+                <a:latin typeface="Poppins" pitchFamily="34" charset="0"/>
+                <a:ea typeface="Poppins" pitchFamily="34" charset="-122"/>
+                <a:cs typeface="Poppins" pitchFamily="34" charset="-120"/>
               </a:rPr>
               <a:t>AI can influence real-world performance, but its impact depends on task suitability, user behavior, and human judgment.</a:t>
             </a:r>
@@ -10981,14 +11522,17 @@
               <a:buNone/>
             </a:pPr>
             <a:r>
-              <a:rPr lang="en-US" sz="900" dirty="0">
+              <a:rPr lang="en-US" sz="850" dirty="0">
                 <a:solidFill>
                   <a:srgbClr val="FFFFFF"/>
                 </a:solidFill>
+                <a:latin typeface="Poppins" pitchFamily="34" charset="0"/>
+                <a:ea typeface="Poppins" pitchFamily="34" charset="-122"/>
+                <a:cs typeface="Poppins" pitchFamily="34" charset="-120"/>
               </a:rPr>
               <a:t>Match the task to what AI does well</a:t>
             </a:r>
-            <a:endParaRPr lang="en-US" sz="900" dirty="0"/>
+            <a:endParaRPr lang="en-US" sz="850" dirty="0"/>
           </a:p>
         </p:txBody>
       </p:sp>
@@ -11041,14 +11585,17 @@
               <a:buNone/>
             </a:pPr>
             <a:r>
-              <a:rPr lang="en-US" sz="900" dirty="0">
+              <a:rPr lang="en-US" sz="850" dirty="0">
                 <a:solidFill>
                   <a:srgbClr val="FFFFFF"/>
                 </a:solidFill>
+                <a:latin typeface="Poppins" pitchFamily="34" charset="0"/>
+                <a:ea typeface="Poppins" pitchFamily="34" charset="-122"/>
+                <a:cs typeface="Poppins" pitchFamily="34" charset="-120"/>
               </a:rPr>
               <a:t>Evaluate AI advice critically before acting</a:t>
             </a:r>
-            <a:endParaRPr lang="en-US" sz="900" dirty="0"/>
+            <a:endParaRPr lang="en-US" sz="850" dirty="0"/>
           </a:p>
         </p:txBody>
       </p:sp>
@@ -11101,14 +11648,17 @@
               <a:buNone/>
             </a:pPr>
             <a:r>
-              <a:rPr lang="en-US" sz="900" dirty="0">
+              <a:rPr lang="en-US" sz="850" dirty="0">
                 <a:solidFill>
                   <a:srgbClr val="FFFFFF"/>
                 </a:solidFill>
+                <a:latin typeface="Poppins" pitchFamily="34" charset="0"/>
+                <a:ea typeface="Poppins" pitchFamily="34" charset="-122"/>
+                <a:cs typeface="Poppins" pitchFamily="34" charset="-120"/>
               </a:rPr>
               <a:t>Keep human judgment in the loop</a:t>
             </a:r>
-            <a:endParaRPr lang="en-US" sz="900" dirty="0"/>
+            <a:endParaRPr lang="en-US" sz="850" dirty="0"/>
           </a:p>
         </p:txBody>
       </p:sp>
@@ -11189,6 +11739,9 @@
                 <a:solidFill>
                   <a:schemeClr val="tx2"/>
                 </a:solidFill>
+                <a:latin typeface="Poppins" pitchFamily="34" charset="0"/>
+                <a:ea typeface="Poppins" pitchFamily="34" charset="-122"/>
+                <a:cs typeface="Poppins" pitchFamily="34" charset="-120"/>
               </a:rPr>
               <a:t>Dell'Acqua et al. (2023), Harvard Business School Working Paper 24-013   |   Otis et al. (2026), Management Science, 72(7), https://doi.org/10.1287/mnsc.2024.06909</a:t>
             </a:r>
@@ -11276,6 +11829,9 @@
                 <a:solidFill>
                   <a:srgbClr val="2E8B86"/>
                 </a:solidFill>
+                <a:latin typeface="Poppins" pitchFamily="34" charset="0"/>
+                <a:ea typeface="Poppins" pitchFamily="34" charset="-122"/>
+                <a:cs typeface="Poppins" pitchFamily="34" charset="-120"/>
               </a:rPr>
               <a:t>Next:  </a:t>
             </a:r>
@@ -11287,6 +11843,9 @@
                 <a:solidFill>
                   <a:srgbClr val="1B2A4A"/>
                 </a:solidFill>
+                <a:latin typeface="Poppins" pitchFamily="34" charset="0"/>
+                <a:ea typeface="Poppins" pitchFamily="34" charset="-122"/>
+                <a:cs typeface="Poppins" pitchFamily="34" charset="-120"/>
               </a:rPr>
               <a:t>Thank you. Questions are welcome.</a:t>
             </a:r>
@@ -11326,6 +11885,9 @@
                 <a:solidFill>
                   <a:srgbClr val="9AA5B4"/>
                 </a:solidFill>
+                <a:latin typeface="Poppins"/>
+                <a:ea typeface="Poppins"/>
+                <a:cs typeface="Poppins"/>
               </a:defRPr>
             </a:lvl1pPr>
           </a:lstStyle>
@@ -11395,6 +11957,9 @@
                 <a:solidFill>
                   <a:schemeClr val="bg1"/>
                 </a:solidFill>
+                <a:latin typeface="Prompt" pitchFamily="34" charset="0"/>
+                <a:ea typeface="Prompt" pitchFamily="34" charset="-122"/>
+                <a:cs typeface="Prompt" pitchFamily="34" charset="-120"/>
               </a:rPr>
               <a:t>ปัญญาประดิษฐ์กับประสิทธิภาพการทำงาน</a:t>
             </a:r>
@@ -11433,6 +11998,9 @@
                 <a:solidFill>
                   <a:schemeClr val="accent4"/>
                 </a:solidFill>
+                <a:latin typeface="Prompt" pitchFamily="34" charset="0"/>
+                <a:ea typeface="Prompt" pitchFamily="34" charset="-122"/>
+                <a:cs typeface="Prompt" pitchFamily="34" charset="-120"/>
               </a:rPr>
               <a:t>หลักฐานจากการทดลองภาคสนามสองชิ้นล่าสุด</a:t>
             </a:r>
@@ -11493,6 +12061,9 @@
                 <a:solidFill>
                   <a:srgbClr val="BFE6E0"/>
                 </a:solidFill>
+                <a:latin typeface="Prompt" pitchFamily="34" charset="0"/>
+                <a:ea typeface="Prompt" pitchFamily="34" charset="-122"/>
+                <a:cs typeface="Prompt" pitchFamily="34" charset="-120"/>
               </a:rPr>
               <a:t>คำถามหลัก: AI ส่งผลต่อผลิตภาพ คุณภาพงาน และผลการดำเนินธุรกิจอย่างไร?</a:t>
             </a:r>
@@ -11556,6 +12127,9 @@
                 <a:solidFill>
                   <a:srgbClr val="BFE6E0"/>
                 </a:solidFill>
+                <a:latin typeface="Prompt" pitchFamily="34" charset="0"/>
+                <a:ea typeface="Prompt" pitchFamily="34" charset="-122"/>
+                <a:cs typeface="Prompt" pitchFamily="34" charset="-120"/>
               </a:rPr>
               <a:t>บทความที่ 2</a:t>
             </a:r>
@@ -11592,6 +12166,9 @@
                 <a:solidFill>
                   <a:srgbClr val="FFFFFF"/>
                 </a:solidFill>
+                <a:latin typeface="Prompt" pitchFamily="34" charset="0"/>
+                <a:ea typeface="Prompt" pitchFamily="34" charset="-122"/>
+                <a:cs typeface="Prompt" pitchFamily="34" charset="-120"/>
               </a:rPr>
               <a:t>Navigating the Jagged Technological Frontier: Field Experimental Evidence of the Effects of AI on Knowledge Worker Productivity and Quality</a:t>
             </a:r>
@@ -11628,6 +12205,9 @@
                 <a:solidFill>
                   <a:srgbClr val="BFE6E0"/>
                 </a:solidFill>
+                <a:latin typeface="Prompt" pitchFamily="34" charset="0"/>
+                <a:ea typeface="Prompt" pitchFamily="34" charset="-122"/>
+                <a:cs typeface="Prompt" pitchFamily="34" charset="-120"/>
               </a:rPr>
               <a:t>Fabrizio Dell'Acqua et al.  |  Harvard Business School Working Paper 24-013, 2023</a:t>
             </a:r>
@@ -11691,6 +12271,9 @@
                 <a:solidFill>
                   <a:srgbClr val="BFE6E0"/>
                 </a:solidFill>
+                <a:latin typeface="Prompt" pitchFamily="34" charset="0"/>
+                <a:ea typeface="Prompt" pitchFamily="34" charset="-122"/>
+                <a:cs typeface="Prompt" pitchFamily="34" charset="-120"/>
               </a:rPr>
               <a:t>บทความที่ 5</a:t>
             </a:r>
@@ -11727,6 +12310,9 @@
                 <a:solidFill>
                   <a:srgbClr val="FFFFFF"/>
                 </a:solidFill>
+                <a:latin typeface="Prompt" pitchFamily="34" charset="0"/>
+                <a:ea typeface="Prompt" pitchFamily="34" charset="-122"/>
+                <a:cs typeface="Prompt" pitchFamily="34" charset="-120"/>
               </a:rPr>
               <a:t>The Uneven Impact of Generative Artificial Intelligence on Entrepreneurial Performance: Evidence from a Field Experiment in Kenya</a:t>
             </a:r>
@@ -11763,6 +12349,9 @@
                 <a:solidFill>
                   <a:srgbClr val="BFE6E0"/>
                 </a:solidFill>
+                <a:latin typeface="Prompt" pitchFamily="34" charset="0"/>
+                <a:ea typeface="Prompt" pitchFamily="34" charset="-122"/>
+                <a:cs typeface="Prompt" pitchFamily="34" charset="-120"/>
               </a:rPr>
               <a:t>Nicholas G. Otis et al.  |  Management Science, Vol. 72, No. 7, 2026  |  DOI 10.1287/mnsc.2024.06909</a:t>
             </a:r>
@@ -11799,6 +12388,9 @@
                 <a:solidFill>
                   <a:srgbClr val="BFE6E0"/>
                 </a:solidFill>
+                <a:latin typeface="Prompt" pitchFamily="34" charset="0"/>
+                <a:ea typeface="Prompt" pitchFamily="34" charset="-122"/>
+                <a:cs typeface="Prompt" pitchFamily="34" charset="-120"/>
               </a:rPr>
               <a:t>ลำดับการนำเสนอ</a:t>
             </a:r>
@@ -11862,6 +12454,9 @@
                 <a:solidFill>
                   <a:srgbClr val="FFFFFF"/>
                 </a:solidFill>
+                <a:latin typeface="Prompt" pitchFamily="34" charset="0"/>
+                <a:ea typeface="Prompt" pitchFamily="34" charset="-122"/>
+                <a:cs typeface="Prompt" pitchFamily="34" charset="-120"/>
               </a:rPr>
               <a:t>1  บทนำ</a:t>
             </a:r>
@@ -11925,6 +12520,9 @@
                 <a:solidFill>
                   <a:srgbClr val="FFFFFF"/>
                 </a:solidFill>
+                <a:latin typeface="Prompt" pitchFamily="34" charset="0"/>
+                <a:ea typeface="Prompt" pitchFamily="34" charset="-122"/>
+                <a:cs typeface="Prompt" pitchFamily="34" charset="-120"/>
               </a:rPr>
               <a:t>2  บทความ 2: วิธีวิจัย</a:t>
             </a:r>
@@ -11988,6 +12586,9 @@
                 <a:solidFill>
                   <a:srgbClr val="FFFFFF"/>
                 </a:solidFill>
+                <a:latin typeface="Prompt" pitchFamily="34" charset="0"/>
+                <a:ea typeface="Prompt" pitchFamily="34" charset="-122"/>
+                <a:cs typeface="Prompt" pitchFamily="34" charset="-120"/>
               </a:rPr>
               <a:t>3  บทความ 2: ผลการศึกษา</a:t>
             </a:r>
@@ -12051,6 +12652,9 @@
                 <a:solidFill>
                   <a:srgbClr val="FFFFFF"/>
                 </a:solidFill>
+                <a:latin typeface="Prompt" pitchFamily="34" charset="0"/>
+                <a:ea typeface="Prompt" pitchFamily="34" charset="-122"/>
+                <a:cs typeface="Prompt" pitchFamily="34" charset="-120"/>
               </a:rPr>
               <a:t>4  บทความ 5: ผู้ประกอบการ</a:t>
             </a:r>
@@ -12114,6 +12718,9 @@
                 <a:solidFill>
                   <a:srgbClr val="FFFFFF"/>
                 </a:solidFill>
+                <a:latin typeface="Prompt" pitchFamily="34" charset="0"/>
+                <a:ea typeface="Prompt" pitchFamily="34" charset="-122"/>
+                <a:cs typeface="Prompt" pitchFamily="34" charset="-120"/>
               </a:rPr>
               <a:t>5  อภิปรายผล</a:t>
             </a:r>
@@ -12150,6 +12757,9 @@
                 <a:solidFill>
                   <a:srgbClr val="FFFFFF"/>
                 </a:solidFill>
+                <a:latin typeface="Prompt" pitchFamily="34" charset="0"/>
+                <a:ea typeface="Prompt" pitchFamily="34" charset="-122"/>
+                <a:cs typeface="Prompt" pitchFamily="34" charset="-120"/>
               </a:rPr>
               <a:t>Chayanun Sungsa-ard</a:t>
             </a:r>
@@ -12164,6 +12774,9 @@
                 <a:solidFill>
                   <a:srgbClr val="BFE6E0"/>
                 </a:solidFill>
+                <a:latin typeface="Prompt" pitchFamily="34" charset="0"/>
+                <a:ea typeface="Prompt" pitchFamily="34" charset="-122"/>
+                <a:cs typeface="Prompt" pitchFamily="34" charset="-120"/>
               </a:rPr>
               <a:t>รหัสนักศึกษา 691401708  |  หลักสูตรบริหารธุรกิจมหาบัณฑิต (MBA)  |  ENG 501 English for Master's Degree</a:t>
             </a:r>
@@ -12203,6 +12816,9 @@
                 <a:solidFill>
                   <a:srgbClr val="9AA5B4"/>
                 </a:solidFill>
+                <a:latin typeface="Prompt"/>
+                <a:ea typeface="Prompt"/>
+                <a:cs typeface="Prompt"/>
               </a:defRPr>
             </a:lvl1pPr>
           </a:lstStyle>
@@ -12272,6 +12888,9 @@
                 <a:solidFill>
                   <a:schemeClr val="accent1"/>
                 </a:solidFill>
+                <a:latin typeface="Prompt" pitchFamily="34" charset="0"/>
+                <a:ea typeface="Prompt" pitchFamily="34" charset="-122"/>
+                <a:cs typeface="Prompt" pitchFamily="34" charset="-120"/>
               </a:rPr>
               <a:t>บทความที่ 2  |  วัตถุประสงค์และวิธีวิจัย</a:t>
             </a:r>
@@ -12312,6 +12931,9 @@
                 <a:solidFill>
                   <a:schemeClr val="tx1"/>
                 </a:solidFill>
+                <a:latin typeface="Prompt" pitchFamily="34" charset="0"/>
+                <a:ea typeface="Prompt" pitchFamily="34" charset="-122"/>
+                <a:cs typeface="Prompt" pitchFamily="34" charset="-120"/>
               </a:rPr>
               <a:t>การนำทางในพรมแดนเทคโนโลยีที่ไม่สม่ำเสมอ</a:t>
             </a:r>
@@ -12473,6 +13095,9 @@
                 <a:solidFill>
                   <a:schemeClr val="tx2"/>
                 </a:solidFill>
+                <a:latin typeface="Prompt" pitchFamily="34" charset="0"/>
+                <a:ea typeface="Prompt" pitchFamily="34" charset="-122"/>
+                <a:cs typeface="Prompt" pitchFamily="34" charset="-120"/>
               </a:rPr>
               <a:t>บทความ 2: วิธีวิจัย</a:t>
             </a:r>
@@ -12509,6 +13134,9 @@
                 <a:solidFill>
                   <a:schemeClr val="tx2"/>
                 </a:solidFill>
+                <a:latin typeface="Prompt" pitchFamily="34" charset="0"/>
+                <a:ea typeface="Prompt" pitchFamily="34" charset="-122"/>
+                <a:cs typeface="Prompt" pitchFamily="34" charset="-120"/>
               </a:rPr>
               <a:t>Fabrizio Dell'Acqua et al.  |  Harvard Business School Working Paper 24-013, 2023</a:t>
             </a:r>
@@ -12594,6 +13222,9 @@
                 <a:solidFill>
                   <a:schemeClr val="tx1"/>
                 </a:solidFill>
+                <a:latin typeface="Prompt" pitchFamily="34" charset="0"/>
+                <a:ea typeface="Prompt" pitchFamily="34" charset="-122"/>
+                <a:cs typeface="Prompt" pitchFamily="34" charset="-120"/>
               </a:rPr>
               <a:t>องค์กรที่ร่วมวิจัย</a:t>
             </a:r>
@@ -12608,6 +13239,9 @@
                 <a:solidFill>
                   <a:schemeClr val="tx2"/>
                 </a:solidFill>
+                <a:latin typeface="Prompt" pitchFamily="34" charset="0"/>
+                <a:ea typeface="Prompt" pitchFamily="34" charset="-122"/>
+                <a:cs typeface="Prompt" pitchFamily="34" charset="-120"/>
               </a:rPr>
               <a:t>การทดลองภาคสนามร่วมกับ Boston Consulting Group (BCG)</a:t>
             </a:r>
@@ -12693,6 +13327,9 @@
                 <a:solidFill>
                   <a:schemeClr val="tx1"/>
                 </a:solidFill>
+                <a:latin typeface="Prompt" pitchFamily="34" charset="0"/>
+                <a:ea typeface="Prompt" pitchFamily="34" charset="-122"/>
+                <a:cs typeface="Prompt" pitchFamily="34" charset="-120"/>
               </a:rPr>
               <a:t>ผู้เข้าร่วม</a:t>
             </a:r>
@@ -12707,6 +13344,9 @@
                 <a:solidFill>
                   <a:schemeClr val="tx2"/>
                 </a:solidFill>
+                <a:latin typeface="Prompt" pitchFamily="34" charset="0"/>
+                <a:ea typeface="Prompt" pitchFamily="34" charset="-122"/>
+                <a:cs typeface="Prompt" pitchFamily="34" charset="-120"/>
               </a:rPr>
               <a:t>ที่ปรึกษาจำนวน 758 คน</a:t>
             </a:r>
@@ -12792,6 +13432,9 @@
                 <a:solidFill>
                   <a:schemeClr val="tx1"/>
                 </a:solidFill>
+                <a:latin typeface="Prompt" pitchFamily="34" charset="0"/>
+                <a:ea typeface="Prompt" pitchFamily="34" charset="-122"/>
+                <a:cs typeface="Prompt" pitchFamily="34" charset="-120"/>
               </a:rPr>
               <a:t>ประเด็นที่ศึกษา</a:t>
             </a:r>
@@ -12806,6 +13449,9 @@
                 <a:solidFill>
                   <a:schemeClr val="tx2"/>
                 </a:solidFill>
+                <a:latin typeface="Prompt" pitchFamily="34" charset="0"/>
+                <a:ea typeface="Prompt" pitchFamily="34" charset="-122"/>
+                <a:cs typeface="Prompt" pitchFamily="34" charset="-120"/>
               </a:rPr>
               <a:t>ผลิตภาพ คุณภาพงาน และขอบเขตความสามารถของ AI</a:t>
             </a:r>
@@ -12842,6 +13488,9 @@
                 <a:solidFill>
                   <a:schemeClr val="tx1"/>
                 </a:solidFill>
+                <a:latin typeface="Prompt" pitchFamily="34" charset="0"/>
+                <a:ea typeface="Prompt" pitchFamily="34" charset="-122"/>
+                <a:cs typeface="Prompt" pitchFamily="34" charset="-120"/>
               </a:rPr>
               <a:t>เงื่อนไขการทดลองสามกลุ่ม</a:t>
             </a:r>
@@ -12912,6 +13561,9 @@
                 <a:solidFill>
                   <a:srgbClr val="2E8B86"/>
                 </a:solidFill>
+                <a:latin typeface="Prompt" pitchFamily="34" charset="0"/>
+                <a:ea typeface="Prompt" pitchFamily="34" charset="-122"/>
+                <a:cs typeface="Prompt" pitchFamily="34" charset="-120"/>
               </a:rPr>
               <a:t>1</a:t>
             </a:r>
@@ -12948,6 +13600,9 @@
                 <a:solidFill>
                   <a:schemeClr val="tx1"/>
                 </a:solidFill>
+                <a:latin typeface="Prompt" pitchFamily="34" charset="0"/>
+                <a:ea typeface="Prompt" pitchFamily="34" charset="-122"/>
+                <a:cs typeface="Prompt" pitchFamily="34" charset="-120"/>
               </a:rPr>
               <a:t>ไม่สามารถใช้ AI</a:t>
             </a:r>
@@ -13042,6 +13697,9 @@
                 <a:solidFill>
                   <a:srgbClr val="BFE6E0"/>
                 </a:solidFill>
+                <a:latin typeface="Prompt" pitchFamily="34" charset="0"/>
+                <a:ea typeface="Prompt" pitchFamily="34" charset="-122"/>
+                <a:cs typeface="Prompt" pitchFamily="34" charset="-120"/>
               </a:rPr>
               <a:t>2</a:t>
             </a:r>
@@ -13078,6 +13736,9 @@
                 <a:solidFill>
                   <a:srgbClr val="FFFFFF"/>
                 </a:solidFill>
+                <a:latin typeface="Prompt" pitchFamily="34" charset="0"/>
+                <a:ea typeface="Prompt" pitchFamily="34" charset="-122"/>
+                <a:cs typeface="Prompt" pitchFamily="34" charset="-120"/>
               </a:rPr>
               <a:t>ใช้ GPT-4 ได้</a:t>
             </a:r>
@@ -13172,6 +13833,9 @@
                 <a:solidFill>
                   <a:srgbClr val="BFE6E0"/>
                 </a:solidFill>
+                <a:latin typeface="Prompt" pitchFamily="34" charset="0"/>
+                <a:ea typeface="Prompt" pitchFamily="34" charset="-122"/>
+                <a:cs typeface="Prompt" pitchFamily="34" charset="-120"/>
               </a:rPr>
               <a:t>3</a:t>
             </a:r>
@@ -13208,6 +13872,9 @@
                 <a:solidFill>
                   <a:srgbClr val="FFFFFF"/>
                 </a:solidFill>
+                <a:latin typeface="Prompt" pitchFamily="34" charset="0"/>
+                <a:ea typeface="Prompt" pitchFamily="34" charset="-122"/>
+                <a:cs typeface="Prompt" pitchFamily="34" charset="-120"/>
               </a:rPr>
               <a:t>ใช้ GPT-4 ได้ พร้อมคำแนะนำการเขียน prompt</a:t>
             </a:r>
@@ -13305,6 +13972,9 @@
                 <a:solidFill>
                   <a:schemeClr val="tx2"/>
                 </a:solidFill>
+                <a:latin typeface="Prompt" pitchFamily="34" charset="0"/>
+                <a:ea typeface="Prompt" pitchFamily="34" charset="-122"/>
+                <a:cs typeface="Prompt" pitchFamily="34" charset="-120"/>
               </a:rPr>
               <a:t>แนวคิด</a:t>
             </a:r>
@@ -13341,6 +14011,9 @@
                 <a:solidFill>
                   <a:schemeClr val="tx1"/>
                 </a:solidFill>
+                <a:latin typeface="Prompt" pitchFamily="34" charset="0"/>
+                <a:ea typeface="Prompt" pitchFamily="34" charset="-122"/>
+                <a:cs typeface="Prompt" pitchFamily="34" charset="-120"/>
               </a:rPr>
               <a:t>"Jagged Technological Frontier"</a:t>
             </a:r>
@@ -13377,6 +14050,9 @@
                 <a:solidFill>
                   <a:schemeClr val="tx2"/>
                 </a:solidFill>
+                <a:latin typeface="Prompt" pitchFamily="34" charset="0"/>
+                <a:ea typeface="Prompt" pitchFamily="34" charset="-122"/>
+                <a:cs typeface="Prompt" pitchFamily="34" charset="-120"/>
               </a:rPr>
               <a:t>AI ทำงานบางอย่างได้ดี แต่กลับทำงานอื่นที่ดูยากพอกันได้ไม่ดี เส้นแบ่งนี้ไม่สม่ำเสมอ ผู้ใช้จึงไม่ควรสรุปว่างานใด "ปลอดภัย" ที่จะมอบให้ AI เพียงเพราะงานนั้นดูง่าย</a:t>
             </a:r>
@@ -13461,6 +14137,9 @@
                 <a:solidFill>
                   <a:schemeClr val="tx2"/>
                 </a:solidFill>
+                <a:latin typeface="Prompt" pitchFamily="34" charset="0"/>
+                <a:ea typeface="Prompt" pitchFamily="34" charset="-122"/>
+                <a:cs typeface="Prompt" pitchFamily="34" charset="-120"/>
               </a:rPr>
               <a:t>ภายนอกพรมแดน: AI ทำได้ไม่ดี</a:t>
             </a:r>
@@ -13497,6 +14176,9 @@
                 <a:solidFill>
                   <a:srgbClr val="2E8B86"/>
                 </a:solidFill>
+                <a:latin typeface="Prompt" pitchFamily="34" charset="0"/>
+                <a:ea typeface="Prompt" pitchFamily="34" charset="-122"/>
+                <a:cs typeface="Prompt" pitchFamily="34" charset="-120"/>
               </a:rPr>
               <a:t>ภายในพรมแดน: AI ทำได้ดี</a:t>
             </a:r>
@@ -13533,6 +14215,9 @@
                 <a:solidFill>
                   <a:schemeClr val="tx2"/>
                 </a:solidFill>
+                <a:latin typeface="Prompt" pitchFamily="34" charset="0"/>
+                <a:ea typeface="Prompt" pitchFamily="34" charset="-122"/>
+                <a:cs typeface="Prompt" pitchFamily="34" charset="-120"/>
               </a:rPr>
               <a:t>งานที่ดูยากในระดับใกล้เคียงกัน</a:t>
             </a:r>
@@ -13569,6 +14254,9 @@
                 <a:solidFill>
                   <a:schemeClr val="tx2"/>
                 </a:solidFill>
+                <a:latin typeface="Prompt" pitchFamily="34" charset="0"/>
+                <a:ea typeface="Prompt" pitchFamily="34" charset="-122"/>
+                <a:cs typeface="Prompt" pitchFamily="34" charset="-120"/>
               </a:rPr>
               <a:t>Dell'Acqua, F., McFowland III, E., Mollick, E., Lifshitz-Assaf, H., Kellogg, K. C., Rajendran, S., Krayer, L., Candelon, F., &amp; Lakhani, K. R. (2023). Navigating the Jagged Technological Frontier. Harvard Business School Working Paper 24-013.</a:t>
             </a:r>
@@ -13656,6 +14344,9 @@
                 <a:solidFill>
                   <a:srgbClr val="2E8B86"/>
                 </a:solidFill>
+                <a:latin typeface="Prompt" pitchFamily="34" charset="0"/>
+                <a:ea typeface="Prompt" pitchFamily="34" charset="-122"/>
+                <a:cs typeface="Prompt" pitchFamily="34" charset="-120"/>
               </a:rPr>
               <a:t>ถัดไป:  </a:t>
             </a:r>
@@ -13667,6 +14358,9 @@
                 <a:solidFill>
                   <a:srgbClr val="1B2A4A"/>
                 </a:solidFill>
+                <a:latin typeface="Prompt" pitchFamily="34" charset="0"/>
+                <a:ea typeface="Prompt" pitchFamily="34" charset="-122"/>
+                <a:cs typeface="Prompt" pitchFamily="34" charset="-120"/>
               </a:rPr>
               <a:t>แล้วเมื่อที่ปรึกษา 758 คนใช้ GPT-4 จริง เกิดอะไรขึ้น?</a:t>
             </a:r>
@@ -13706,6 +14400,9 @@
                 <a:solidFill>
                   <a:srgbClr val="9AA5B4"/>
                 </a:solidFill>
+                <a:latin typeface="Prompt"/>
+                <a:ea typeface="Prompt"/>
+                <a:cs typeface="Prompt"/>
               </a:defRPr>
             </a:lvl1pPr>
           </a:lstStyle>
@@ -13775,6 +14472,9 @@
                 <a:solidFill>
                   <a:schemeClr val="accent1"/>
                 </a:solidFill>
+                <a:latin typeface="Prompt" pitchFamily="34" charset="0"/>
+                <a:ea typeface="Prompt" pitchFamily="34" charset="-122"/>
+                <a:cs typeface="Prompt" pitchFamily="34" charset="-120"/>
               </a:rPr>
               <a:t>บทความที่ 2  |  ผลการศึกษาที่สำคัญ</a:t>
             </a:r>
@@ -13815,6 +14515,9 @@
                 <a:solidFill>
                   <a:schemeClr val="tx1"/>
                 </a:solidFill>
+                <a:latin typeface="Prompt" pitchFamily="34" charset="0"/>
+                <a:ea typeface="Prompt" pitchFamily="34" charset="-122"/>
+                <a:cs typeface="Prompt" pitchFamily="34" charset="-120"/>
               </a:rPr>
               <a:t>AI ช่วยเพิ่มประสิทธิภาพ แต่มีข้อจำกัด</a:t>
             </a:r>
@@ -13976,6 +14679,9 @@
                 <a:solidFill>
                   <a:schemeClr val="tx2"/>
                 </a:solidFill>
+                <a:latin typeface="Prompt" pitchFamily="34" charset="0"/>
+                <a:ea typeface="Prompt" pitchFamily="34" charset="-122"/>
+                <a:cs typeface="Prompt" pitchFamily="34" charset="-120"/>
               </a:rPr>
               <a:t>บทความ 2: ผลการศึกษา</a:t>
             </a:r>
@@ -14039,6 +14745,9 @@
                 <a:solidFill>
                   <a:srgbClr val="FFFFFF"/>
                 </a:solidFill>
+                <a:latin typeface="Prompt" pitchFamily="34" charset="0"/>
+                <a:ea typeface="Prompt" pitchFamily="34" charset="-122"/>
+                <a:cs typeface="Prompt" pitchFamily="34" charset="-120"/>
               </a:rPr>
               <a:t>ผลการวิจัย (รายงานในบทความ)</a:t>
             </a:r>
@@ -14054,7 +14763,7 @@
         </p:nvGraphicFramePr>
         <p:xfrm>
           <a:off x="457200" y="1371600"/>
-          <a:ext cx="4846320" cy="2057400"/>
+          <a:ext cx="4846320" cy="2103120"/>
         </p:xfrm>
         <a:graphic xmlns:a="http://schemas.openxmlformats.org/drawingml/2006/main">
           <a:graphicData uri="http://schemas.openxmlformats.org/drawingml/2006/chart">
@@ -14091,6 +14800,9 @@
                 <a:solidFill>
                   <a:schemeClr val="tx2"/>
                 </a:solidFill>
+                <a:latin typeface="Prompt" pitchFamily="34" charset="0"/>
+                <a:ea typeface="Prompt" pitchFamily="34" charset="-122"/>
+                <a:cs typeface="Prompt" pitchFamily="34" charset="-120"/>
               </a:rPr>
               <a:t>คุณภาพรายงานว่าสูงขึ้น "มากกว่า 40%" แท่งกราฟจึงแสดงที่ 40 ส่วนตัวเลขของแต่ละกลุ่มคือการพัฒนาเทียบกับคะแนนเดิมของกลุ่มนั้นเอง</a:t>
             </a:r>
@@ -14161,6 +14873,9 @@
                 <a:solidFill>
                   <a:srgbClr val="BFE6E0"/>
                 </a:solidFill>
+                <a:latin typeface="Prompt" pitchFamily="34" charset="0"/>
+                <a:ea typeface="Prompt" pitchFamily="34" charset="-122"/>
+                <a:cs typeface="Prompt" pitchFamily="34" charset="-120"/>
               </a:rPr>
               <a:t>งานภายนอกพรมแดน</a:t>
             </a:r>
@@ -14197,6 +14912,9 @@
                 <a:solidFill>
                   <a:srgbClr val="FFFFFF"/>
                 </a:solidFill>
+                <a:latin typeface="Prompt" pitchFamily="34" charset="0"/>
+                <a:ea typeface="Prompt" pitchFamily="34" charset="-122"/>
+                <a:cs typeface="Prompt" pitchFamily="34" charset="-120"/>
               </a:rPr>
               <a:t>−19</a:t>
             </a:r>
@@ -14213,7 +14931,7 @@
         <p:spPr>
           <a:xfrm>
             <a:off x="5760720" y="1883664"/>
-            <a:ext cx="1828800" cy="201168"/>
+            <a:ext cx="1920240" cy="201168"/>
           </a:xfrm>
           <a:prstGeom prst="rect">
             <a:avLst/>
@@ -14229,14 +14947,17 @@
               <a:buNone/>
             </a:pPr>
             <a:r>
-              <a:rPr lang="en-US" sz="1050" dirty="0">
+              <a:rPr lang="en-US" sz="950" dirty="0">
                 <a:solidFill>
                   <a:srgbClr val="BFE6E0"/>
                 </a:solidFill>
+                <a:latin typeface="Prompt" pitchFamily="34" charset="0"/>
+                <a:ea typeface="Prompt" pitchFamily="34" charset="-122"/>
+                <a:cs typeface="Prompt" pitchFamily="34" charset="-120"/>
               </a:rPr>
               <a:t>จุดร้อยละ (percentage points)</a:t>
             </a:r>
-            <a:endParaRPr lang="en-US" sz="1050" dirty="0"/>
+            <a:endParaRPr lang="en-US" sz="950" dirty="0"/>
           </a:p>
         </p:txBody>
       </p:sp>
@@ -14293,6 +15014,9 @@
                 <a:solidFill>
                   <a:srgbClr val="FFFFFF"/>
                 </a:solidFill>
+                <a:latin typeface="Prompt" pitchFamily="34" charset="0"/>
+                <a:ea typeface="Prompt" pitchFamily="34" charset="-122"/>
+                <a:cs typeface="Prompt" pitchFamily="34" charset="-120"/>
               </a:rPr>
               <a:t>สำหรับงานที่เลือกให้อยู่นอกพรมแดน ผู้ใช้ AI มีโอกาสได้คำตอบที่ถูกต้องน้อยกว่าผู้ไม่ใช้ AI อยู่ 19 จุดร้อยละ</a:t>
             </a:r>
@@ -14356,6 +15080,9 @@
                 <a:solidFill>
                   <a:schemeClr val="tx2"/>
                 </a:solidFill>
+                <a:latin typeface="Prompt" pitchFamily="34" charset="0"/>
+                <a:ea typeface="Prompt" pitchFamily="34" charset="-122"/>
+                <a:cs typeface="Prompt" pitchFamily="34" charset="-120"/>
               </a:rPr>
               <a:t>ร้อยละการเปลี่ยนแปลง (เช่น +12.2%) เทียบกับค่าฐานเดิม ส่วนจุดร้อยละ (−19) คือส่วนต่างระหว่างอัตราความถูกต้องของสองกลุ่ม</a:t>
             </a:r>
@@ -14392,6 +15119,9 @@
                 <a:solidFill>
                   <a:schemeClr val="tx1"/>
                 </a:solidFill>
+                <a:latin typeface="Prompt" pitchFamily="34" charset="0"/>
+                <a:ea typeface="Prompt" pitchFamily="34" charset="-122"/>
+                <a:cs typeface="Prompt" pitchFamily="34" charset="-120"/>
               </a:rPr>
               <a:t>รูปแบบการใช้ AI ที่ประสบความสำเร็จสองแบบ</a:t>
             </a:r>
@@ -14479,6 +15209,9 @@
                 <a:solidFill>
                   <a:schemeClr val="tx1"/>
                 </a:solidFill>
+                <a:latin typeface="Prompt" pitchFamily="34" charset="0"/>
+                <a:ea typeface="Prompt" pitchFamily="34" charset="-122"/>
+                <a:cs typeface="Prompt" pitchFamily="34" charset="-120"/>
               </a:rPr>
               <a:t>Centaurs (เซนทอร์)  </a:t>
             </a:r>
@@ -14490,6 +15223,9 @@
                 <a:solidFill>
                   <a:schemeClr val="tx2"/>
                 </a:solidFill>
+                <a:latin typeface="Prompt" pitchFamily="34" charset="0"/>
+                <a:ea typeface="Prompt" pitchFamily="34" charset="-122"/>
+                <a:cs typeface="Prompt" pitchFamily="34" charset="-120"/>
               </a:rPr>
               <a:t>แบ่งงานระหว่างคนกับ AI โดยมอบงานย่อยให้ฝ่ายที่เหมาะสมกว่า</a:t>
             </a:r>
@@ -14577,6 +15313,9 @@
                 <a:solidFill>
                   <a:schemeClr val="tx1"/>
                 </a:solidFill>
+                <a:latin typeface="Prompt" pitchFamily="34" charset="0"/>
+                <a:ea typeface="Prompt" pitchFamily="34" charset="-122"/>
+                <a:cs typeface="Prompt" pitchFamily="34" charset="-120"/>
               </a:rPr>
               <a:t>Cyborgs (ไซบอร์ก)  </a:t>
             </a:r>
@@ -14588,6 +15327,9 @@
                 <a:solidFill>
                   <a:schemeClr val="tx2"/>
                 </a:solidFill>
+                <a:latin typeface="Prompt" pitchFamily="34" charset="0"/>
+                <a:ea typeface="Prompt" pitchFamily="34" charset="-122"/>
+                <a:cs typeface="Prompt" pitchFamily="34" charset="-120"/>
               </a:rPr>
               <a:t>ผสาน AI เข้ากับขั้นตอนการทำงานอย่างต่อเนื่อง สลับไปมากับเครื่องมือตลอดเวลา</a:t>
             </a:r>
@@ -14624,6 +15366,9 @@
                 <a:solidFill>
                   <a:schemeClr val="tx2"/>
                 </a:solidFill>
+                <a:latin typeface="Prompt" pitchFamily="34" charset="0"/>
+                <a:ea typeface="Prompt" pitchFamily="34" charset="-122"/>
+                <a:cs typeface="Prompt" pitchFamily="34" charset="-120"/>
               </a:rPr>
               <a:t>Dell'Acqua, F., McFowland III, E., Mollick, E., Lifshitz-Assaf, H., Kellogg, K. C., Rajendran, S., Krayer, L., Candelon, F., &amp; Lakhani, K. R. (2023). Navigating the Jagged Technological Frontier. Harvard Business School Working Paper 24-013.</a:t>
             </a:r>
@@ -14711,6 +15456,9 @@
                 <a:solidFill>
                   <a:srgbClr val="2E8B86"/>
                 </a:solidFill>
+                <a:latin typeface="Prompt" pitchFamily="34" charset="0"/>
+                <a:ea typeface="Prompt" pitchFamily="34" charset="-122"/>
+                <a:cs typeface="Prompt" pitchFamily="34" charset="-120"/>
               </a:rPr>
               <a:t>ถัดไป:  </a:t>
             </a:r>
@@ -14722,6 +15470,9 @@
                 <a:solidFill>
                   <a:srgbClr val="1B2A4A"/>
                 </a:solidFill>
+                <a:latin typeface="Prompt" pitchFamily="34" charset="0"/>
+                <a:ea typeface="Prompt" pitchFamily="34" charset="-122"/>
+                <a:cs typeface="Prompt" pitchFamily="34" charset="-120"/>
               </a:rPr>
               <a:t>ผลแบบนี้จะยังเป็นจริงนอกสำนักงาน กับธุรกิจขนาดเล็กจริงหรือไม่?</a:t>
             </a:r>
@@ -14761,6 +15512,9 @@
                 <a:solidFill>
                   <a:srgbClr val="9AA5B4"/>
                 </a:solidFill>
+                <a:latin typeface="Prompt"/>
+                <a:ea typeface="Prompt"/>
+                <a:cs typeface="Prompt"/>
               </a:defRPr>
             </a:lvl1pPr>
           </a:lstStyle>
@@ -14830,6 +15584,9 @@
                 <a:solidFill>
                   <a:schemeClr val="accent1"/>
                 </a:solidFill>
+                <a:latin typeface="Prompt" pitchFamily="34" charset="0"/>
+                <a:ea typeface="Prompt" pitchFamily="34" charset="-122"/>
+                <a:cs typeface="Prompt" pitchFamily="34" charset="-120"/>
               </a:rPr>
               <a:t>บทความที่ 5  |  วัตถุประสงค์และผลการศึกษา</a:t>
             </a:r>
@@ -14870,6 +15627,9 @@
                 <a:solidFill>
                   <a:schemeClr val="tx1"/>
                 </a:solidFill>
+                <a:latin typeface="Prompt" pitchFamily="34" charset="0"/>
+                <a:ea typeface="Prompt" pitchFamily="34" charset="-122"/>
+                <a:cs typeface="Prompt" pitchFamily="34" charset="-120"/>
               </a:rPr>
               <a:t>ผลกระทบของ AI ต่อผู้ประกอบการที่แตกต่างกัน</a:t>
             </a:r>
@@ -15031,6 +15791,9 @@
                 <a:solidFill>
                   <a:schemeClr val="tx2"/>
                 </a:solidFill>
+                <a:latin typeface="Prompt" pitchFamily="34" charset="0"/>
+                <a:ea typeface="Prompt" pitchFamily="34" charset="-122"/>
+                <a:cs typeface="Prompt" pitchFamily="34" charset="-120"/>
               </a:rPr>
               <a:t>บทความ 5: ผู้ประกอบการ</a:t>
             </a:r>
@@ -15067,6 +15830,9 @@
                 <a:solidFill>
                   <a:schemeClr val="tx2"/>
                 </a:solidFill>
+                <a:latin typeface="Prompt" pitchFamily="34" charset="0"/>
+                <a:ea typeface="Prompt" pitchFamily="34" charset="-122"/>
+                <a:cs typeface="Prompt" pitchFamily="34" charset="-120"/>
               </a:rPr>
               <a:t>Nicholas G. Otis et al.  |  Management Science, Vol. 72, No. 7, 2026  |  DOI 10.1287/mnsc.2024.06909</a:t>
             </a:r>
@@ -15152,6 +15918,9 @@
                 <a:solidFill>
                   <a:schemeClr val="tx1"/>
                 </a:solidFill>
+                <a:latin typeface="Prompt" pitchFamily="34" charset="0"/>
+                <a:ea typeface="Prompt" pitchFamily="34" charset="-122"/>
+                <a:cs typeface="Prompt" pitchFamily="34" charset="-120"/>
               </a:rPr>
               <a:t>บริบทการศึกษา</a:t>
             </a:r>
@@ -15166,6 +15935,9 @@
                 <a:solidFill>
                   <a:schemeClr val="tx2"/>
                 </a:solidFill>
+                <a:latin typeface="Prompt" pitchFamily="34" charset="0"/>
+                <a:ea typeface="Prompt" pitchFamily="34" charset="-122"/>
+                <a:cs typeface="Prompt" pitchFamily="34" charset="-120"/>
               </a:rPr>
               <a:t>การทดลองภาคสนามกับผู้ประกอบการธุรกิจขนาดเล็กในประเทศเคนยา</a:t>
             </a:r>
@@ -15251,6 +16023,9 @@
                 <a:solidFill>
                   <a:schemeClr val="tx1"/>
                 </a:solidFill>
+                <a:latin typeface="Prompt" pitchFamily="34" charset="0"/>
+                <a:ea typeface="Prompt" pitchFamily="34" charset="-122"/>
+                <a:cs typeface="Prompt" pitchFamily="34" charset="-120"/>
               </a:rPr>
               <a:t>สิ่งที่ทดลอง</a:t>
             </a:r>
@@ -15265,6 +16040,9 @@
                 <a:solidFill>
                   <a:schemeClr val="tx2"/>
                 </a:solidFill>
+                <a:latin typeface="Prompt" pitchFamily="34" charset="0"/>
+                <a:ea typeface="Prompt" pitchFamily="34" charset="-122"/>
+                <a:cs typeface="Prompt" pitchFamily="34" charset="-120"/>
               </a:rPr>
               <a:t>การเข้าถึงผู้ช่วยธุรกิจ AI ที่ขับเคลื่อนด้วย GPT-4 ซึ่งให้คำแนะนำทางธุรกิจ</a:t>
             </a:r>
@@ -15350,6 +16128,9 @@
                 <a:solidFill>
                   <a:schemeClr val="tx1"/>
                 </a:solidFill>
+                <a:latin typeface="Prompt" pitchFamily="34" charset="0"/>
+                <a:ea typeface="Prompt" pitchFamily="34" charset="-122"/>
+                <a:cs typeface="Prompt" pitchFamily="34" charset="-120"/>
               </a:rPr>
               <a:t>ตัวแปรผลลัพธ์</a:t>
             </a:r>
@@ -15364,6 +16145,9 @@
                 <a:solidFill>
                   <a:schemeClr val="tx2"/>
                 </a:solidFill>
+                <a:latin typeface="Prompt" pitchFamily="34" charset="0"/>
+                <a:ea typeface="Prompt" pitchFamily="34" charset="-122"/>
+                <a:cs typeface="Prompt" pitchFamily="34" charset="-120"/>
               </a:rPr>
               <a:t>รายได้และกำไรของธุรกิจขนาดเล็ก</a:t>
             </a:r>
@@ -15461,6 +16245,9 @@
                 <a:solidFill>
                   <a:srgbClr val="FFFFFF"/>
                 </a:solidFill>
+                <a:latin typeface="Prompt" pitchFamily="34" charset="0"/>
+                <a:ea typeface="Prompt" pitchFamily="34" charset="-122"/>
+                <a:cs typeface="Prompt" pitchFamily="34" charset="-120"/>
               </a:rPr>
               <a:t>ผลการวิจัย (รายงานในบทความ)</a:t>
             </a:r>
@@ -15497,6 +16284,9 @@
                 <a:solidFill>
                   <a:srgbClr val="BFE6E0"/>
                 </a:solidFill>
+                <a:latin typeface="Prompt" pitchFamily="34" charset="0"/>
+                <a:ea typeface="Prompt" pitchFamily="34" charset="-122"/>
+                <a:cs typeface="Prompt" pitchFamily="34" charset="-120"/>
               </a:rPr>
               <a:t>ผลโดยเฉลี่ย</a:t>
             </a:r>
@@ -15533,6 +16323,9 @@
                 <a:solidFill>
                   <a:srgbClr val="FFFFFF"/>
                 </a:solidFill>
+                <a:latin typeface="Prompt" pitchFamily="34" charset="0"/>
+                <a:ea typeface="Prompt" pitchFamily="34" charset="-122"/>
+                <a:cs typeface="Prompt" pitchFamily="34" charset="-120"/>
               </a:rPr>
               <a:t>ผู้วิจัยไม่สามารถปฏิเสธสมมติฐานว่าง (null hypothesis) ที่ว่าไม่มีผลเฉลี่ยของการทดลองต่อรายได้และกำไร</a:t>
             </a:r>
@@ -15654,6 +16447,9 @@
                 <a:solidFill>
                   <a:srgbClr val="FFFFFF"/>
                 </a:solidFill>
+                <a:latin typeface="Prompt" pitchFamily="34" charset="0"/>
+                <a:ea typeface="Prompt" pitchFamily="34" charset="-122"/>
+                <a:cs typeface="Prompt" pitchFamily="34" charset="-120"/>
               </a:rPr>
               <a:t>ผลการวิจัย (รายงานในบทความ)</a:t>
             </a:r>
@@ -15690,6 +16486,9 @@
                 <a:solidFill>
                   <a:schemeClr val="tx1"/>
                 </a:solidFill>
+                <a:latin typeface="Prompt" pitchFamily="34" charset="0"/>
+                <a:ea typeface="Prompt" pitchFamily="34" charset="-122"/>
+                <a:cs typeface="Prompt" pitchFamily="34" charset="-120"/>
               </a:rPr>
               <a:t>ผลแยกตามกลุ่มผลการดำเนินงานตั้งต้น</a:t>
             </a:r>
@@ -15769,10 +16568,13 @@
               <a:buNone/>
             </a:pPr>
             <a:r>
-              <a:rPr lang="en-US" sz="1000" b="1" dirty="0">
+              <a:rPr lang="en-US" sz="950" b="1" dirty="0">
                 <a:solidFill>
                   <a:schemeClr val="tx1"/>
                 </a:solidFill>
+                <a:latin typeface="Prompt" pitchFamily="34" charset="0"/>
+                <a:ea typeface="Prompt" pitchFamily="34" charset="-122"/>
+                <a:cs typeface="Prompt" pitchFamily="34" charset="-120"/>
               </a:rPr>
               <a:t>กลุ่มผลงานต่ำตั้งแต่ต้น  </a:t>
             </a:r>
@@ -15780,14 +16582,17 @@
               <a:buNone/>
             </a:pPr>
             <a:r>
-              <a:rPr lang="en-US" sz="1000" b="1" dirty="0">
+              <a:rPr lang="en-US" sz="950" b="1" dirty="0">
                 <a:solidFill>
                   <a:srgbClr val="5A6472"/>
                 </a:solidFill>
+                <a:latin typeface="Prompt" pitchFamily="34" charset="0"/>
+                <a:ea typeface="Prompt" pitchFamily="34" charset="-122"/>
+                <a:cs typeface="Prompt" pitchFamily="34" charset="-120"/>
               </a:rPr>
               <a:t>แย่ลงเกือบ 10%</a:t>
             </a:r>
-            <a:endParaRPr lang="en-US" sz="1000" dirty="0"/>
+            <a:endParaRPr lang="en-US" sz="950" dirty="0"/>
           </a:p>
         </p:txBody>
       </p:sp>
@@ -15841,10 +16646,13 @@
               <a:buNone/>
             </a:pPr>
             <a:r>
-              <a:rPr lang="en-US" sz="1000" b="1" dirty="0">
+              <a:rPr lang="en-US" sz="950" b="1" dirty="0">
                 <a:solidFill>
                   <a:schemeClr val="tx1"/>
                 </a:solidFill>
+                <a:latin typeface="Prompt" pitchFamily="34" charset="0"/>
+                <a:ea typeface="Prompt" pitchFamily="34" charset="-122"/>
+                <a:cs typeface="Prompt" pitchFamily="34" charset="-120"/>
               </a:rPr>
               <a:t>กลุ่มผลงานสูงตั้งแต่ต้น  </a:t>
             </a:r>
@@ -15852,14 +16660,17 @@
               <a:buNone/>
             </a:pPr>
             <a:r>
-              <a:rPr lang="en-US" sz="1000" b="1" dirty="0">
+              <a:rPr lang="en-US" sz="950" b="1" dirty="0">
                 <a:solidFill>
                   <a:srgbClr val="2E8B86"/>
                 </a:solidFill>
+                <a:latin typeface="Prompt" pitchFamily="34" charset="0"/>
+                <a:ea typeface="Prompt" pitchFamily="34" charset="-122"/>
+                <a:cs typeface="Prompt" pitchFamily="34" charset="-120"/>
               </a:rPr>
               <a:t>อาจได้ประโยชน์มากกว่า 15%</a:t>
             </a:r>
-            <a:endParaRPr lang="en-US" sz="1000" dirty="0"/>
+            <a:endParaRPr lang="en-US" sz="950" dirty="0"/>
           </a:p>
         </p:txBody>
       </p:sp>
@@ -15917,6 +16728,9 @@
                 <a:solidFill>
                   <a:schemeClr val="tx2"/>
                 </a:solidFill>
+                <a:latin typeface="Prompt" pitchFamily="34" charset="0"/>
+                <a:ea typeface="Prompt" pitchFamily="34" charset="-122"/>
+                <a:cs typeface="Prompt" pitchFamily="34" charset="-120"/>
               </a:rPr>
               <a:t>ความยาวแท่งเป็นเพียงภาพประกอบของตัวเลขที่รายงาน</a:t>
             </a:r>
@@ -15980,6 +16794,9 @@
                 <a:solidFill>
                   <a:schemeClr val="tx1"/>
                 </a:solidFill>
+                <a:latin typeface="Prompt" pitchFamily="34" charset="0"/>
+                <a:ea typeface="Prompt" pitchFamily="34" charset="-122"/>
+                <a:cs typeface="Prompt" pitchFamily="34" charset="-120"/>
               </a:rPr>
               <a:t>ความแตกต่างนี้ไม่ได้มาจากคำถามที่ถามหรือคำแนะนำที่ AI ให้ แต่มาจากคำแนะนำที่ผู้ประกอบการเลือกนำไปปฏิบัติ</a:t>
             </a:r>
@@ -16067,6 +16884,9 @@
                 <a:solidFill>
                   <a:schemeClr val="tx2"/>
                 </a:solidFill>
+                <a:latin typeface="Prompt" pitchFamily="34" charset="0"/>
+                <a:ea typeface="Prompt" pitchFamily="34" charset="-122"/>
+                <a:cs typeface="Prompt" pitchFamily="34" charset="-120"/>
               </a:rPr>
               <a:t>ข้อควรระวัง: ตัวเลขนี้เป็นค่าเฉลี่ยของกลุ่มย่อย ไม่ได้แสดงว่าผู้ประกอบการที่เก่งทุกคนจะได้ประโยชน์ หรือผู้ประกอบการที่อ่อนทุกคนจะเสียประโยชน์</a:t>
             </a:r>
@@ -16103,6 +16923,9 @@
                 <a:solidFill>
                   <a:schemeClr val="tx2"/>
                 </a:solidFill>
+                <a:latin typeface="Prompt" pitchFamily="34" charset="0"/>
+                <a:ea typeface="Prompt" pitchFamily="34" charset="-122"/>
+                <a:cs typeface="Prompt" pitchFamily="34" charset="-120"/>
               </a:rPr>
               <a:t>Otis, N. G., Clarke, R., Delecourt, S., Holtz, D., &amp; Koning, R. (2026). The Uneven Impact of Generative Artificial Intelligence on Entrepreneurial Performance: Evidence from a Field Experiment in Kenya. Management Science, 72(7). https://doi.org/10.1287/mnsc.2024.06909</a:t>
             </a:r>
@@ -16190,6 +17013,9 @@
                 <a:solidFill>
                   <a:srgbClr val="2E8B86"/>
                 </a:solidFill>
+                <a:latin typeface="Prompt" pitchFamily="34" charset="0"/>
+                <a:ea typeface="Prompt" pitchFamily="34" charset="-122"/>
+                <a:cs typeface="Prompt" pitchFamily="34" charset="-120"/>
               </a:rPr>
               <a:t>ถัดไป:  </a:t>
             </a:r>
@@ -16201,6 +17027,9 @@
                 <a:solidFill>
                   <a:srgbClr val="1B2A4A"/>
                 </a:solidFill>
+                <a:latin typeface="Prompt" pitchFamily="34" charset="0"/>
+                <a:ea typeface="Prompt" pitchFamily="34" charset="-122"/>
+                <a:cs typeface="Prompt" pitchFamily="34" charset="-120"/>
               </a:rPr>
               <a:t>สองงานวิจัย บทเรียนเดียว: เมื่อมองร่วมกันบอกอะไรเรา?</a:t>
             </a:r>
@@ -16240,6 +17069,9 @@
                 <a:solidFill>
                   <a:srgbClr val="9AA5B4"/>
                 </a:solidFill>
+                <a:latin typeface="Prompt"/>
+                <a:ea typeface="Prompt"/>
+                <a:cs typeface="Prompt"/>
               </a:defRPr>
             </a:lvl1pPr>
           </a:lstStyle>
@@ -16304,7 +17136,7 @@
     </a:clrScheme>
     <a:fontScheme name="AI Navy Teal">
       <a:majorFont>
-        <a:latin typeface="Tahoma"/>
+        <a:latin typeface="Poppins"/>
         <a:ea typeface=""/>
         <a:cs typeface=""/>
         <a:font script="Jpan" typeface="游ゴシック Light"/>
@@ -16356,7 +17188,7 @@
         <a:font script="Tfng" typeface="Ebrima"/>
       </a:majorFont>
       <a:minorFont>
-        <a:latin typeface="Tahoma"/>
+        <a:latin typeface="Poppins"/>
         <a:ea typeface=""/>
         <a:cs typeface=""/>
         <a:font script="Jpan" typeface="游ゴシック"/>

</xml_diff>

<commit_message>
Mascot variants for dark and teal backgrounds in the deck
Co-Authored-By: Claude Fable 5.1 <noreply@anthropic.com>
Claude-Session: https://claude.ai/code/session_01MJB3WpVo3kuH25GjttwApw
</commit_message>
<xml_diff>
--- a/presentation/AI_Work_Performance_ENG501.pptx
+++ b/presentation/AI_Work_Performance_ENG501.pptx
@@ -116,7 +116,7 @@
   <p:extLst>
     <p:ext uri="{521415D9-36F7-43E2-AB2F-B90AF26B5E84}">
       <p14:sectionLst xmlns:p14="http://schemas.microsoft.com/office/powerpoint/2010/main">
-        <p14:section name="English (Slides 1-5)" id="{634685b7-f5ec-e893-8e3f-34eaaca150ac}">
+        <p14:section name="English (Slides 1-5)" id="{58d66c0d-2ef4-732c-3a0b-0c45bc4ff314}">
           <p14:sldIdLst>
             <p14:sldId id="256"/>
             <p14:sldId id="257"/>
@@ -125,7 +125,7 @@
             <p14:sldId id="260"/>
           </p14:sldIdLst>
         </p14:section>
-        <p14:section name="ภาษาไทย (Slides 6-10)" id="{a2d8bb49-f92f-f433-b64c-24a12a24b020}">
+        <p14:section name="ภาษาไทย (Slides 6-10)" id="{75e8ac88-95ac-c807-9bab-8c4f89a07d1b}">
           <p14:sldIdLst>
             <p14:sldId id="261"/>
             <p14:sldId id="262"/>

</xml_diff>

<commit_message>
Keep single-line text unwrapped and widen wrapping boxes; add PDF reference render
Co-Authored-By: Claude Fable 5.1 <noreply@anthropic.com>
Claude-Session: https://claude.ai/code/session_01MJB3WpVo3kuH25GjttwApw
</commit_message>
<xml_diff>
--- a/presentation/AI_Work_Performance_ENG501.pptx
+++ b/presentation/AI_Work_Performance_ENG501.pptx
@@ -116,7 +116,7 @@
   <p:extLst>
     <p:ext uri="{521415D9-36F7-43E2-AB2F-B90AF26B5E84}">
       <p14:sectionLst xmlns:p14="http://schemas.microsoft.com/office/powerpoint/2010/main">
-        <p14:section name="English version: two field experiments on AI, productivity and business performance." id="{af6cf5be-a0b5-6d41-56cd-672e3d0910ee}">
+        <p14:section name="English version: two field experiments on AI, productivity and business performance." id="{a4191d4c-2f5c-4ce6-f622-e5471820d11e}">
           <p14:sldIdLst>
             <p14:sldId id="256"/>
             <p14:sldId id="257"/>
@@ -130,7 +130,7 @@
             <p14:sldId id="265"/>
           </p14:sldIdLst>
         </p14:section>
-        <p14:section name="ฉบับภาษาไทย: การทดลองภาคสนามสองชิ้นเรื่อง AI ผลิตภาพ และผลการดำเนินธุรกิจ" id="{10922c1d-c01d-182c-4717-5834c61fa97e}">
+        <p14:section name="ฉบับภาษาไทย: การทดลองภาคสนามสองชิ้นเรื่อง AI ผลิตภาพ และผลการดำเนินธุรกิจ" id="{b2802288-ed4d-3b8f-cbc6-2dd6fae267ab}">
           <p14:sldIdLst/>
         </p14:section>
       </p14:sectionLst>
@@ -1744,7 +1744,7 @@
           <a:ln/>
         </p:spPr>
         <p:txBody>
-          <a:bodyPr wrap="square" lIns="0" tIns="0" rIns="0" bIns="0" rtlCol="0" anchor="ctr"/>
+          <a:bodyPr wrap="none" lIns="0" tIns="0" rIns="0" bIns="0" rtlCol="0" anchor="ctr"/>
           <a:lstStyle/>
           <a:p>
             <a:pPr algn="l" indent="0" marL="0">
@@ -1777,7 +1777,7 @@
         <p:spPr>
           <a:xfrm>
             <a:off x="609600" y="693390"/>
-            <a:ext cx="5829300" cy="1015305"/>
+            <a:ext cx="5943600" cy="1015305"/>
           </a:xfrm>
           <a:prstGeom prst="rect">
             <a:avLst/>
@@ -1828,7 +1828,7 @@
           <a:ln/>
         </p:spPr>
         <p:txBody>
-          <a:bodyPr wrap="square" lIns="0" tIns="0" rIns="0" bIns="0" rtlCol="0" anchor="ctr"/>
+          <a:bodyPr wrap="none" lIns="0" tIns="0" rIns="0" bIns="0" rtlCol="0" anchor="ctr"/>
           <a:lstStyle/>
           <a:p>
             <a:pPr algn="l" indent="0" marL="0">
@@ -1894,7 +1894,7 @@
           <a:ln/>
         </p:spPr>
         <p:txBody>
-          <a:bodyPr wrap="square" lIns="0" tIns="0" rIns="0" bIns="0" rtlCol="0" anchor="ctr"/>
+          <a:bodyPr wrap="none" lIns="0" tIns="0" rIns="0" bIns="0" rtlCol="0" anchor="ctr"/>
           <a:lstStyle/>
           <a:p>
             <a:pPr algn="l" indent="0" marL="0">
@@ -1958,7 +1958,7 @@
           <a:ln/>
         </p:spPr>
         <p:txBody>
-          <a:bodyPr wrap="square" lIns="0" tIns="0" rIns="0" bIns="0" rtlCol="0" anchor="ctr"/>
+          <a:bodyPr wrap="none" lIns="0" tIns="0" rIns="0" bIns="0" rtlCol="0" anchor="ctr"/>
           <a:lstStyle/>
           <a:p>
             <a:pPr algn="l" indent="0" marL="0">
@@ -1991,7 +1991,7 @@
         <p:spPr>
           <a:xfrm>
             <a:off x="800100" y="3055590"/>
-            <a:ext cx="3575304" cy="482873"/>
+            <a:ext cx="3645408" cy="482873"/>
           </a:xfrm>
           <a:prstGeom prst="rect">
             <a:avLst/>
@@ -2033,7 +2033,7 @@
         <p:spPr>
           <a:xfrm>
             <a:off x="800100" y="3595613"/>
-            <a:ext cx="3575304" cy="319980"/>
+            <a:ext cx="3645408" cy="319980"/>
           </a:xfrm>
           <a:prstGeom prst="rect">
             <a:avLst/>
@@ -2106,7 +2106,7 @@
           <a:ln/>
         </p:spPr>
         <p:txBody>
-          <a:bodyPr wrap="square" lIns="0" tIns="0" rIns="0" bIns="0" rtlCol="0" anchor="ctr"/>
+          <a:bodyPr wrap="none" lIns="0" tIns="0" rIns="0" bIns="0" rtlCol="0" anchor="ctr"/>
           <a:lstStyle/>
           <a:p>
             <a:pPr algn="l" indent="0" marL="0">
@@ -2139,7 +2139,7 @@
         <p:spPr>
           <a:xfrm>
             <a:off x="4838700" y="3055590"/>
-            <a:ext cx="3575304" cy="482873"/>
+            <a:ext cx="3645408" cy="482873"/>
           </a:xfrm>
           <a:prstGeom prst="rect">
             <a:avLst/>
@@ -2181,7 +2181,7 @@
         <p:spPr>
           <a:xfrm>
             <a:off x="4838700" y="3595613"/>
-            <a:ext cx="3575304" cy="319980"/>
+            <a:ext cx="3645408" cy="319980"/>
           </a:xfrm>
           <a:prstGeom prst="rect">
             <a:avLst/>
@@ -2232,7 +2232,7 @@
           <a:ln/>
         </p:spPr>
         <p:txBody>
-          <a:bodyPr wrap="square" lIns="0" tIns="0" rIns="0" bIns="0" rtlCol="0" anchor="ctr"/>
+          <a:bodyPr wrap="none" lIns="0" tIns="0" rIns="0" bIns="0" rtlCol="0" anchor="ctr"/>
           <a:lstStyle/>
           <a:p>
             <a:pPr algn="l" indent="0" marL="0">
@@ -3148,7 +3148,7 @@
           <a:ln/>
         </p:spPr>
         <p:txBody>
-          <a:bodyPr wrap="square" lIns="0" tIns="0" rIns="0" bIns="0" rtlCol="0" anchor="ctr"/>
+          <a:bodyPr wrap="none" lIns="0" tIns="0" rIns="0" bIns="0" rtlCol="0" anchor="ctr"/>
           <a:lstStyle/>
           <a:p>
             <a:pPr algn="l" indent="0" marL="0">
@@ -3190,7 +3190,7 @@
           <a:ln/>
         </p:spPr>
         <p:txBody>
-          <a:bodyPr wrap="square" lIns="0" tIns="0" rIns="0" bIns="0" rtlCol="0" anchor="ctr"/>
+          <a:bodyPr wrap="none" lIns="0" tIns="0" rIns="0" bIns="0" rtlCol="0" anchor="ctr"/>
           <a:lstStyle/>
           <a:p>
             <a:pPr algn="l" indent="0" marL="0">
@@ -3254,7 +3254,7 @@
           <a:ln/>
         </p:spPr>
         <p:txBody>
-          <a:bodyPr wrap="square" lIns="95250" tIns="0" rIns="95250" bIns="0" rtlCol="0" anchor="ctr"/>
+          <a:bodyPr wrap="none" lIns="95250" tIns="0" rIns="95250" bIns="0" rtlCol="0" anchor="ctr"/>
           <a:lstStyle/>
           <a:p>
             <a:pPr algn="ctr" indent="0" marL="0">
@@ -3342,7 +3342,7 @@
           <a:ln/>
         </p:spPr>
         <p:txBody>
-          <a:bodyPr wrap="square" lIns="95250" tIns="0" rIns="95250" bIns="0" rtlCol="0" anchor="ctr"/>
+          <a:bodyPr wrap="none" lIns="95250" tIns="0" rIns="95250" bIns="0" rtlCol="0" anchor="ctr"/>
           <a:lstStyle/>
           <a:p>
             <a:pPr algn="l" indent="0" marL="0">
@@ -3407,7 +3407,7 @@
           <a:ln/>
         </p:spPr>
         <p:txBody>
-          <a:bodyPr wrap="square" lIns="95250" tIns="0" rIns="95250" bIns="0" rtlCol="0" anchor="ctr"/>
+          <a:bodyPr wrap="none" lIns="95250" tIns="0" rIns="95250" bIns="0" rtlCol="0" anchor="ctr"/>
           <a:lstStyle/>
           <a:p>
             <a:pPr algn="l" indent="0" marL="0">
@@ -3472,7 +3472,7 @@
           <a:ln/>
         </p:spPr>
         <p:txBody>
-          <a:bodyPr wrap="square" lIns="95250" tIns="0" rIns="95250" bIns="0" rtlCol="0" anchor="ctr"/>
+          <a:bodyPr wrap="none" lIns="95250" tIns="0" rIns="95250" bIns="0" rtlCol="0" anchor="ctr"/>
           <a:lstStyle/>
           <a:p>
             <a:pPr algn="l" indent="0" marL="0">
@@ -3537,7 +3537,7 @@
           <a:ln/>
         </p:spPr>
         <p:txBody>
-          <a:bodyPr wrap="square" lIns="95250" tIns="0" rIns="95250" bIns="0" rtlCol="0" anchor="ctr"/>
+          <a:bodyPr wrap="none" lIns="95250" tIns="0" rIns="95250" bIns="0" rtlCol="0" anchor="ctr"/>
           <a:lstStyle/>
           <a:p>
             <a:pPr algn="l" indent="0" marL="0">
@@ -3602,7 +3602,7 @@
           <a:ln/>
         </p:spPr>
         <p:txBody>
-          <a:bodyPr wrap="square" lIns="95250" tIns="0" rIns="95250" bIns="0" rtlCol="0" anchor="ctr"/>
+          <a:bodyPr wrap="none" lIns="95250" tIns="0" rIns="95250" bIns="0" rtlCol="0" anchor="ctr"/>
           <a:lstStyle/>
           <a:p>
             <a:pPr algn="l" indent="0" marL="0">
@@ -3687,7 +3687,7 @@
           <a:ln/>
         </p:spPr>
         <p:txBody>
-          <a:bodyPr wrap="square" lIns="95250" tIns="0" rIns="95250" bIns="0" rtlCol="0" anchor="ctr"/>
+          <a:bodyPr wrap="none" lIns="95250" tIns="0" rIns="95250" bIns="0" rtlCol="0" anchor="ctr"/>
           <a:lstStyle/>
           <a:p>
             <a:pPr algn="l" indent="0" marL="0">
@@ -3752,7 +3752,7 @@
           <a:ln/>
         </p:spPr>
         <p:txBody>
-          <a:bodyPr wrap="square" lIns="95250" tIns="0" rIns="95250" bIns="0" rtlCol="0" anchor="ctr"/>
+          <a:bodyPr wrap="none" lIns="95250" tIns="0" rIns="95250" bIns="0" rtlCol="0" anchor="ctr"/>
           <a:lstStyle/>
           <a:p>
             <a:pPr algn="l" indent="0" marL="0">
@@ -3817,7 +3817,7 @@
           <a:ln/>
         </p:spPr>
         <p:txBody>
-          <a:bodyPr wrap="square" lIns="95250" tIns="0" rIns="95250" bIns="0" rtlCol="0" anchor="ctr"/>
+          <a:bodyPr wrap="none" lIns="95250" tIns="0" rIns="95250" bIns="0" rtlCol="0" anchor="ctr"/>
           <a:lstStyle/>
           <a:p>
             <a:pPr algn="l" indent="0" marL="0">
@@ -3882,7 +3882,7 @@
           <a:ln/>
         </p:spPr>
         <p:txBody>
-          <a:bodyPr wrap="square" lIns="95250" tIns="0" rIns="95250" bIns="0" rtlCol="0" anchor="ctr"/>
+          <a:bodyPr wrap="none" lIns="95250" tIns="0" rIns="95250" bIns="0" rtlCol="0" anchor="ctr"/>
           <a:lstStyle/>
           <a:p>
             <a:pPr algn="l" indent="0" marL="0">
@@ -3947,7 +3947,7 @@
           <a:ln/>
         </p:spPr>
         <p:txBody>
-          <a:bodyPr wrap="square" lIns="95250" tIns="0" rIns="95250" bIns="0" rtlCol="0" anchor="ctr"/>
+          <a:bodyPr wrap="none" lIns="95250" tIns="0" rIns="95250" bIns="0" rtlCol="0" anchor="ctr"/>
           <a:lstStyle/>
           <a:p>
             <a:pPr algn="l" indent="0" marL="0">
@@ -4012,7 +4012,7 @@
           <a:ln/>
         </p:spPr>
         <p:txBody>
-          <a:bodyPr wrap="square" lIns="95250" tIns="0" rIns="95250" bIns="0" rtlCol="0" anchor="ctr"/>
+          <a:bodyPr wrap="none" lIns="95250" tIns="0" rIns="95250" bIns="0" rtlCol="0" anchor="ctr"/>
           <a:lstStyle/>
           <a:p>
             <a:pPr algn="l" indent="0" marL="0">
@@ -4098,7 +4098,7 @@
           <a:ln/>
         </p:spPr>
         <p:txBody>
-          <a:bodyPr wrap="square" lIns="85725" tIns="0" rIns="85725" bIns="0" rtlCol="0" anchor="ctr"/>
+          <a:bodyPr wrap="none" lIns="85725" tIns="0" rIns="85725" bIns="0" rtlCol="0" anchor="ctr"/>
           <a:lstStyle/>
           <a:p>
             <a:pPr algn="ctr" indent="0" marL="0">
@@ -4131,7 +4131,7 @@
         <p:spPr>
           <a:xfrm>
             <a:off x="819150" y="3541365"/>
-            <a:ext cx="3400425" cy="559222"/>
+            <a:ext cx="3467100" cy="559222"/>
           </a:xfrm>
           <a:prstGeom prst="rect">
             <a:avLst/>
@@ -4223,7 +4223,7 @@
           <a:ln/>
         </p:spPr>
         <p:txBody>
-          <a:bodyPr wrap="square" lIns="0" tIns="0" rIns="0" bIns="0" rtlCol="0" anchor="ctr"/>
+          <a:bodyPr wrap="none" lIns="0" tIns="0" rIns="0" bIns="0" rtlCol="0" anchor="ctr"/>
           <a:lstStyle/>
           <a:p>
             <a:pPr algn="l" indent="0" marL="0">
@@ -4289,7 +4289,7 @@
           <a:ln/>
         </p:spPr>
         <p:txBody>
-          <a:bodyPr wrap="square" lIns="0" tIns="0" rIns="0" bIns="0" rtlCol="0" anchor="ctr"/>
+          <a:bodyPr wrap="none" lIns="0" tIns="0" rIns="0" bIns="0" rtlCol="0" anchor="ctr"/>
           <a:lstStyle/>
           <a:p>
             <a:pPr algn="l" indent="0" marL="0">
@@ -4355,7 +4355,7 @@
           <a:ln/>
         </p:spPr>
         <p:txBody>
-          <a:bodyPr wrap="square" lIns="0" tIns="0" rIns="0" bIns="0" rtlCol="0" anchor="ctr"/>
+          <a:bodyPr wrap="none" lIns="0" tIns="0" rIns="0" bIns="0" rtlCol="0" anchor="ctr"/>
           <a:lstStyle/>
           <a:p>
             <a:pPr algn="l" indent="0" marL="0">
@@ -4436,7 +4436,7 @@
         <p:spPr>
           <a:xfrm>
             <a:off x="609600" y="4678710"/>
-            <a:ext cx="5343525" cy="319980"/>
+            <a:ext cx="5448300" cy="319980"/>
           </a:xfrm>
           <a:prstGeom prst="rect">
             <a:avLst/>
@@ -4487,7 +4487,7 @@
           <a:ln/>
         </p:spPr>
         <p:txBody>
-          <a:bodyPr wrap="square" lIns="0" tIns="0" rIns="0" bIns="0" rtlCol="0" anchor="ctr"/>
+          <a:bodyPr wrap="none" lIns="0" tIns="0" rIns="0" bIns="0" rtlCol="0" anchor="ctr"/>
           <a:lstStyle/>
           <a:p>
             <a:pPr algn="r" indent="0" marL="0">
@@ -6848,7 +6848,7 @@
           <a:ln/>
         </p:spPr>
         <p:txBody>
-          <a:bodyPr wrap="square" lIns="0" tIns="0" rIns="0" bIns="0" rtlCol="0" anchor="ctr"/>
+          <a:bodyPr wrap="none" lIns="0" tIns="0" rIns="0" bIns="0" rtlCol="0" anchor="ctr"/>
           <a:lstStyle/>
           <a:p>
             <a:pPr algn="l" indent="0" marL="0">
@@ -6890,7 +6890,7 @@
           <a:ln/>
         </p:spPr>
         <p:txBody>
-          <a:bodyPr wrap="square" lIns="0" tIns="0" rIns="0" bIns="0" rtlCol="0" anchor="ctr"/>
+          <a:bodyPr wrap="none" lIns="0" tIns="0" rIns="0" bIns="0" rtlCol="0" anchor="ctr"/>
           <a:lstStyle/>
           <a:p>
             <a:pPr algn="l" indent="0" marL="0">
@@ -6978,7 +6978,7 @@
           <a:ln/>
         </p:spPr>
         <p:txBody>
-          <a:bodyPr wrap="square" lIns="0" tIns="0" rIns="0" bIns="0" rtlCol="0" anchor="ctr"/>
+          <a:bodyPr wrap="none" lIns="0" tIns="0" rIns="0" bIns="0" rtlCol="0" anchor="ctr"/>
           <a:lstStyle/>
           <a:p>
             <a:pPr algn="l" indent="0" marL="0">
@@ -7011,7 +7011,7 @@
         <p:spPr>
           <a:xfrm>
             <a:off x="1066800" y="1609725"/>
-            <a:ext cx="3225546" cy="346621"/>
+            <a:ext cx="3288792" cy="346621"/>
           </a:xfrm>
           <a:prstGeom prst="rect">
             <a:avLst/>
@@ -7125,7 +7125,7 @@
           <a:ln/>
         </p:spPr>
         <p:txBody>
-          <a:bodyPr wrap="square" lIns="0" tIns="0" rIns="0" bIns="0" rtlCol="0" anchor="ctr"/>
+          <a:bodyPr wrap="none" lIns="0" tIns="0" rIns="0" bIns="0" rtlCol="0" anchor="ctr"/>
           <a:lstStyle/>
           <a:p>
             <a:pPr algn="l" indent="0" marL="0">
@@ -7167,7 +7167,7 @@
           <a:ln/>
         </p:spPr>
         <p:txBody>
-          <a:bodyPr wrap="square" lIns="0" tIns="0" rIns="0" bIns="0" rtlCol="0" anchor="ctr"/>
+          <a:bodyPr wrap="none" lIns="0" tIns="0" rIns="0" bIns="0" rtlCol="0" anchor="ctr"/>
           <a:lstStyle/>
           <a:p>
             <a:pPr algn="l" indent="0" marL="0">
@@ -7209,7 +7209,7 @@
           <a:ln/>
         </p:spPr>
         <p:txBody>
-          <a:bodyPr wrap="square" lIns="0" tIns="0" rIns="0" bIns="0" rtlCol="0" anchor="ctr"/>
+          <a:bodyPr wrap="none" lIns="0" tIns="0" rIns="0" bIns="0" rtlCol="0" anchor="ctr"/>
           <a:lstStyle/>
           <a:p>
             <a:pPr algn="l" indent="0" marL="0">
@@ -7273,7 +7273,7 @@
           <a:ln/>
         </p:spPr>
         <p:txBody>
-          <a:bodyPr wrap="square" lIns="0" tIns="0" rIns="0" bIns="0" rtlCol="0" anchor="ctr"/>
+          <a:bodyPr wrap="none" lIns="0" tIns="0" rIns="0" bIns="0" rtlCol="0" anchor="ctr"/>
           <a:lstStyle/>
           <a:p>
             <a:pPr algn="l" indent="0" marL="0">
@@ -7315,7 +7315,7 @@
           <a:ln/>
         </p:spPr>
         <p:txBody>
-          <a:bodyPr wrap="square" lIns="0" tIns="0" rIns="0" bIns="0" rtlCol="0" anchor="ctr"/>
+          <a:bodyPr wrap="none" lIns="0" tIns="0" rIns="0" bIns="0" rtlCol="0" anchor="ctr"/>
           <a:lstStyle/>
           <a:p>
             <a:pPr algn="l" indent="0" marL="0">
@@ -7379,7 +7379,7 @@
           <a:ln/>
         </p:spPr>
         <p:txBody>
-          <a:bodyPr wrap="square" lIns="0" tIns="0" rIns="0" bIns="0" rtlCol="0" anchor="ctr"/>
+          <a:bodyPr wrap="none" lIns="0" tIns="0" rIns="0" bIns="0" rtlCol="0" anchor="ctr"/>
           <a:lstStyle/>
           <a:p>
             <a:pPr algn="l" indent="0" marL="0">
@@ -7421,7 +7421,7 @@
           <a:ln/>
         </p:spPr>
         <p:txBody>
-          <a:bodyPr wrap="square" lIns="0" tIns="0" rIns="0" bIns="0" rtlCol="0" anchor="ctr"/>
+          <a:bodyPr wrap="none" lIns="0" tIns="0" rIns="0" bIns="0" rtlCol="0" anchor="ctr"/>
           <a:lstStyle/>
           <a:p>
             <a:pPr algn="l" indent="0" marL="0">
@@ -7485,7 +7485,7 @@
           <a:ln/>
         </p:spPr>
         <p:txBody>
-          <a:bodyPr wrap="square" lIns="0" tIns="0" rIns="0" bIns="0" rtlCol="0" anchor="ctr"/>
+          <a:bodyPr wrap="none" lIns="0" tIns="0" rIns="0" bIns="0" rtlCol="0" anchor="ctr"/>
           <a:lstStyle/>
           <a:p>
             <a:pPr algn="l" indent="0" marL="0">
@@ -7518,7 +7518,7 @@
         <p:spPr>
           <a:xfrm>
             <a:off x="3219450" y="3308970"/>
-            <a:ext cx="893826" cy="639961"/>
+            <a:ext cx="911352" cy="639961"/>
           </a:xfrm>
           <a:prstGeom prst="rect">
             <a:avLst/>
@@ -7591,7 +7591,7 @@
           <a:ln/>
         </p:spPr>
         <p:txBody>
-          <a:bodyPr wrap="square" lIns="95250" tIns="0" rIns="95250" bIns="0" rtlCol="0" anchor="ctr"/>
+          <a:bodyPr wrap="none" lIns="95250" tIns="0" rIns="95250" bIns="0" rtlCol="0" anchor="ctr"/>
           <a:lstStyle/>
           <a:p>
             <a:pPr algn="ctr" indent="0" marL="0">
@@ -7624,7 +7624,7 @@
         <p:spPr>
           <a:xfrm>
             <a:off x="4724400" y="1741140"/>
-            <a:ext cx="2720340" cy="388590"/>
+            <a:ext cx="2773680" cy="388590"/>
           </a:xfrm>
           <a:prstGeom prst="rect">
             <a:avLst/>
@@ -7666,7 +7666,7 @@
         <p:spPr>
           <a:xfrm>
             <a:off x="4724400" y="2205930"/>
-            <a:ext cx="2720340" cy="519931"/>
+            <a:ext cx="2773680" cy="519931"/>
           </a:xfrm>
           <a:prstGeom prst="rect">
             <a:avLst/>
@@ -7775,7 +7775,7 @@
           <a:ln/>
         </p:spPr>
         <p:txBody>
-          <a:bodyPr wrap="square" lIns="0" tIns="0" rIns="0" bIns="0" rtlCol="0" anchor="ctr"/>
+          <a:bodyPr wrap="none" lIns="0" tIns="0" rIns="0" bIns="0" rtlCol="0" anchor="ctr"/>
           <a:lstStyle/>
           <a:p>
             <a:pPr algn="r" indent="0" marL="0">
@@ -7889,7 +7889,7 @@
           <a:ln/>
         </p:spPr>
         <p:txBody>
-          <a:bodyPr wrap="square" lIns="0" tIns="0" rIns="0" bIns="0" rtlCol="0" anchor="ctr"/>
+          <a:bodyPr wrap="none" lIns="0" tIns="0" rIns="0" bIns="0" rtlCol="0" anchor="ctr"/>
           <a:lstStyle/>
           <a:p>
             <a:pPr algn="l" indent="0" marL="0">
@@ -7922,7 +7922,7 @@
         <p:spPr>
           <a:xfrm>
             <a:off x="4724400" y="4110930"/>
-            <a:ext cx="3886200" cy="308521"/>
+            <a:ext cx="3962400" cy="308521"/>
           </a:xfrm>
           <a:prstGeom prst="rect">
             <a:avLst/>
@@ -7973,7 +7973,7 @@
           <a:ln/>
         </p:spPr>
         <p:txBody>
-          <a:bodyPr wrap="square" lIns="0" tIns="0" rIns="0" bIns="0" rtlCol="0" anchor="ctr"/>
+          <a:bodyPr wrap="none" lIns="0" tIns="0" rIns="0" bIns="0" rtlCol="0" anchor="ctr"/>
           <a:lstStyle/>
           <a:p>
             <a:pPr algn="l" indent="0" marL="0">
@@ -8015,7 +8015,7 @@
           <a:ln/>
         </p:spPr>
         <p:txBody>
-          <a:bodyPr wrap="square" lIns="0" tIns="0" rIns="0" bIns="0" rtlCol="0" anchor="ctr"/>
+          <a:bodyPr wrap="none" lIns="0" tIns="0" rIns="0" bIns="0" rtlCol="0" anchor="ctr"/>
           <a:lstStyle/>
           <a:p>
             <a:pPr algn="r" indent="0" marL="0">
@@ -10140,7 +10140,7 @@
           <a:ln/>
         </p:spPr>
         <p:txBody>
-          <a:bodyPr wrap="square" lIns="0" tIns="0" rIns="0" bIns="0" rtlCol="0" anchor="ctr"/>
+          <a:bodyPr wrap="none" lIns="0" tIns="0" rIns="0" bIns="0" rtlCol="0" anchor="ctr"/>
           <a:lstStyle/>
           <a:p>
             <a:pPr algn="l" indent="0" marL="0">
@@ -10182,7 +10182,7 @@
           <a:ln/>
         </p:spPr>
         <p:txBody>
-          <a:bodyPr wrap="square" lIns="0" tIns="0" rIns="0" bIns="0" rtlCol="0" anchor="ctr"/>
+          <a:bodyPr wrap="none" lIns="0" tIns="0" rIns="0" bIns="0" rtlCol="0" anchor="ctr"/>
           <a:lstStyle/>
           <a:p>
             <a:pPr algn="l" indent="0" marL="0">
@@ -10246,7 +10246,7 @@
           <a:ln/>
         </p:spPr>
         <p:txBody>
-          <a:bodyPr wrap="square" lIns="95250" tIns="0" rIns="95250" bIns="0" rtlCol="0" anchor="ctr"/>
+          <a:bodyPr wrap="none" lIns="95250" tIns="0" rIns="95250" bIns="0" rtlCol="0" anchor="ctr"/>
           <a:lstStyle/>
           <a:p>
             <a:pPr algn="ctr" indent="0" marL="0">
@@ -10288,7 +10288,7 @@
           <a:ln/>
         </p:spPr>
         <p:txBody>
-          <a:bodyPr wrap="square" lIns="0" tIns="0" rIns="0" bIns="0" rtlCol="0" anchor="ctr"/>
+          <a:bodyPr wrap="none" lIns="0" tIns="0" rIns="0" bIns="0" rtlCol="0" anchor="ctr"/>
           <a:lstStyle/>
           <a:p>
             <a:pPr algn="l" indent="0" marL="0">
@@ -10347,7 +10347,7 @@
           <a:ln/>
         </p:spPr>
         <p:txBody>
-          <a:bodyPr wrap="square" lIns="0" tIns="0" rIns="0" bIns="0" rtlCol="0" anchor="ctr"/>
+          <a:bodyPr wrap="none" lIns="0" tIns="0" rIns="0" bIns="0" rtlCol="0" anchor="ctr"/>
           <a:lstStyle/>
           <a:p>
             <a:pPr algn="r" indent="0" marL="0">
@@ -10453,7 +10453,7 @@
           <a:ln/>
         </p:spPr>
         <p:txBody>
-          <a:bodyPr wrap="square" lIns="0" tIns="0" rIns="0" bIns="0" rtlCol="0" anchor="ctr"/>
+          <a:bodyPr wrap="none" lIns="0" tIns="0" rIns="0" bIns="0" rtlCol="0" anchor="ctr"/>
           <a:lstStyle/>
           <a:p>
             <a:pPr algn="r" indent="0" marL="0">
@@ -10559,7 +10559,7 @@
           <a:ln/>
         </p:spPr>
         <p:txBody>
-          <a:bodyPr wrap="square" lIns="0" tIns="0" rIns="0" bIns="0" rtlCol="0" anchor="ctr"/>
+          <a:bodyPr wrap="none" lIns="0" tIns="0" rIns="0" bIns="0" rtlCol="0" anchor="ctr"/>
           <a:lstStyle/>
           <a:p>
             <a:pPr algn="r" indent="0" marL="0">
@@ -10665,7 +10665,7 @@
           <a:ln/>
         </p:spPr>
         <p:txBody>
-          <a:bodyPr wrap="square" lIns="0" tIns="0" rIns="0" bIns="0" rtlCol="0" anchor="ctr"/>
+          <a:bodyPr wrap="none" lIns="0" tIns="0" rIns="0" bIns="0" rtlCol="0" anchor="ctr"/>
           <a:lstStyle/>
           <a:p>
             <a:pPr algn="r" indent="0" marL="0">
@@ -10771,7 +10771,7 @@
           <a:ln/>
         </p:spPr>
         <p:txBody>
-          <a:bodyPr wrap="square" lIns="0" tIns="0" rIns="0" bIns="0" rtlCol="0" anchor="ctr"/>
+          <a:bodyPr wrap="none" lIns="0" tIns="0" rIns="0" bIns="0" rtlCol="0" anchor="ctr"/>
           <a:lstStyle/>
           <a:p>
             <a:pPr algn="r" indent="0" marL="0">
@@ -10868,7 +10868,7 @@
         <p:spPr>
           <a:xfrm>
             <a:off x="609600" y="3333750"/>
-            <a:ext cx="4177665" cy="462781"/>
+            <a:ext cx="4259580" cy="462781"/>
           </a:xfrm>
           <a:prstGeom prst="rect">
             <a:avLst/>
@@ -10941,7 +10941,7 @@
           <a:ln/>
         </p:spPr>
         <p:txBody>
-          <a:bodyPr wrap="square" lIns="0" tIns="0" rIns="0" bIns="0" rtlCol="0" anchor="ctr"/>
+          <a:bodyPr wrap="none" lIns="0" tIns="0" rIns="0" bIns="0" rtlCol="0" anchor="ctr"/>
           <a:lstStyle/>
           <a:p>
             <a:pPr algn="l" indent="0" marL="0">
@@ -10983,7 +10983,7 @@
           <a:ln/>
         </p:spPr>
         <p:txBody>
-          <a:bodyPr wrap="square" lIns="0" tIns="0" rIns="0" bIns="0" rtlCol="0" anchor="ctr"/>
+          <a:bodyPr wrap="none" lIns="0" tIns="0" rIns="0" bIns="0" rtlCol="0" anchor="ctr"/>
           <a:lstStyle/>
           <a:p>
             <a:pPr algn="l" indent="0" marL="0">
@@ -11025,7 +11025,7 @@
           <a:ln/>
         </p:spPr>
         <p:txBody>
-          <a:bodyPr wrap="square" lIns="0" tIns="0" rIns="0" bIns="0" rtlCol="0" anchor="ctr"/>
+          <a:bodyPr wrap="none" lIns="0" tIns="0" rIns="0" bIns="0" rtlCol="0" anchor="ctr"/>
           <a:lstStyle/>
           <a:p>
             <a:pPr algn="l" indent="0" marL="0">
@@ -11058,7 +11058,7 @@
         <p:spPr>
           <a:xfrm>
             <a:off x="5410200" y="2514526"/>
-            <a:ext cx="2914650" cy="537121"/>
+            <a:ext cx="2971800" cy="537121"/>
           </a:xfrm>
           <a:prstGeom prst="rect">
             <a:avLst/>
@@ -11158,7 +11158,7 @@
         <p:spPr>
           <a:xfrm>
             <a:off x="5200650" y="3333750"/>
-            <a:ext cx="3400425" cy="308521"/>
+            <a:ext cx="3467100" cy="308521"/>
           </a:xfrm>
           <a:prstGeom prst="rect">
             <a:avLst/>
@@ -11232,7 +11232,7 @@
           <a:ln/>
         </p:spPr>
         <p:txBody>
-          <a:bodyPr wrap="square" lIns="0" tIns="0" rIns="0" bIns="0" rtlCol="0" anchor="ctr"/>
+          <a:bodyPr wrap="none" lIns="0" tIns="0" rIns="0" bIns="0" rtlCol="0" anchor="ctr"/>
           <a:lstStyle/>
           <a:p>
             <a:pPr algn="l" indent="0" marL="0">
@@ -11298,7 +11298,7 @@
           <a:ln/>
         </p:spPr>
         <p:txBody>
-          <a:bodyPr wrap="square" lIns="0" tIns="0" rIns="0" bIns="0" rtlCol="0" anchor="ctr"/>
+          <a:bodyPr wrap="none" lIns="0" tIns="0" rIns="0" bIns="0" rtlCol="0" anchor="ctr"/>
           <a:lstStyle/>
           <a:p>
             <a:pPr algn="l" indent="0" marL="0">
@@ -11381,7 +11381,7 @@
           <a:ln/>
         </p:spPr>
         <p:txBody>
-          <a:bodyPr wrap="square" lIns="0" tIns="0" rIns="0" bIns="0" rtlCol="0" anchor="ctr"/>
+          <a:bodyPr wrap="none" lIns="0" tIns="0" rIns="0" bIns="0" rtlCol="0" anchor="ctr"/>
           <a:lstStyle/>
           <a:p>
             <a:pPr algn="l" indent="0" marL="0">
@@ -11440,7 +11440,7 @@
           <a:ln/>
         </p:spPr>
         <p:txBody>
-          <a:bodyPr wrap="square" lIns="0" tIns="0" rIns="0" bIns="0" rtlCol="0" anchor="ctr"/>
+          <a:bodyPr wrap="none" lIns="0" tIns="0" rIns="0" bIns="0" rtlCol="0" anchor="ctr"/>
           <a:lstStyle/>
           <a:p>
             <a:pPr algn="l" indent="0" marL="0">
@@ -11482,7 +11482,7 @@
           <a:ln/>
         </p:spPr>
         <p:txBody>
-          <a:bodyPr wrap="square" lIns="0" tIns="0" rIns="0" bIns="0" rtlCol="0" anchor="ctr"/>
+          <a:bodyPr wrap="none" lIns="0" tIns="0" rIns="0" bIns="0" rtlCol="0" anchor="ctr"/>
           <a:lstStyle/>
           <a:p>
             <a:pPr algn="r" indent="0" marL="0">
@@ -13452,7 +13452,7 @@
           <a:ln/>
         </p:spPr>
         <p:txBody>
-          <a:bodyPr wrap="square" lIns="0" tIns="0" rIns="0" bIns="0" rtlCol="0" anchor="ctr"/>
+          <a:bodyPr wrap="none" lIns="0" tIns="0" rIns="0" bIns="0" rtlCol="0" anchor="ctr"/>
           <a:lstStyle/>
           <a:p>
             <a:pPr algn="l" indent="0" marL="0">
@@ -13485,7 +13485,7 @@
         <p:spPr>
           <a:xfrm>
             <a:off x="609600" y="617190"/>
-            <a:ext cx="7286625" cy="685800"/>
+            <a:ext cx="7429500" cy="685800"/>
           </a:xfrm>
           <a:prstGeom prst="rect">
             <a:avLst/>
@@ -13582,7 +13582,7 @@
           <a:ln/>
         </p:spPr>
         <p:txBody>
-          <a:bodyPr wrap="square" lIns="0" tIns="0" rIns="0" bIns="0" rtlCol="0" anchor="ctr"/>
+          <a:bodyPr wrap="none" lIns="0" tIns="0" rIns="0" bIns="0" rtlCol="0" anchor="ctr"/>
           <a:lstStyle/>
           <a:p>
             <a:pPr algn="l" indent="0" marL="0">
@@ -13624,7 +13624,7 @@
           <a:ln/>
         </p:spPr>
         <p:txBody>
-          <a:bodyPr wrap="square" lIns="0" tIns="0" rIns="0" bIns="0" rtlCol="0" anchor="ctr"/>
+          <a:bodyPr wrap="none" lIns="0" tIns="0" rIns="0" bIns="0" rtlCol="0" anchor="ctr"/>
           <a:lstStyle/>
           <a:p>
             <a:pPr algn="l" indent="0" marL="0">
@@ -13712,7 +13712,7 @@
           <a:ln/>
         </p:spPr>
         <p:txBody>
-          <a:bodyPr wrap="square" lIns="0" tIns="0" rIns="0" bIns="0" rtlCol="0" anchor="ctr"/>
+          <a:bodyPr wrap="none" lIns="0" tIns="0" rIns="0" bIns="0" rtlCol="0" anchor="ctr"/>
           <a:lstStyle/>
           <a:p>
             <a:pPr algn="l" indent="0" marL="0">
@@ -13745,7 +13745,7 @@
         <p:spPr>
           <a:xfrm>
             <a:off x="1066800" y="2093565"/>
-            <a:ext cx="3225546" cy="333375"/>
+            <a:ext cx="3288792" cy="333375"/>
           </a:xfrm>
           <a:prstGeom prst="rect">
             <a:avLst/>
@@ -13842,7 +13842,7 @@
           <a:ln/>
         </p:spPr>
         <p:txBody>
-          <a:bodyPr wrap="square" lIns="0" tIns="0" rIns="0" bIns="0" rtlCol="0" anchor="ctr"/>
+          <a:bodyPr wrap="none" lIns="0" tIns="0" rIns="0" bIns="0" rtlCol="0" anchor="ctr"/>
           <a:lstStyle/>
           <a:p>
             <a:pPr algn="l" indent="0" marL="0">
@@ -13884,7 +13884,7 @@
           <a:ln/>
         </p:spPr>
         <p:txBody>
-          <a:bodyPr wrap="square" lIns="0" tIns="0" rIns="0" bIns="0" rtlCol="0" anchor="ctr"/>
+          <a:bodyPr wrap="none" lIns="0" tIns="0" rIns="0" bIns="0" rtlCol="0" anchor="ctr"/>
           <a:lstStyle/>
           <a:p>
             <a:pPr algn="l" indent="0" marL="0">
@@ -13970,7 +13970,7 @@
           <a:ln/>
         </p:spPr>
         <p:txBody>
-          <a:bodyPr wrap="square" lIns="85725" tIns="0" rIns="85725" bIns="0" rtlCol="0" anchor="ctr"/>
+          <a:bodyPr wrap="none" lIns="85725" tIns="0" rIns="85725" bIns="0" rtlCol="0" anchor="ctr"/>
           <a:lstStyle/>
           <a:p>
             <a:pPr algn="ctr" indent="0" marL="0">
@@ -14012,7 +14012,7 @@
           <a:ln/>
         </p:spPr>
         <p:txBody>
-          <a:bodyPr wrap="square" lIns="0" tIns="0" rIns="0" bIns="0" rtlCol="0" anchor="ctr"/>
+          <a:bodyPr wrap="none" lIns="0" tIns="0" rIns="0" bIns="0" rtlCol="0" anchor="ctr"/>
           <a:lstStyle/>
           <a:p>
             <a:pPr algn="l" indent="0" marL="0">
@@ -14045,7 +14045,7 @@
         <p:spPr>
           <a:xfrm>
             <a:off x="800100" y="3691830"/>
-            <a:ext cx="2234565" cy="500063"/>
+            <a:ext cx="2278380" cy="500063"/>
           </a:xfrm>
           <a:prstGeom prst="rect">
             <a:avLst/>
@@ -14142,7 +14142,7 @@
           <a:ln/>
         </p:spPr>
         <p:txBody>
-          <a:bodyPr wrap="square" lIns="95250" tIns="0" rIns="95250" bIns="0" rtlCol="0" anchor="ctr"/>
+          <a:bodyPr wrap="none" lIns="95250" tIns="0" rIns="95250" bIns="0" rtlCol="0" anchor="ctr"/>
           <a:lstStyle/>
           <a:p>
             <a:pPr algn="ctr" indent="0" marL="0">
@@ -14184,7 +14184,7 @@
           <a:ln/>
         </p:spPr>
         <p:txBody>
-          <a:bodyPr wrap="square" lIns="0" tIns="0" rIns="0" bIns="0" rtlCol="0" anchor="ctr"/>
+          <a:bodyPr wrap="none" lIns="0" tIns="0" rIns="0" bIns="0" rtlCol="0" anchor="ctr"/>
           <a:lstStyle/>
           <a:p>
             <a:pPr algn="l" indent="0" marL="0">
@@ -14250,7 +14250,7 @@
           <a:ln/>
         </p:spPr>
         <p:txBody>
-          <a:bodyPr wrap="square" lIns="0" tIns="0" rIns="0" bIns="0" rtlCol="0" anchor="ctr"/>
+          <a:bodyPr wrap="none" lIns="0" tIns="0" rIns="0" bIns="0" rtlCol="0" anchor="ctr"/>
           <a:lstStyle/>
           <a:p>
             <a:pPr algn="l" indent="0" marL="0">
@@ -14348,7 +14348,7 @@
           <a:ln/>
         </p:spPr>
         <p:txBody>
-          <a:bodyPr wrap="square" lIns="0" tIns="0" rIns="0" bIns="0" rtlCol="0" anchor="ctr"/>
+          <a:bodyPr wrap="none" lIns="0" tIns="0" rIns="0" bIns="0" rtlCol="0" anchor="ctr"/>
           <a:lstStyle/>
           <a:p>
             <a:pPr algn="l" indent="0" marL="0">
@@ -14446,7 +14446,7 @@
           <a:ln/>
         </p:spPr>
         <p:txBody>
-          <a:bodyPr wrap="square" lIns="0" tIns="0" rIns="0" bIns="0" rtlCol="0" anchor="ctr"/>
+          <a:bodyPr wrap="none" lIns="0" tIns="0" rIns="0" bIns="0" rtlCol="0" anchor="ctr"/>
           <a:lstStyle/>
           <a:p>
             <a:pPr algn="l" indent="0" marL="0">
@@ -14526,7 +14526,7 @@
         <p:spPr>
           <a:xfrm>
             <a:off x="5067300" y="3414713"/>
-            <a:ext cx="3536442" cy="321469"/>
+            <a:ext cx="3605784" cy="321469"/>
           </a:xfrm>
           <a:prstGeom prst="rect">
             <a:avLst/>
@@ -14626,7 +14626,7 @@
         <p:spPr>
           <a:xfrm>
             <a:off x="5067300" y="3821906"/>
-            <a:ext cx="3536442" cy="321469"/>
+            <a:ext cx="3605784" cy="321469"/>
           </a:xfrm>
           <a:prstGeom prst="rect">
             <a:avLst/>
@@ -14677,7 +14677,7 @@
           <a:ln/>
         </p:spPr>
         <p:txBody>
-          <a:bodyPr wrap="square" lIns="0" tIns="0" rIns="0" bIns="0" rtlCol="0" anchor="ctr"/>
+          <a:bodyPr wrap="none" lIns="0" tIns="0" rIns="0" bIns="0" rtlCol="0" anchor="ctr"/>
           <a:lstStyle/>
           <a:p>
             <a:pPr algn="l" indent="0" marL="0">
@@ -14719,7 +14719,7 @@
           <a:ln/>
         </p:spPr>
         <p:txBody>
-          <a:bodyPr wrap="square" lIns="0" tIns="0" rIns="0" bIns="0" rtlCol="0" anchor="ctr"/>
+          <a:bodyPr wrap="none" lIns="0" tIns="0" rIns="0" bIns="0" rtlCol="0" anchor="ctr"/>
           <a:lstStyle/>
           <a:p>
             <a:pPr algn="r" indent="0" marL="0">
@@ -16884,7 +16884,7 @@
           <a:ln/>
         </p:spPr>
         <p:txBody>
-          <a:bodyPr wrap="square" lIns="0" tIns="0" rIns="0" bIns="0" rtlCol="0" anchor="ctr"/>
+          <a:bodyPr wrap="none" lIns="0" tIns="0" rIns="0" bIns="0" rtlCol="0" anchor="ctr"/>
           <a:lstStyle/>
           <a:p>
             <a:pPr algn="l" indent="0" marL="0">
@@ -16926,7 +16926,7 @@
           <a:ln/>
         </p:spPr>
         <p:txBody>
-          <a:bodyPr wrap="square" lIns="0" tIns="0" rIns="0" bIns="0" rtlCol="0" anchor="ctr"/>
+          <a:bodyPr wrap="none" lIns="0" tIns="0" rIns="0" bIns="0" rtlCol="0" anchor="ctr"/>
           <a:lstStyle/>
           <a:p>
             <a:pPr algn="l" indent="0" marL="0">
@@ -16990,7 +16990,7 @@
           <a:ln/>
         </p:spPr>
         <p:txBody>
-          <a:bodyPr wrap="square" lIns="95250" tIns="0" rIns="95250" bIns="0" rtlCol="0" anchor="ctr"/>
+          <a:bodyPr wrap="none" lIns="95250" tIns="0" rIns="95250" bIns="0" rtlCol="0" anchor="ctr"/>
           <a:lstStyle/>
           <a:p>
             <a:pPr algn="ctr" indent="0" marL="0">
@@ -17078,7 +17078,7 @@
           <a:ln/>
         </p:spPr>
         <p:txBody>
-          <a:bodyPr wrap="square" lIns="95250" tIns="0" rIns="95250" bIns="0" rtlCol="0" anchor="ctr"/>
+          <a:bodyPr wrap="none" lIns="95250" tIns="0" rIns="95250" bIns="0" rtlCol="0" anchor="ctr"/>
           <a:lstStyle/>
           <a:p>
             <a:pPr algn="l" indent="0" marL="0">
@@ -17143,7 +17143,7 @@
           <a:ln/>
         </p:spPr>
         <p:txBody>
-          <a:bodyPr wrap="square" lIns="95250" tIns="0" rIns="95250" bIns="0" rtlCol="0" anchor="ctr"/>
+          <a:bodyPr wrap="none" lIns="95250" tIns="0" rIns="95250" bIns="0" rtlCol="0" anchor="ctr"/>
           <a:lstStyle/>
           <a:p>
             <a:pPr algn="l" indent="0" marL="0">
@@ -17208,7 +17208,7 @@
           <a:ln/>
         </p:spPr>
         <p:txBody>
-          <a:bodyPr wrap="square" lIns="95250" tIns="0" rIns="95250" bIns="0" rtlCol="0" anchor="ctr"/>
+          <a:bodyPr wrap="none" lIns="95250" tIns="0" rIns="95250" bIns="0" rtlCol="0" anchor="ctr"/>
           <a:lstStyle/>
           <a:p>
             <a:pPr algn="l" indent="0" marL="0">
@@ -17273,7 +17273,7 @@
           <a:ln/>
         </p:spPr>
         <p:txBody>
-          <a:bodyPr wrap="square" lIns="95250" tIns="0" rIns="95250" bIns="0" rtlCol="0" anchor="ctr"/>
+          <a:bodyPr wrap="none" lIns="95250" tIns="0" rIns="95250" bIns="0" rtlCol="0" anchor="ctr"/>
           <a:lstStyle/>
           <a:p>
             <a:pPr algn="l" indent="0" marL="0">
@@ -17338,7 +17338,7 @@
           <a:ln/>
         </p:spPr>
         <p:txBody>
-          <a:bodyPr wrap="square" lIns="95250" tIns="0" rIns="95250" bIns="0" rtlCol="0" anchor="ctr"/>
+          <a:bodyPr wrap="none" lIns="95250" tIns="0" rIns="95250" bIns="0" rtlCol="0" anchor="ctr"/>
           <a:lstStyle/>
           <a:p>
             <a:pPr algn="l" indent="0" marL="0">
@@ -17414,7 +17414,7 @@
         <p:spPr>
           <a:xfrm>
             <a:off x="609600" y="2281684"/>
-            <a:ext cx="1454972" cy="471488"/>
+            <a:ext cx="1483501" cy="471488"/>
           </a:xfrm>
           <a:prstGeom prst="rect">
             <a:avLst/>
@@ -17479,7 +17479,7 @@
         <p:spPr>
           <a:xfrm>
             <a:off x="2036043" y="2281684"/>
-            <a:ext cx="3314124" cy="471488"/>
+            <a:ext cx="3379107" cy="471488"/>
           </a:xfrm>
           <a:prstGeom prst="rect">
             <a:avLst/>
@@ -17544,7 +17544,7 @@
         <p:spPr>
           <a:xfrm>
             <a:off x="5285184" y="2281684"/>
-            <a:ext cx="3314200" cy="471488"/>
+            <a:ext cx="3379184" cy="471488"/>
           </a:xfrm>
           <a:prstGeom prst="rect">
             <a:avLst/>
@@ -17609,7 +17609,7 @@
         <p:spPr>
           <a:xfrm>
             <a:off x="609600" y="2753171"/>
-            <a:ext cx="1454972" cy="471488"/>
+            <a:ext cx="1483501" cy="471488"/>
           </a:xfrm>
           <a:prstGeom prst="rect">
             <a:avLst/>
@@ -17674,7 +17674,7 @@
         <p:spPr>
           <a:xfrm>
             <a:off x="2036043" y="2753171"/>
-            <a:ext cx="3314124" cy="471488"/>
+            <a:ext cx="3379107" cy="471488"/>
           </a:xfrm>
           <a:prstGeom prst="rect">
             <a:avLst/>
@@ -17739,7 +17739,7 @@
         <p:spPr>
           <a:xfrm>
             <a:off x="5285184" y="2753171"/>
-            <a:ext cx="3314200" cy="471488"/>
+            <a:ext cx="3379184" cy="471488"/>
           </a:xfrm>
           <a:prstGeom prst="rect">
             <a:avLst/>
@@ -17834,7 +17834,7 @@
           <a:ln/>
         </p:spPr>
         <p:txBody>
-          <a:bodyPr wrap="square" lIns="85725" tIns="0" rIns="85725" bIns="0" rtlCol="0" anchor="ctr"/>
+          <a:bodyPr wrap="none" lIns="85725" tIns="0" rIns="85725" bIns="0" rtlCol="0" anchor="ctr"/>
           <a:lstStyle/>
           <a:p>
             <a:pPr algn="ctr" indent="0" marL="0">
@@ -17867,7 +17867,7 @@
         <p:spPr>
           <a:xfrm>
             <a:off x="819150" y="3541365"/>
-            <a:ext cx="3400425" cy="520601"/>
+            <a:ext cx="3467100" cy="520601"/>
           </a:xfrm>
           <a:prstGeom prst="rect">
             <a:avLst/>
@@ -17976,7 +17976,7 @@
           <a:ln/>
         </p:spPr>
         <p:txBody>
-          <a:bodyPr wrap="square" lIns="0" tIns="0" rIns="0" bIns="0" rtlCol="0" anchor="ctr"/>
+          <a:bodyPr wrap="none" lIns="0" tIns="0" rIns="0" bIns="0" rtlCol="0" anchor="ctr"/>
           <a:lstStyle/>
           <a:p>
             <a:pPr algn="l" indent="0" marL="0">
@@ -18042,7 +18042,7 @@
           <a:ln/>
         </p:spPr>
         <p:txBody>
-          <a:bodyPr wrap="square" lIns="0" tIns="0" rIns="0" bIns="0" rtlCol="0" anchor="ctr"/>
+          <a:bodyPr wrap="none" lIns="0" tIns="0" rIns="0" bIns="0" rtlCol="0" anchor="ctr"/>
           <a:lstStyle/>
           <a:p>
             <a:pPr algn="l" indent="0" marL="0">
@@ -18108,7 +18108,7 @@
           <a:ln/>
         </p:spPr>
         <p:txBody>
-          <a:bodyPr wrap="square" lIns="0" tIns="0" rIns="0" bIns="0" rtlCol="0" anchor="ctr"/>
+          <a:bodyPr wrap="none" lIns="0" tIns="0" rIns="0" bIns="0" rtlCol="0" anchor="ctr"/>
           <a:lstStyle/>
           <a:p>
             <a:pPr algn="l" indent="0" marL="0">
@@ -18189,7 +18189,7 @@
         <p:spPr>
           <a:xfrm>
             <a:off x="609600" y="4678710"/>
-            <a:ext cx="5343525" cy="319980"/>
+            <a:ext cx="5448300" cy="319980"/>
           </a:xfrm>
           <a:prstGeom prst="rect">
             <a:avLst/>
@@ -18240,7 +18240,7 @@
           <a:ln/>
         </p:spPr>
         <p:txBody>
-          <a:bodyPr wrap="square" lIns="0" tIns="0" rIns="0" bIns="0" rtlCol="0" anchor="ctr"/>
+          <a:bodyPr wrap="none" lIns="0" tIns="0" rIns="0" bIns="0" rtlCol="0" anchor="ctr"/>
           <a:lstStyle/>
           <a:p>
             <a:pPr algn="r" indent="0" marL="0">
@@ -20625,7 +20625,7 @@
           <a:ln/>
         </p:spPr>
         <p:txBody>
-          <a:bodyPr wrap="square" lIns="0" tIns="0" rIns="0" bIns="0" rtlCol="0" anchor="ctr"/>
+          <a:bodyPr wrap="none" lIns="0" tIns="0" rIns="0" bIns="0" rtlCol="0" anchor="ctr"/>
           <a:lstStyle/>
           <a:p>
             <a:pPr algn="l" indent="0" marL="0">
@@ -20658,7 +20658,7 @@
         <p:spPr>
           <a:xfrm>
             <a:off x="609600" y="693390"/>
-            <a:ext cx="5829300" cy="1059061"/>
+            <a:ext cx="5943600" cy="1059061"/>
           </a:xfrm>
           <a:prstGeom prst="rect">
             <a:avLst/>
@@ -20709,7 +20709,7 @@
           <a:ln/>
         </p:spPr>
         <p:txBody>
-          <a:bodyPr wrap="square" lIns="0" tIns="0" rIns="0" bIns="0" rtlCol="0" anchor="ctr"/>
+          <a:bodyPr wrap="none" lIns="0" tIns="0" rIns="0" bIns="0" rtlCol="0" anchor="ctr"/>
           <a:lstStyle/>
           <a:p>
             <a:pPr algn="l" indent="0" marL="0">
@@ -20775,7 +20775,7 @@
           <a:ln/>
         </p:spPr>
         <p:txBody>
-          <a:bodyPr wrap="square" lIns="0" tIns="0" rIns="0" bIns="0" rtlCol="0" anchor="ctr"/>
+          <a:bodyPr wrap="none" lIns="0" tIns="0" rIns="0" bIns="0" rtlCol="0" anchor="ctr"/>
           <a:lstStyle/>
           <a:p>
             <a:pPr algn="l" indent="0" marL="0">
@@ -20839,7 +20839,7 @@
           <a:ln/>
         </p:spPr>
         <p:txBody>
-          <a:bodyPr wrap="square" lIns="0" tIns="0" rIns="0" bIns="0" rtlCol="0" anchor="ctr"/>
+          <a:bodyPr wrap="none" lIns="0" tIns="0" rIns="0" bIns="0" rtlCol="0" anchor="ctr"/>
           <a:lstStyle/>
           <a:p>
             <a:pPr algn="l" indent="0" marL="0">
@@ -20872,7 +20872,7 @@
         <p:spPr>
           <a:xfrm>
             <a:off x="800100" y="3055590"/>
-            <a:ext cx="3575304" cy="482873"/>
+            <a:ext cx="3645408" cy="482873"/>
           </a:xfrm>
           <a:prstGeom prst="rect">
             <a:avLst/>
@@ -20914,7 +20914,7 @@
         <p:spPr>
           <a:xfrm>
             <a:off x="800100" y="3595613"/>
-            <a:ext cx="3575304" cy="319980"/>
+            <a:ext cx="3645408" cy="319980"/>
           </a:xfrm>
           <a:prstGeom prst="rect">
             <a:avLst/>
@@ -20987,7 +20987,7 @@
           <a:ln/>
         </p:spPr>
         <p:txBody>
-          <a:bodyPr wrap="square" lIns="0" tIns="0" rIns="0" bIns="0" rtlCol="0" anchor="ctr"/>
+          <a:bodyPr wrap="none" lIns="0" tIns="0" rIns="0" bIns="0" rtlCol="0" anchor="ctr"/>
           <a:lstStyle/>
           <a:p>
             <a:pPr algn="l" indent="0" marL="0">
@@ -21020,7 +21020,7 @@
         <p:spPr>
           <a:xfrm>
             <a:off x="4838700" y="3055590"/>
-            <a:ext cx="3575304" cy="482873"/>
+            <a:ext cx="3645408" cy="482873"/>
           </a:xfrm>
           <a:prstGeom prst="rect">
             <a:avLst/>
@@ -21062,7 +21062,7 @@
         <p:spPr>
           <a:xfrm>
             <a:off x="4838700" y="3595613"/>
-            <a:ext cx="3575304" cy="319980"/>
+            <a:ext cx="3645408" cy="319980"/>
           </a:xfrm>
           <a:prstGeom prst="rect">
             <a:avLst/>
@@ -21113,7 +21113,7 @@
           <a:ln/>
         </p:spPr>
         <p:txBody>
-          <a:bodyPr wrap="square" lIns="0" tIns="0" rIns="0" bIns="0" rtlCol="0" anchor="ctr"/>
+          <a:bodyPr wrap="none" lIns="0" tIns="0" rIns="0" bIns="0" rtlCol="0" anchor="ctr"/>
           <a:lstStyle/>
           <a:p>
             <a:pPr algn="l" indent="0" marL="0">
@@ -22029,7 +22029,7 @@
           <a:ln/>
         </p:spPr>
         <p:txBody>
-          <a:bodyPr wrap="square" lIns="0" tIns="0" rIns="0" bIns="0" rtlCol="0" anchor="ctr"/>
+          <a:bodyPr wrap="none" lIns="0" tIns="0" rIns="0" bIns="0" rtlCol="0" anchor="ctr"/>
           <a:lstStyle/>
           <a:p>
             <a:pPr algn="l" indent="0" marL="0">
@@ -22071,7 +22071,7 @@
           <a:ln/>
         </p:spPr>
         <p:txBody>
-          <a:bodyPr wrap="square" lIns="0" tIns="0" rIns="0" bIns="0" rtlCol="0" anchor="ctr"/>
+          <a:bodyPr wrap="none" lIns="0" tIns="0" rIns="0" bIns="0" rtlCol="0" anchor="ctr"/>
           <a:lstStyle/>
           <a:p>
             <a:pPr algn="l" indent="0" marL="0">
@@ -22159,7 +22159,7 @@
           <a:ln/>
         </p:spPr>
         <p:txBody>
-          <a:bodyPr wrap="square" lIns="0" tIns="0" rIns="0" bIns="0" rtlCol="0" anchor="ctr"/>
+          <a:bodyPr wrap="none" lIns="0" tIns="0" rIns="0" bIns="0" rtlCol="0" anchor="ctr"/>
           <a:lstStyle/>
           <a:p>
             <a:pPr algn="l" indent="0" marL="0">
@@ -22192,7 +22192,7 @@
         <p:spPr>
           <a:xfrm>
             <a:off x="1066800" y="1609725"/>
-            <a:ext cx="3225546" cy="346621"/>
+            <a:ext cx="3288792" cy="346621"/>
           </a:xfrm>
           <a:prstGeom prst="rect">
             <a:avLst/>
@@ -22306,7 +22306,7 @@
           <a:ln/>
         </p:spPr>
         <p:txBody>
-          <a:bodyPr wrap="square" lIns="0" tIns="0" rIns="0" bIns="0" rtlCol="0" anchor="ctr"/>
+          <a:bodyPr wrap="none" lIns="0" tIns="0" rIns="0" bIns="0" rtlCol="0" anchor="ctr"/>
           <a:lstStyle/>
           <a:p>
             <a:pPr algn="l" indent="0" marL="0">
@@ -22348,7 +22348,7 @@
           <a:ln/>
         </p:spPr>
         <p:txBody>
-          <a:bodyPr wrap="square" lIns="0" tIns="0" rIns="0" bIns="0" rtlCol="0" anchor="ctr"/>
+          <a:bodyPr wrap="none" lIns="0" tIns="0" rIns="0" bIns="0" rtlCol="0" anchor="ctr"/>
           <a:lstStyle/>
           <a:p>
             <a:pPr algn="l" indent="0" marL="0">
@@ -22390,7 +22390,7 @@
           <a:ln/>
         </p:spPr>
         <p:txBody>
-          <a:bodyPr wrap="square" lIns="0" tIns="0" rIns="0" bIns="0" rtlCol="0" anchor="ctr"/>
+          <a:bodyPr wrap="none" lIns="0" tIns="0" rIns="0" bIns="0" rtlCol="0" anchor="ctr"/>
           <a:lstStyle/>
           <a:p>
             <a:pPr algn="l" indent="0" marL="0">
@@ -22454,7 +22454,7 @@
           <a:ln/>
         </p:spPr>
         <p:txBody>
-          <a:bodyPr wrap="square" lIns="0" tIns="0" rIns="0" bIns="0" rtlCol="0" anchor="ctr"/>
+          <a:bodyPr wrap="none" lIns="0" tIns="0" rIns="0" bIns="0" rtlCol="0" anchor="ctr"/>
           <a:lstStyle/>
           <a:p>
             <a:pPr algn="l" indent="0" marL="0">
@@ -22496,7 +22496,7 @@
           <a:ln/>
         </p:spPr>
         <p:txBody>
-          <a:bodyPr wrap="square" lIns="0" tIns="0" rIns="0" bIns="0" rtlCol="0" anchor="ctr"/>
+          <a:bodyPr wrap="none" lIns="0" tIns="0" rIns="0" bIns="0" rtlCol="0" anchor="ctr"/>
           <a:lstStyle/>
           <a:p>
             <a:pPr algn="l" indent="0" marL="0">
@@ -22560,7 +22560,7 @@
           <a:ln/>
         </p:spPr>
         <p:txBody>
-          <a:bodyPr wrap="square" lIns="0" tIns="0" rIns="0" bIns="0" rtlCol="0" anchor="ctr"/>
+          <a:bodyPr wrap="none" lIns="0" tIns="0" rIns="0" bIns="0" rtlCol="0" anchor="ctr"/>
           <a:lstStyle/>
           <a:p>
             <a:pPr algn="l" indent="0" marL="0">
@@ -22602,7 +22602,7 @@
           <a:ln/>
         </p:spPr>
         <p:txBody>
-          <a:bodyPr wrap="square" lIns="0" tIns="0" rIns="0" bIns="0" rtlCol="0" anchor="ctr"/>
+          <a:bodyPr wrap="none" lIns="0" tIns="0" rIns="0" bIns="0" rtlCol="0" anchor="ctr"/>
           <a:lstStyle/>
           <a:p>
             <a:pPr algn="l" indent="0" marL="0">
@@ -22666,7 +22666,7 @@
           <a:ln/>
         </p:spPr>
         <p:txBody>
-          <a:bodyPr wrap="square" lIns="0" tIns="0" rIns="0" bIns="0" rtlCol="0" anchor="ctr"/>
+          <a:bodyPr wrap="none" lIns="0" tIns="0" rIns="0" bIns="0" rtlCol="0" anchor="ctr"/>
           <a:lstStyle/>
           <a:p>
             <a:pPr algn="l" indent="0" marL="0">
@@ -22699,7 +22699,7 @@
         <p:spPr>
           <a:xfrm>
             <a:off x="3219450" y="3308970"/>
-            <a:ext cx="893826" cy="479971"/>
+            <a:ext cx="911352" cy="479971"/>
           </a:xfrm>
           <a:prstGeom prst="rect">
             <a:avLst/>
@@ -22772,7 +22772,7 @@
           <a:ln/>
         </p:spPr>
         <p:txBody>
-          <a:bodyPr wrap="square" lIns="95250" tIns="0" rIns="95250" bIns="0" rtlCol="0" anchor="ctr"/>
+          <a:bodyPr wrap="none" lIns="95250" tIns="0" rIns="95250" bIns="0" rtlCol="0" anchor="ctr"/>
           <a:lstStyle/>
           <a:p>
             <a:pPr algn="ctr" indent="0" marL="0">
@@ -22814,7 +22814,7 @@
           <a:ln/>
         </p:spPr>
         <p:txBody>
-          <a:bodyPr wrap="square" lIns="0" tIns="0" rIns="0" bIns="0" rtlCol="0" anchor="ctr"/>
+          <a:bodyPr wrap="none" lIns="0" tIns="0" rIns="0" bIns="0" rtlCol="0" anchor="ctr"/>
           <a:lstStyle/>
           <a:p>
             <a:pPr algn="l" indent="0" marL="0">
@@ -22847,7 +22847,7 @@
         <p:spPr>
           <a:xfrm>
             <a:off x="4724400" y="2011635"/>
-            <a:ext cx="2720340" cy="371475"/>
+            <a:ext cx="2773680" cy="371475"/>
           </a:xfrm>
           <a:prstGeom prst="rect">
             <a:avLst/>
@@ -22939,7 +22939,7 @@
           <a:ln/>
         </p:spPr>
         <p:txBody>
-          <a:bodyPr wrap="square" lIns="0" tIns="0" rIns="0" bIns="0" rtlCol="0" anchor="ctr"/>
+          <a:bodyPr wrap="none" lIns="0" tIns="0" rIns="0" bIns="0" rtlCol="0" anchor="ctr"/>
           <a:lstStyle/>
           <a:p>
             <a:pPr algn="r" indent="0" marL="0">
@@ -23053,7 +23053,7 @@
           <a:ln/>
         </p:spPr>
         <p:txBody>
-          <a:bodyPr wrap="square" lIns="0" tIns="0" rIns="0" bIns="0" rtlCol="0" anchor="ctr"/>
+          <a:bodyPr wrap="none" lIns="0" tIns="0" rIns="0" bIns="0" rtlCol="0" anchor="ctr"/>
           <a:lstStyle/>
           <a:p>
             <a:pPr algn="l" indent="0" marL="0">
@@ -23086,7 +23086,7 @@
         <p:spPr>
           <a:xfrm>
             <a:off x="4724400" y="4110930"/>
-            <a:ext cx="3886200" cy="331440"/>
+            <a:ext cx="3962400" cy="331440"/>
           </a:xfrm>
           <a:prstGeom prst="rect">
             <a:avLst/>
@@ -23137,7 +23137,7 @@
           <a:ln/>
         </p:spPr>
         <p:txBody>
-          <a:bodyPr wrap="square" lIns="0" tIns="0" rIns="0" bIns="0" rtlCol="0" anchor="ctr"/>
+          <a:bodyPr wrap="none" lIns="0" tIns="0" rIns="0" bIns="0" rtlCol="0" anchor="ctr"/>
           <a:lstStyle/>
           <a:p>
             <a:pPr algn="l" indent="0" marL="0">
@@ -23179,7 +23179,7 @@
           <a:ln/>
         </p:spPr>
         <p:txBody>
-          <a:bodyPr wrap="square" lIns="0" tIns="0" rIns="0" bIns="0" rtlCol="0" anchor="ctr"/>
+          <a:bodyPr wrap="none" lIns="0" tIns="0" rIns="0" bIns="0" rtlCol="0" anchor="ctr"/>
           <a:lstStyle/>
           <a:p>
             <a:pPr algn="r" indent="0" marL="0">
@@ -25304,7 +25304,7 @@
           <a:ln/>
         </p:spPr>
         <p:txBody>
-          <a:bodyPr wrap="square" lIns="0" tIns="0" rIns="0" bIns="0" rtlCol="0" anchor="ctr"/>
+          <a:bodyPr wrap="none" lIns="0" tIns="0" rIns="0" bIns="0" rtlCol="0" anchor="ctr"/>
           <a:lstStyle/>
           <a:p>
             <a:pPr algn="l" indent="0" marL="0">
@@ -25346,7 +25346,7 @@
           <a:ln/>
         </p:spPr>
         <p:txBody>
-          <a:bodyPr wrap="square" lIns="0" tIns="0" rIns="0" bIns="0" rtlCol="0" anchor="ctr"/>
+          <a:bodyPr wrap="none" lIns="0" tIns="0" rIns="0" bIns="0" rtlCol="0" anchor="ctr"/>
           <a:lstStyle/>
           <a:p>
             <a:pPr algn="l" indent="0" marL="0">
@@ -25410,7 +25410,7 @@
           <a:ln/>
         </p:spPr>
         <p:txBody>
-          <a:bodyPr wrap="square" lIns="95250" tIns="0" rIns="95250" bIns="0" rtlCol="0" anchor="ctr"/>
+          <a:bodyPr wrap="none" lIns="95250" tIns="0" rIns="95250" bIns="0" rtlCol="0" anchor="ctr"/>
           <a:lstStyle/>
           <a:p>
             <a:pPr algn="ctr" indent="0" marL="0">
@@ -25452,7 +25452,7 @@
           <a:ln/>
         </p:spPr>
         <p:txBody>
-          <a:bodyPr wrap="square" lIns="0" tIns="0" rIns="0" bIns="0" rtlCol="0" anchor="ctr"/>
+          <a:bodyPr wrap="none" lIns="0" tIns="0" rIns="0" bIns="0" rtlCol="0" anchor="ctr"/>
           <a:lstStyle/>
           <a:p>
             <a:pPr algn="l" indent="0" marL="0">
@@ -25511,7 +25511,7 @@
           <a:ln/>
         </p:spPr>
         <p:txBody>
-          <a:bodyPr wrap="square" lIns="0" tIns="0" rIns="0" bIns="0" rtlCol="0" anchor="ctr"/>
+          <a:bodyPr wrap="none" lIns="0" tIns="0" rIns="0" bIns="0" rtlCol="0" anchor="ctr"/>
           <a:lstStyle/>
           <a:p>
             <a:pPr algn="r" indent="0" marL="0">
@@ -25617,7 +25617,7 @@
           <a:ln/>
         </p:spPr>
         <p:txBody>
-          <a:bodyPr wrap="square" lIns="0" tIns="0" rIns="0" bIns="0" rtlCol="0" anchor="ctr"/>
+          <a:bodyPr wrap="none" lIns="0" tIns="0" rIns="0" bIns="0" rtlCol="0" anchor="ctr"/>
           <a:lstStyle/>
           <a:p>
             <a:pPr algn="r" indent="0" marL="0">
@@ -25723,7 +25723,7 @@
           <a:ln/>
         </p:spPr>
         <p:txBody>
-          <a:bodyPr wrap="square" lIns="0" tIns="0" rIns="0" bIns="0" rtlCol="0" anchor="ctr"/>
+          <a:bodyPr wrap="none" lIns="0" tIns="0" rIns="0" bIns="0" rtlCol="0" anchor="ctr"/>
           <a:lstStyle/>
           <a:p>
             <a:pPr algn="r" indent="0" marL="0">
@@ -25829,7 +25829,7 @@
           <a:ln/>
         </p:spPr>
         <p:txBody>
-          <a:bodyPr wrap="square" lIns="0" tIns="0" rIns="0" bIns="0" rtlCol="0" anchor="ctr"/>
+          <a:bodyPr wrap="none" lIns="0" tIns="0" rIns="0" bIns="0" rtlCol="0" anchor="ctr"/>
           <a:lstStyle/>
           <a:p>
             <a:pPr algn="r" indent="0" marL="0">
@@ -25935,7 +25935,7 @@
           <a:ln/>
         </p:spPr>
         <p:txBody>
-          <a:bodyPr wrap="square" lIns="0" tIns="0" rIns="0" bIns="0" rtlCol="0" anchor="ctr"/>
+          <a:bodyPr wrap="none" lIns="0" tIns="0" rIns="0" bIns="0" rtlCol="0" anchor="ctr"/>
           <a:lstStyle/>
           <a:p>
             <a:pPr algn="r" indent="0" marL="0">
@@ -26032,7 +26032,7 @@
         <p:spPr>
           <a:xfrm>
             <a:off x="609600" y="3333750"/>
-            <a:ext cx="4177665" cy="331440"/>
+            <a:ext cx="4259580" cy="331440"/>
           </a:xfrm>
           <a:prstGeom prst="rect">
             <a:avLst/>
@@ -26105,7 +26105,7 @@
           <a:ln/>
         </p:spPr>
         <p:txBody>
-          <a:bodyPr wrap="square" lIns="0" tIns="0" rIns="0" bIns="0" rtlCol="0" anchor="ctr"/>
+          <a:bodyPr wrap="none" lIns="0" tIns="0" rIns="0" bIns="0" rtlCol="0" anchor="ctr"/>
           <a:lstStyle/>
           <a:p>
             <a:pPr algn="l" indent="0" marL="0">
@@ -26147,7 +26147,7 @@
           <a:ln/>
         </p:spPr>
         <p:txBody>
-          <a:bodyPr wrap="square" lIns="0" tIns="0" rIns="0" bIns="0" rtlCol="0" anchor="ctr"/>
+          <a:bodyPr wrap="none" lIns="0" tIns="0" rIns="0" bIns="0" rtlCol="0" anchor="ctr"/>
           <a:lstStyle/>
           <a:p>
             <a:pPr algn="l" indent="0" marL="0">
@@ -26189,7 +26189,7 @@
           <a:ln/>
         </p:spPr>
         <p:txBody>
-          <a:bodyPr wrap="square" lIns="0" tIns="0" rIns="0" bIns="0" rtlCol="0" anchor="ctr"/>
+          <a:bodyPr wrap="none" lIns="0" tIns="0" rIns="0" bIns="0" rtlCol="0" anchor="ctr"/>
           <a:lstStyle/>
           <a:p>
             <a:pPr algn="l" indent="0" marL="0">
@@ -26222,7 +26222,7 @@
         <p:spPr>
           <a:xfrm>
             <a:off x="5410200" y="2514526"/>
-            <a:ext cx="2914650" cy="400050"/>
+            <a:ext cx="2971800" cy="400050"/>
           </a:xfrm>
           <a:prstGeom prst="rect">
             <a:avLst/>
@@ -26305,7 +26305,7 @@
         <p:spPr>
           <a:xfrm>
             <a:off x="5200650" y="3333750"/>
-            <a:ext cx="3400425" cy="331440"/>
+            <a:ext cx="3467100" cy="331440"/>
           </a:xfrm>
           <a:prstGeom prst="rect">
             <a:avLst/>
@@ -26379,7 +26379,7 @@
           <a:ln/>
         </p:spPr>
         <p:txBody>
-          <a:bodyPr wrap="square" lIns="0" tIns="0" rIns="0" bIns="0" rtlCol="0" anchor="ctr"/>
+          <a:bodyPr wrap="none" lIns="0" tIns="0" rIns="0" bIns="0" rtlCol="0" anchor="ctr"/>
           <a:lstStyle/>
           <a:p>
             <a:pPr algn="l" indent="0" marL="0">
@@ -26445,7 +26445,7 @@
           <a:ln/>
         </p:spPr>
         <p:txBody>
-          <a:bodyPr wrap="square" lIns="0" tIns="0" rIns="0" bIns="0" rtlCol="0" anchor="ctr"/>
+          <a:bodyPr wrap="none" lIns="0" tIns="0" rIns="0" bIns="0" rtlCol="0" anchor="ctr"/>
           <a:lstStyle/>
           <a:p>
             <a:pPr algn="l" indent="0" marL="0">
@@ -26528,7 +26528,7 @@
           <a:ln/>
         </p:spPr>
         <p:txBody>
-          <a:bodyPr wrap="square" lIns="0" tIns="0" rIns="0" bIns="0" rtlCol="0" anchor="ctr"/>
+          <a:bodyPr wrap="none" lIns="0" tIns="0" rIns="0" bIns="0" rtlCol="0" anchor="ctr"/>
           <a:lstStyle/>
           <a:p>
             <a:pPr algn="l" indent="0" marL="0">
@@ -26587,7 +26587,7 @@
           <a:ln/>
         </p:spPr>
         <p:txBody>
-          <a:bodyPr wrap="square" lIns="0" tIns="0" rIns="0" bIns="0" rtlCol="0" anchor="ctr"/>
+          <a:bodyPr wrap="none" lIns="0" tIns="0" rIns="0" bIns="0" rtlCol="0" anchor="ctr"/>
           <a:lstStyle/>
           <a:p>
             <a:pPr algn="l" indent="0" marL="0">
@@ -26629,7 +26629,7 @@
           <a:ln/>
         </p:spPr>
         <p:txBody>
-          <a:bodyPr wrap="square" lIns="0" tIns="0" rIns="0" bIns="0" rtlCol="0" anchor="ctr"/>
+          <a:bodyPr wrap="none" lIns="0" tIns="0" rIns="0" bIns="0" rtlCol="0" anchor="ctr"/>
           <a:lstStyle/>
           <a:p>
             <a:pPr algn="r" indent="0" marL="0">
@@ -28599,7 +28599,7 @@
           <a:ln/>
         </p:spPr>
         <p:txBody>
-          <a:bodyPr wrap="square" lIns="0" tIns="0" rIns="0" bIns="0" rtlCol="0" anchor="ctr"/>
+          <a:bodyPr wrap="none" lIns="0" tIns="0" rIns="0" bIns="0" rtlCol="0" anchor="ctr"/>
           <a:lstStyle/>
           <a:p>
             <a:pPr algn="l" indent="0" marL="0">
@@ -28641,7 +28641,7 @@
           <a:ln/>
         </p:spPr>
         <p:txBody>
-          <a:bodyPr wrap="square" lIns="0" tIns="0" rIns="0" bIns="0" rtlCol="0" anchor="ctr"/>
+          <a:bodyPr wrap="none" lIns="0" tIns="0" rIns="0" bIns="0" rtlCol="0" anchor="ctr"/>
           <a:lstStyle/>
           <a:p>
             <a:pPr algn="l" indent="0" marL="0">
@@ -28729,7 +28729,7 @@
           <a:ln/>
         </p:spPr>
         <p:txBody>
-          <a:bodyPr wrap="square" lIns="0" tIns="0" rIns="0" bIns="0" rtlCol="0" anchor="ctr"/>
+          <a:bodyPr wrap="none" lIns="0" tIns="0" rIns="0" bIns="0" rtlCol="0" anchor="ctr"/>
           <a:lstStyle/>
           <a:p>
             <a:pPr algn="l" indent="0" marL="0">
@@ -28771,7 +28771,7 @@
           <a:ln/>
         </p:spPr>
         <p:txBody>
-          <a:bodyPr wrap="square" lIns="0" tIns="0" rIns="0" bIns="0" rtlCol="0" anchor="ctr"/>
+          <a:bodyPr wrap="none" lIns="0" tIns="0" rIns="0" bIns="0" rtlCol="0" anchor="ctr"/>
           <a:lstStyle/>
           <a:p>
             <a:pPr algn="l" indent="0" marL="0">
@@ -28859,7 +28859,7 @@
           <a:ln/>
         </p:spPr>
         <p:txBody>
-          <a:bodyPr wrap="square" lIns="0" tIns="0" rIns="0" bIns="0" rtlCol="0" anchor="ctr"/>
+          <a:bodyPr wrap="none" lIns="0" tIns="0" rIns="0" bIns="0" rtlCol="0" anchor="ctr"/>
           <a:lstStyle/>
           <a:p>
             <a:pPr algn="l" indent="0" marL="0">
@@ -28901,7 +28901,7 @@
           <a:ln/>
         </p:spPr>
         <p:txBody>
-          <a:bodyPr wrap="square" lIns="0" tIns="0" rIns="0" bIns="0" rtlCol="0" anchor="ctr"/>
+          <a:bodyPr wrap="none" lIns="0" tIns="0" rIns="0" bIns="0" rtlCol="0" anchor="ctr"/>
           <a:lstStyle/>
           <a:p>
             <a:pPr algn="l" indent="0" marL="0">
@@ -28989,7 +28989,7 @@
           <a:ln/>
         </p:spPr>
         <p:txBody>
-          <a:bodyPr wrap="square" lIns="0" tIns="0" rIns="0" bIns="0" rtlCol="0" anchor="ctr"/>
+          <a:bodyPr wrap="none" lIns="0" tIns="0" rIns="0" bIns="0" rtlCol="0" anchor="ctr"/>
           <a:lstStyle/>
           <a:p>
             <a:pPr algn="l" indent="0" marL="0">
@@ -29031,7 +29031,7 @@
           <a:ln/>
         </p:spPr>
         <p:txBody>
-          <a:bodyPr wrap="square" lIns="0" tIns="0" rIns="0" bIns="0" rtlCol="0" anchor="ctr"/>
+          <a:bodyPr wrap="none" lIns="0" tIns="0" rIns="0" bIns="0" rtlCol="0" anchor="ctr"/>
           <a:lstStyle/>
           <a:p>
             <a:pPr algn="l" indent="0" marL="0">
@@ -29117,7 +29117,7 @@
           <a:ln/>
         </p:spPr>
         <p:txBody>
-          <a:bodyPr wrap="square" lIns="85725" tIns="0" rIns="85725" bIns="0" rtlCol="0" anchor="ctr"/>
+          <a:bodyPr wrap="none" lIns="85725" tIns="0" rIns="85725" bIns="0" rtlCol="0" anchor="ctr"/>
           <a:lstStyle/>
           <a:p>
             <a:pPr algn="ctr" indent="0" marL="0">
@@ -29159,7 +29159,7 @@
           <a:ln/>
         </p:spPr>
         <p:txBody>
-          <a:bodyPr wrap="square" lIns="0" tIns="0" rIns="0" bIns="0" rtlCol="0" anchor="ctr"/>
+          <a:bodyPr wrap="none" lIns="0" tIns="0" rIns="0" bIns="0" rtlCol="0" anchor="ctr"/>
           <a:lstStyle/>
           <a:p>
             <a:pPr algn="l" indent="0" marL="0">
@@ -29192,7 +29192,7 @@
         <p:spPr>
           <a:xfrm>
             <a:off x="800100" y="3691830"/>
-            <a:ext cx="2234565" cy="535781"/>
+            <a:ext cx="2278380" cy="535781"/>
           </a:xfrm>
           <a:prstGeom prst="rect">
             <a:avLst/>
@@ -29289,7 +29289,7 @@
           <a:ln/>
         </p:spPr>
         <p:txBody>
-          <a:bodyPr wrap="square" lIns="95250" tIns="0" rIns="95250" bIns="0" rtlCol="0" anchor="ctr"/>
+          <a:bodyPr wrap="none" lIns="95250" tIns="0" rIns="95250" bIns="0" rtlCol="0" anchor="ctr"/>
           <a:lstStyle/>
           <a:p>
             <a:pPr algn="ctr" indent="0" marL="0">
@@ -29331,7 +29331,7 @@
           <a:ln/>
         </p:spPr>
         <p:txBody>
-          <a:bodyPr wrap="square" lIns="0" tIns="0" rIns="0" bIns="0" rtlCol="0" anchor="ctr"/>
+          <a:bodyPr wrap="none" lIns="0" tIns="0" rIns="0" bIns="0" rtlCol="0" anchor="ctr"/>
           <a:lstStyle/>
           <a:p>
             <a:pPr algn="l" indent="0" marL="0">
@@ -29397,7 +29397,7 @@
           <a:ln/>
         </p:spPr>
         <p:txBody>
-          <a:bodyPr wrap="square" lIns="0" tIns="0" rIns="0" bIns="0" rtlCol="0" anchor="ctr"/>
+          <a:bodyPr wrap="none" lIns="0" tIns="0" rIns="0" bIns="0" rtlCol="0" anchor="ctr"/>
           <a:lstStyle/>
           <a:p>
             <a:pPr algn="l" indent="0" marL="0">
@@ -29495,7 +29495,7 @@
           <a:ln/>
         </p:spPr>
         <p:txBody>
-          <a:bodyPr wrap="square" lIns="0" tIns="0" rIns="0" bIns="0" rtlCol="0" anchor="ctr"/>
+          <a:bodyPr wrap="none" lIns="0" tIns="0" rIns="0" bIns="0" rtlCol="0" anchor="ctr"/>
           <a:lstStyle/>
           <a:p>
             <a:pPr algn="l" indent="0" marL="0">
@@ -29593,7 +29593,7 @@
           <a:ln/>
         </p:spPr>
         <p:txBody>
-          <a:bodyPr wrap="square" lIns="0" tIns="0" rIns="0" bIns="0" rtlCol="0" anchor="ctr"/>
+          <a:bodyPr wrap="none" lIns="0" tIns="0" rIns="0" bIns="0" rtlCol="0" anchor="ctr"/>
           <a:lstStyle/>
           <a:p>
             <a:pPr algn="l" indent="0" marL="0">
@@ -29673,7 +29673,7 @@
         <p:spPr>
           <a:xfrm>
             <a:off x="5067300" y="3414713"/>
-            <a:ext cx="3536442" cy="345281"/>
+            <a:ext cx="3605784" cy="345281"/>
           </a:xfrm>
           <a:prstGeom prst="rect">
             <a:avLst/>
@@ -29756,7 +29756,7 @@
         <p:spPr>
           <a:xfrm>
             <a:off x="5067300" y="3845719"/>
-            <a:ext cx="3536442" cy="345281"/>
+            <a:ext cx="3605784" cy="345281"/>
           </a:xfrm>
           <a:prstGeom prst="rect">
             <a:avLst/>
@@ -29807,7 +29807,7 @@
           <a:ln/>
         </p:spPr>
         <p:txBody>
-          <a:bodyPr wrap="square" lIns="0" tIns="0" rIns="0" bIns="0" rtlCol="0" anchor="ctr"/>
+          <a:bodyPr wrap="none" lIns="0" tIns="0" rIns="0" bIns="0" rtlCol="0" anchor="ctr"/>
           <a:lstStyle/>
           <a:p>
             <a:pPr algn="l" indent="0" marL="0">
@@ -29849,7 +29849,7 @@
           <a:ln/>
         </p:spPr>
         <p:txBody>
-          <a:bodyPr wrap="square" lIns="0" tIns="0" rIns="0" bIns="0" rtlCol="0" anchor="ctr"/>
+          <a:bodyPr wrap="none" lIns="0" tIns="0" rIns="0" bIns="0" rtlCol="0" anchor="ctr"/>
           <a:lstStyle/>
           <a:p>
             <a:pPr algn="r" indent="0" marL="0">

</xml_diff>

<commit_message>
Pair hand-off chips by identical names and put Morph on the entering slide
Co-Authored-By: Claude Fable 5.1 <noreply@anthropic.com>
Claude-Session: https://claude.ai/code/session_01MJB3WpVo3kuH25GjttwApw
</commit_message>
<xml_diff>
--- a/presentation/AI_Work_Performance_ENG501.pptx
+++ b/presentation/AI_Work_Performance_ENG501.pptx
@@ -116,7 +116,7 @@
   <p:extLst>
     <p:ext uri="{521415D9-36F7-43E2-AB2F-B90AF26B5E84}">
       <p14:sectionLst xmlns:p14="http://schemas.microsoft.com/office/powerpoint/2010/main">
-        <p14:section name="English version: two field experiments on AI, productivity and business performance." id="{a4191d4c-2f5c-4ce6-f622-e5471820d11e}">
+        <p14:section name="English version: two field experiments on AI, productivity and business performance." id="{fd813ca2-37fc-a93e-61f2-48f9a7e71516}">
           <p14:sldIdLst>
             <p14:sldId id="256"/>
             <p14:sldId id="257"/>
@@ -130,7 +130,7 @@
             <p14:sldId id="265"/>
           </p14:sldIdLst>
         </p14:section>
-        <p14:section name="ฉบับภาษาไทย: การทดลองภาคสนามสองชิ้นเรื่อง AI ผลิตภาพ และผลการดำเนินธุรกิจ" id="{b2802288-ed4d-3b8f-cbc6-2dd6fae267ab}">
+        <p14:section name="ฉบับภาษาไทย: การทดลองภาคสนามสองชิ้นเรื่อง AI ผลิตภาพ และผลการดำเนินธุรกิจ" id="{0406d872-9cf5-6b59-1f66-d409e1cc735e}">
           <p14:sldIdLst/>
         </p14:section>
       </p14:sectionLst>
@@ -2275,7 +2275,7 @@
       </p:sp>
       <p:sp>
         <p:nvSpPr>
-          <p:cNvPr id="17" name="!!key1-en-16 b4:pop"/>
+          <p:cNvPr id="17" name="!!key1-en-1"/>
           <p:cNvSpPr/>
           <p:nvPr/>
         </p:nvSpPr>
@@ -2297,7 +2297,7 @@
       </p:sp>
       <p:sp>
         <p:nvSpPr>
-          <p:cNvPr id="18" name="!!key1-en-17 b4:pop"/>
+          <p:cNvPr id="18" name="!!key1-en-2"/>
           <p:cNvSpPr txBox="1"/>
           <p:nvPr/>
         </p:nvSpPr>
@@ -2342,18 +2342,9 @@
   <p:clrMapOvr>
     <a:masterClrMapping/>
   </p:clrMapOvr>
-  <mc:AlternateContent xmlns:mc="http://schemas.openxmlformats.org/markup-compatibility/2006">
-    <mc:Choice xmlns:p159="http://schemas.microsoft.com/office/powerpoint/2015/09/main" Requires="p159">
-      <p:transition xmlns:p14="http://schemas.microsoft.com/office/powerpoint/2010/main" spd="slow" p14:dur="800">
-        <p159:morph option="byObject"/>
-      </p:transition>
-    </mc:Choice>
-    <mc:Fallback>
-      <p:transition spd="med">
-        <p:fade/>
-      </p:transition>
-    </mc:Fallback>
-  </mc:AlternateContent>
+  <p:transition spd="med">
+    <p:fade/>
+  </p:transition>
   <p:timing>
     <p:tnLst>
       <p:par>
@@ -4530,7 +4521,7 @@
       </p:sp>
       <p:sp>
         <p:nvSpPr>
-          <p:cNvPr id="44" name="!!key4-th-43 static"/>
+          <p:cNvPr id="44" name="!!key4-th-1"/>
           <p:cNvSpPr/>
           <p:nvPr/>
         </p:nvSpPr>
@@ -4552,7 +4543,7 @@
       </p:sp>
       <p:sp>
         <p:nvSpPr>
-          <p:cNvPr id="45" name="!!key4-th-44 static"/>
+          <p:cNvPr id="45" name="!!key4-th-2"/>
           <p:cNvSpPr txBox="1"/>
           <p:nvPr/>
         </p:nvSpPr>
@@ -4597,9 +4588,18 @@
   <p:clrMapOvr>
     <a:masterClrMapping/>
   </p:clrMapOvr>
-  <p:transition spd="med">
-    <p:fade/>
-  </p:transition>
+  <mc:AlternateContent xmlns:mc="http://schemas.openxmlformats.org/markup-compatibility/2006">
+    <mc:Choice xmlns:p159="http://schemas.microsoft.com/office/powerpoint/2015/09/main" Requires="p159">
+      <p:transition xmlns:p14="http://schemas.microsoft.com/office/powerpoint/2010/main" spd="slow" p14:dur="800">
+        <p159:morph option="byObject"/>
+      </p:transition>
+    </mc:Choice>
+    <mc:Fallback>
+      <p:transition spd="med">
+        <p:fade/>
+      </p:transition>
+    </mc:Fallback>
+  </mc:AlternateContent>
   <p:timing>
     <p:tnLst>
       <p:par>
@@ -8092,7 +8092,7 @@
       </p:sp>
       <p:sp>
         <p:nvSpPr>
-          <p:cNvPr id="35" name="!!key1-en-34 static"/>
+          <p:cNvPr id="35" name="!!key1-en-1"/>
           <p:cNvSpPr/>
           <p:nvPr/>
         </p:nvSpPr>
@@ -8114,7 +8114,7 @@
       </p:sp>
       <p:sp>
         <p:nvSpPr>
-          <p:cNvPr id="36" name="!!key1-en-35 static"/>
+          <p:cNvPr id="36" name="!!key1-en-2"/>
           <p:cNvSpPr txBox="1"/>
           <p:nvPr/>
         </p:nvSpPr>
@@ -8156,7 +8156,7 @@
       </p:sp>
       <p:sp>
         <p:nvSpPr>
-          <p:cNvPr id="37" name="!!key2-en-36 b6:pop"/>
+          <p:cNvPr id="37" name="!!key2-en-1"/>
           <p:cNvSpPr/>
           <p:nvPr/>
         </p:nvSpPr>
@@ -8178,7 +8178,7 @@
       </p:sp>
       <p:sp>
         <p:nvSpPr>
-          <p:cNvPr id="38" name="!!key2-en-37 b6:pop"/>
+          <p:cNvPr id="38" name="!!key2-en-2"/>
           <p:cNvSpPr txBox="1"/>
           <p:nvPr/>
         </p:nvSpPr>
@@ -11559,7 +11559,7 @@
       </p:sp>
       <p:sp>
         <p:nvSpPr>
-          <p:cNvPr id="38" name="!!key2-en-37 static"/>
+          <p:cNvPr id="38" name="!!key2-en-1"/>
           <p:cNvSpPr/>
           <p:nvPr/>
         </p:nvSpPr>
@@ -11581,7 +11581,7 @@
       </p:sp>
       <p:sp>
         <p:nvSpPr>
-          <p:cNvPr id="39" name="!!key2-en-38 static"/>
+          <p:cNvPr id="39" name="!!key2-en-2"/>
           <p:cNvSpPr txBox="1"/>
           <p:nvPr/>
         </p:nvSpPr>
@@ -11623,7 +11623,7 @@
       </p:sp>
       <p:sp>
         <p:nvSpPr>
-          <p:cNvPr id="40" name="!!key3-en-39 b11:pop"/>
+          <p:cNvPr id="40" name="!!key3-en-1"/>
           <p:cNvSpPr/>
           <p:nvPr/>
         </p:nvSpPr>
@@ -11645,7 +11645,7 @@
       </p:sp>
       <p:sp>
         <p:nvSpPr>
-          <p:cNvPr id="41" name="!!key3-en-40 b11:pop"/>
+          <p:cNvPr id="41" name="!!key3-en-2"/>
           <p:cNvSpPr txBox="1"/>
           <p:nvPr/>
         </p:nvSpPr>
@@ -14796,7 +14796,7 @@
       </p:sp>
       <p:sp>
         <p:nvSpPr>
-          <p:cNvPr id="38" name="!!key3-en-37 static"/>
+          <p:cNvPr id="38" name="!!key3-en-1"/>
           <p:cNvSpPr/>
           <p:nvPr/>
         </p:nvSpPr>
@@ -14818,7 +14818,7 @@
       </p:sp>
       <p:sp>
         <p:nvSpPr>
-          <p:cNvPr id="39" name="!!key3-en-38 static"/>
+          <p:cNvPr id="39" name="!!key3-en-2"/>
           <p:cNvSpPr txBox="1"/>
           <p:nvPr/>
         </p:nvSpPr>
@@ -14860,7 +14860,7 @@
       </p:sp>
       <p:sp>
         <p:nvSpPr>
-          <p:cNvPr id="40" name="!!key4-en-39 b8:pop"/>
+          <p:cNvPr id="40" name="!!key4-en-1"/>
           <p:cNvSpPr/>
           <p:nvPr/>
         </p:nvSpPr>
@@ -14882,7 +14882,7 @@
       </p:sp>
       <p:sp>
         <p:nvSpPr>
-          <p:cNvPr id="41" name="!!key4-en-40 b8:pop"/>
+          <p:cNvPr id="41" name="!!key4-en-2"/>
           <p:cNvSpPr txBox="1"/>
           <p:nvPr/>
         </p:nvSpPr>
@@ -18283,7 +18283,7 @@
       </p:sp>
       <p:sp>
         <p:nvSpPr>
-          <p:cNvPr id="44" name="!!key4-en-43 static"/>
+          <p:cNvPr id="44" name="!!key4-en-1"/>
           <p:cNvSpPr/>
           <p:nvPr/>
         </p:nvSpPr>
@@ -18305,7 +18305,7 @@
       </p:sp>
       <p:sp>
         <p:nvSpPr>
-          <p:cNvPr id="45" name="!!key4-en-44 static"/>
+          <p:cNvPr id="45" name="!!key4-en-2"/>
           <p:cNvSpPr txBox="1"/>
           <p:nvPr/>
         </p:nvSpPr>
@@ -18350,9 +18350,18 @@
   <p:clrMapOvr>
     <a:masterClrMapping/>
   </p:clrMapOvr>
-  <p:transition spd="med">
-    <p:fade/>
-  </p:transition>
+  <mc:AlternateContent xmlns:mc="http://schemas.openxmlformats.org/markup-compatibility/2006">
+    <mc:Choice xmlns:p159="http://schemas.microsoft.com/office/powerpoint/2015/09/main" Requires="p159">
+      <p:transition xmlns:p14="http://schemas.microsoft.com/office/powerpoint/2010/main" spd="slow" p14:dur="800">
+        <p159:morph option="byObject"/>
+      </p:transition>
+    </mc:Choice>
+    <mc:Fallback>
+      <p:transition spd="med">
+        <p:fade/>
+      </p:transition>
+    </mc:Fallback>
+  </mc:AlternateContent>
   <p:timing>
     <p:tnLst>
       <p:par>
@@ -21156,7 +21165,7 @@
       </p:sp>
       <p:sp>
         <p:nvSpPr>
-          <p:cNvPr id="17" name="!!key1-th-16 b4:pop"/>
+          <p:cNvPr id="17" name="!!key1-th-1"/>
           <p:cNvSpPr/>
           <p:nvPr/>
         </p:nvSpPr>
@@ -21178,7 +21187,7 @@
       </p:sp>
       <p:sp>
         <p:nvSpPr>
-          <p:cNvPr id="18" name="!!key1-th-17 b4:pop"/>
+          <p:cNvPr id="18" name="!!key1-th-2"/>
           <p:cNvSpPr txBox="1"/>
           <p:nvPr/>
         </p:nvSpPr>
@@ -21223,18 +21232,9 @@
   <p:clrMapOvr>
     <a:masterClrMapping/>
   </p:clrMapOvr>
-  <mc:AlternateContent xmlns:mc="http://schemas.openxmlformats.org/markup-compatibility/2006">
-    <mc:Choice xmlns:p159="http://schemas.microsoft.com/office/powerpoint/2015/09/main" Requires="p159">
-      <p:transition xmlns:p14="http://schemas.microsoft.com/office/powerpoint/2010/main" spd="slow" p14:dur="800">
-        <p159:morph option="byObject"/>
-      </p:transition>
-    </mc:Choice>
-    <mc:Fallback>
-      <p:transition spd="med">
-        <p:fade/>
-      </p:transition>
-    </mc:Fallback>
-  </mc:AlternateContent>
+  <p:transition spd="med">
+    <p:fade/>
+  </p:transition>
   <p:timing>
     <p:tnLst>
       <p:par>
@@ -23256,7 +23256,7 @@
       </p:sp>
       <p:sp>
         <p:nvSpPr>
-          <p:cNvPr id="35" name="!!key1-th-34 static"/>
+          <p:cNvPr id="35" name="!!key1-th-1"/>
           <p:cNvSpPr/>
           <p:nvPr/>
         </p:nvSpPr>
@@ -23278,7 +23278,7 @@
       </p:sp>
       <p:sp>
         <p:nvSpPr>
-          <p:cNvPr id="36" name="!!key1-th-35 static"/>
+          <p:cNvPr id="36" name="!!key1-th-2"/>
           <p:cNvSpPr txBox="1"/>
           <p:nvPr/>
         </p:nvSpPr>
@@ -23320,7 +23320,7 @@
       </p:sp>
       <p:sp>
         <p:nvSpPr>
-          <p:cNvPr id="37" name="!!key2-th-36 b6:pop"/>
+          <p:cNvPr id="37" name="!!key2-th-1"/>
           <p:cNvSpPr/>
           <p:nvPr/>
         </p:nvSpPr>
@@ -23342,7 +23342,7 @@
       </p:sp>
       <p:sp>
         <p:nvSpPr>
-          <p:cNvPr id="38" name="!!key2-th-37 b6:pop"/>
+          <p:cNvPr id="38" name="!!key2-th-2"/>
           <p:cNvSpPr txBox="1"/>
           <p:nvPr/>
         </p:nvSpPr>
@@ -26706,7 +26706,7 @@
       </p:sp>
       <p:sp>
         <p:nvSpPr>
-          <p:cNvPr id="38" name="!!key2-th-37 static"/>
+          <p:cNvPr id="38" name="!!key2-th-1"/>
           <p:cNvSpPr/>
           <p:nvPr/>
         </p:nvSpPr>
@@ -26728,7 +26728,7 @@
       </p:sp>
       <p:sp>
         <p:nvSpPr>
-          <p:cNvPr id="39" name="!!key2-th-38 static"/>
+          <p:cNvPr id="39" name="!!key2-th-2"/>
           <p:cNvSpPr txBox="1"/>
           <p:nvPr/>
         </p:nvSpPr>
@@ -26770,7 +26770,7 @@
       </p:sp>
       <p:sp>
         <p:nvSpPr>
-          <p:cNvPr id="40" name="!!key3-th-39 b11:pop"/>
+          <p:cNvPr id="40" name="!!key3-th-1"/>
           <p:cNvSpPr/>
           <p:nvPr/>
         </p:nvSpPr>
@@ -26792,7 +26792,7 @@
       </p:sp>
       <p:sp>
         <p:nvSpPr>
-          <p:cNvPr id="41" name="!!key3-th-40 b11:pop"/>
+          <p:cNvPr id="41" name="!!key3-th-2"/>
           <p:cNvSpPr txBox="1"/>
           <p:nvPr/>
         </p:nvSpPr>
@@ -29926,7 +29926,7 @@
       </p:sp>
       <p:sp>
         <p:nvSpPr>
-          <p:cNvPr id="38" name="!!key3-th-37 static"/>
+          <p:cNvPr id="38" name="!!key3-th-1"/>
           <p:cNvSpPr/>
           <p:nvPr/>
         </p:nvSpPr>
@@ -29948,7 +29948,7 @@
       </p:sp>
       <p:sp>
         <p:nvSpPr>
-          <p:cNvPr id="39" name="!!key3-th-38 static"/>
+          <p:cNvPr id="39" name="!!key3-th-2"/>
           <p:cNvSpPr txBox="1"/>
           <p:nvPr/>
         </p:nvSpPr>
@@ -29990,7 +29990,7 @@
       </p:sp>
       <p:sp>
         <p:nvSpPr>
-          <p:cNvPr id="40" name="!!key4-th-39 b8:pop"/>
+          <p:cNvPr id="40" name="!!key4-th-1"/>
           <p:cNvSpPr/>
           <p:nvPr/>
         </p:nvSpPr>
@@ -30012,7 +30012,7 @@
       </p:sp>
       <p:sp>
         <p:nvSpPr>
-          <p:cNvPr id="41" name="!!key4-th-40 b8:pop"/>
+          <p:cNvPr id="41" name="!!key4-th-2"/>
           <p:cNvSpPr txBox="1"/>
           <p:nvPr/>
         </p:nvSpPr>

</xml_diff>

<commit_message>
Draw the frontier diagram at its slide box's aspect ratio so it is never stretched
Co-Authored-By: Claude Fable 5.1 <noreply@anthropic.com>
Claude-Session: https://claude.ai/code/session_01MJB3WpVo3kuH25GjttwApw
</commit_message>
<xml_diff>
--- a/presentation/AI_Work_Performance_ENG501.pptx
+++ b/presentation/AI_Work_Performance_ENG501.pptx
@@ -116,7 +116,7 @@
   <p:extLst>
     <p:ext uri="{521415D9-36F7-43E2-AB2F-B90AF26B5E84}">
       <p14:sectionLst xmlns:p14="http://schemas.microsoft.com/office/powerpoint/2010/main">
-        <p14:section name="English version: two field experiments on AI, productivity and business performance." id="{fd813ca2-37fc-a93e-61f2-48f9a7e71516}">
+        <p14:section name="English version: two field experiments on AI, productivity and business performance." id="{e32aae4a-0e1a-c2f2-3e8d-3ef0946ef2e5}">
           <p14:sldIdLst>
             <p14:sldId id="256"/>
             <p14:sldId id="257"/>
@@ -130,7 +130,7 @@
             <p14:sldId id="265"/>
           </p14:sldIdLst>
         </p14:section>
-        <p14:section name="ฉบับภาษาไทย: การทดลองภาคสนามสองชิ้นเรื่อง AI ผลิตภาพ และผลการดำเนินธุรกิจ" id="{0406d872-9cf5-6b59-1f66-d409e1cc735e}">
+        <p14:section name="ฉบับภาษาไทย: การทดลองภาคสนามสองชิ้นเรื่อง AI ผลิตภาพ และผลการดำเนินธุรกิจ" id="{348442ed-0f6e-a732-abd3-243bd4698d0c}">
           <p14:sldIdLst/>
         </p14:section>
       </p14:sectionLst>
@@ -7825,7 +7825,7 @@
       </p:sp>
       <p:pic>
         <p:nvPicPr>
-          <p:cNvPr id="29" name="b4:rise (Jagged line dividing tasks AI does well from tasks it does not)" descr="/home/user/slide-present-en/presentation/webdeck/art/frontier.png">    </p:cNvPr>
+          <p:cNvPr id="29" name="b4:rise (Jagged line dividing tasks AI does well from tasks it does not)" descr="/home/user/slide-present-en/presentation/webdeck/art/frontier-wide.png">    </p:cNvPr>
           <p:cNvPicPr>
             <a:picLocks noChangeAspect="1"/>
           </p:cNvPicPr>
@@ -22989,7 +22989,7 @@
       </p:sp>
       <p:pic>
         <p:nvPicPr>
-          <p:cNvPr id="29" name="b4:rise (เส้นหยักแบ่งงานที่ AI ทำได้ดีกับงานที่ทำได้ไม่ดี)" descr="/home/user/slide-present-en/presentation/webdeck/art/frontier.png">    </p:cNvPr>
+          <p:cNvPr id="29" name="b4:rise (เส้นหยักแบ่งงานที่ AI ทำได้ดีกับงานที่ทำได้ไม่ดี)" descr="/home/user/slide-present-en/presentation/webdeck/art/frontier-wide.png">    </p:cNvPr>
           <p:cNvPicPr>
             <a:picLocks noChangeAspect="1"/>
           </p:cNvPicPr>

</xml_diff>